<commit_message>
Generating networks and their symbolic matrices
</commit_message>
<xml_diff>
--- a/docs/figures.pptx
+++ b/docs/figures.pptx
@@ -7,10 +7,12 @@
   <p:sldIdLst>
     <p:sldId id="256" r:id="rId2"/>
     <p:sldId id="259" r:id="rId3"/>
-    <p:sldId id="258" r:id="rId4"/>
-    <p:sldId id="261" r:id="rId5"/>
-    <p:sldId id="260" r:id="rId6"/>
-    <p:sldId id="257" r:id="rId7"/>
+    <p:sldId id="263" r:id="rId4"/>
+    <p:sldId id="262" r:id="rId5"/>
+    <p:sldId id="258" r:id="rId6"/>
+    <p:sldId id="261" r:id="rId7"/>
+    <p:sldId id="260" r:id="rId8"/>
+    <p:sldId id="257" r:id="rId9"/>
   </p:sldIdLst>
   <p:sldSz cx="12192000" cy="6858000"/>
   <p:notesSz cx="6858000" cy="9144000"/>
@@ -109,6 +111,11 @@
       </a:defRPr>
     </a:lvl9pPr>
   </p:defaultTextStyle>
+  <p:extLst>
+    <p:ext uri="{EFAFB233-063F-42B5-8137-9DF3F51BA10A}">
+      <p15:sldGuideLst xmlns:p15="http://schemas.microsoft.com/office/powerpoint/2012/main"/>
+    </p:ext>
+  </p:extLst>
 </p:presentation>
 </file>
 
@@ -259,7 +266,7 @@
           <a:p>
             <a:fld id="{7D87BF0F-22D5-0B4D-84CF-17DF525CE877}" type="datetimeFigureOut">
               <a:rPr lang="en-US" smtClean="0"/>
-              <a:t>1/2/24</a:t>
+              <a:t>11/14/25</a:t>
             </a:fld>
             <a:endParaRPr lang="en-US"/>
           </a:p>
@@ -457,7 +464,7 @@
           <a:p>
             <a:fld id="{7D87BF0F-22D5-0B4D-84CF-17DF525CE877}" type="datetimeFigureOut">
               <a:rPr lang="en-US" smtClean="0"/>
-              <a:t>1/2/24</a:t>
+              <a:t>11/14/25</a:t>
             </a:fld>
             <a:endParaRPr lang="en-US"/>
           </a:p>
@@ -665,7 +672,7 @@
           <a:p>
             <a:fld id="{7D87BF0F-22D5-0B4D-84CF-17DF525CE877}" type="datetimeFigureOut">
               <a:rPr lang="en-US" smtClean="0"/>
-              <a:t>1/2/24</a:t>
+              <a:t>11/14/25</a:t>
             </a:fld>
             <a:endParaRPr lang="en-US"/>
           </a:p>
@@ -863,7 +870,7 @@
           <a:p>
             <a:fld id="{7D87BF0F-22D5-0B4D-84CF-17DF525CE877}" type="datetimeFigureOut">
               <a:rPr lang="en-US" smtClean="0"/>
-              <a:t>1/2/24</a:t>
+              <a:t>11/14/25</a:t>
             </a:fld>
             <a:endParaRPr lang="en-US"/>
           </a:p>
@@ -1138,7 +1145,7 @@
           <a:p>
             <a:fld id="{7D87BF0F-22D5-0B4D-84CF-17DF525CE877}" type="datetimeFigureOut">
               <a:rPr lang="en-US" smtClean="0"/>
-              <a:t>1/2/24</a:t>
+              <a:t>11/14/25</a:t>
             </a:fld>
             <a:endParaRPr lang="en-US"/>
           </a:p>
@@ -1403,7 +1410,7 @@
           <a:p>
             <a:fld id="{7D87BF0F-22D5-0B4D-84CF-17DF525CE877}" type="datetimeFigureOut">
               <a:rPr lang="en-US" smtClean="0"/>
-              <a:t>1/2/24</a:t>
+              <a:t>11/14/25</a:t>
             </a:fld>
             <a:endParaRPr lang="en-US"/>
           </a:p>
@@ -1815,7 +1822,7 @@
           <a:p>
             <a:fld id="{7D87BF0F-22D5-0B4D-84CF-17DF525CE877}" type="datetimeFigureOut">
               <a:rPr lang="en-US" smtClean="0"/>
-              <a:t>1/2/24</a:t>
+              <a:t>11/14/25</a:t>
             </a:fld>
             <a:endParaRPr lang="en-US"/>
           </a:p>
@@ -1956,7 +1963,7 @@
           <a:p>
             <a:fld id="{7D87BF0F-22D5-0B4D-84CF-17DF525CE877}" type="datetimeFigureOut">
               <a:rPr lang="en-US" smtClean="0"/>
-              <a:t>1/2/24</a:t>
+              <a:t>11/14/25</a:t>
             </a:fld>
             <a:endParaRPr lang="en-US"/>
           </a:p>
@@ -2069,7 +2076,7 @@
           <a:p>
             <a:fld id="{7D87BF0F-22D5-0B4D-84CF-17DF525CE877}" type="datetimeFigureOut">
               <a:rPr lang="en-US" smtClean="0"/>
-              <a:t>1/2/24</a:t>
+              <a:t>11/14/25</a:t>
             </a:fld>
             <a:endParaRPr lang="en-US"/>
           </a:p>
@@ -2380,7 +2387,7 @@
           <a:p>
             <a:fld id="{7D87BF0F-22D5-0B4D-84CF-17DF525CE877}" type="datetimeFigureOut">
               <a:rPr lang="en-US" smtClean="0"/>
-              <a:t>1/2/24</a:t>
+              <a:t>11/14/25</a:t>
             </a:fld>
             <a:endParaRPr lang="en-US"/>
           </a:p>
@@ -2668,7 +2675,7 @@
           <a:p>
             <a:fld id="{7D87BF0F-22D5-0B4D-84CF-17DF525CE877}" type="datetimeFigureOut">
               <a:rPr lang="en-US" smtClean="0"/>
-              <a:t>1/2/24</a:t>
+              <a:t>11/14/25</a:t>
             </a:fld>
             <a:endParaRPr lang="en-US"/>
           </a:p>
@@ -2909,7 +2916,7 @@
           <a:p>
             <a:fld id="{7D87BF0F-22D5-0B4D-84CF-17DF525CE877}" type="datetimeFigureOut">
               <a:rPr lang="en-US" smtClean="0"/>
-              <a:t>1/2/24</a:t>
+              <a:t>11/14/25</a:t>
             </a:fld>
             <a:endParaRPr lang="en-US"/>
           </a:p>
@@ -3501,8 +3508,8 @@
           </a:fontRef>
         </p:style>
       </p:cxnSp>
-      <mc:AlternateContent xmlns:mc="http://schemas.openxmlformats.org/markup-compatibility/2006">
-        <mc:Choice xmlns:a14="http://schemas.microsoft.com/office/drawing/2010/main" Requires="a14">
+      <mc:AlternateContent xmlns:mc="http://schemas.openxmlformats.org/markup-compatibility/2006" xmlns:a14="http://schemas.microsoft.com/office/drawing/2010/main">
+        <mc:Choice Requires="a14">
           <p:sp>
             <p:nvSpPr>
               <p:cNvPr id="37" name="TextBox 36">
@@ -3531,6 +3538,7 @@
               </a:bodyPr>
               <a:lstStyle/>
               <a:p>
+                <a:pPr/>
                 <a14:m>
                   <m:oMathPara xmlns:m="http://schemas.openxmlformats.org/officeDocument/2006/math">
                     <m:oMathParaPr>
@@ -3578,7 +3586,7 @@
             </p:txBody>
           </p:sp>
         </mc:Choice>
-        <mc:Fallback>
+        <mc:Fallback xmlns="">
           <p:sp>
             <p:nvSpPr>
               <p:cNvPr id="37" name="TextBox 36">
@@ -3623,8 +3631,8 @@
           </p:sp>
         </mc:Fallback>
       </mc:AlternateContent>
-      <mc:AlternateContent xmlns:mc="http://schemas.openxmlformats.org/markup-compatibility/2006">
-        <mc:Choice xmlns:a14="http://schemas.microsoft.com/office/drawing/2010/main" Requires="a14">
+      <mc:AlternateContent xmlns:mc="http://schemas.openxmlformats.org/markup-compatibility/2006" xmlns:a14="http://schemas.microsoft.com/office/drawing/2010/main">
+        <mc:Choice Requires="a14">
           <p:sp>
             <p:nvSpPr>
               <p:cNvPr id="40" name="TextBox 39">
@@ -3653,6 +3661,7 @@
               </a:bodyPr>
               <a:lstStyle/>
               <a:p>
+                <a:pPr/>
                 <a14:m>
                   <m:oMathPara xmlns:m="http://schemas.openxmlformats.org/officeDocument/2006/math">
                     <m:oMathParaPr>
@@ -3692,7 +3701,7 @@
             </p:txBody>
           </p:sp>
         </mc:Choice>
-        <mc:Fallback>
+        <mc:Fallback xmlns="">
           <p:sp>
             <p:nvSpPr>
               <p:cNvPr id="40" name="TextBox 39">
@@ -3803,8 +3812,8 @@
             </a:p>
           </p:txBody>
         </p:sp>
-        <mc:AlternateContent xmlns:mc="http://schemas.openxmlformats.org/markup-compatibility/2006">
-          <mc:Choice xmlns:a14="http://schemas.microsoft.com/office/drawing/2010/main" Requires="a14">
+        <mc:AlternateContent xmlns:mc="http://schemas.openxmlformats.org/markup-compatibility/2006" xmlns:a14="http://schemas.microsoft.com/office/drawing/2010/main">
+          <mc:Choice Requires="a14">
             <p:sp>
               <p:nvSpPr>
                 <p:cNvPr id="33" name="TextBox 32">
@@ -3833,6 +3842,7 @@
                 </a:bodyPr>
                 <a:lstStyle/>
                 <a:p>
+                  <a:pPr/>
                   <a14:m>
                     <m:oMathPara xmlns:m="http://schemas.openxmlformats.org/officeDocument/2006/math">
                       <m:oMathParaPr>
@@ -3896,7 +3906,7 @@
               </p:txBody>
             </p:sp>
           </mc:Choice>
-          <mc:Fallback>
+          <mc:Fallback xmlns="">
             <p:sp>
               <p:nvSpPr>
                 <p:cNvPr id="33" name="TextBox 32">
@@ -3941,8 +3951,8 @@
             </p:sp>
           </mc:Fallback>
         </mc:AlternateContent>
-        <mc:AlternateContent xmlns:mc="http://schemas.openxmlformats.org/markup-compatibility/2006">
-          <mc:Choice xmlns:a14="http://schemas.microsoft.com/office/drawing/2010/main" Requires="a14">
+        <mc:AlternateContent xmlns:mc="http://schemas.openxmlformats.org/markup-compatibility/2006" xmlns:a14="http://schemas.microsoft.com/office/drawing/2010/main">
+          <mc:Choice Requires="a14">
             <p:sp>
               <p:nvSpPr>
                 <p:cNvPr id="35" name="TextBox 34">
@@ -3971,6 +3981,7 @@
                 </a:bodyPr>
                 <a:lstStyle/>
                 <a:p>
+                  <a:pPr/>
                   <a14:m>
                     <m:oMathPara xmlns:m="http://schemas.openxmlformats.org/officeDocument/2006/math">
                       <m:oMathParaPr>
@@ -4034,7 +4045,7 @@
               </p:txBody>
             </p:sp>
           </mc:Choice>
-          <mc:Fallback>
+          <mc:Fallback xmlns="">
             <p:sp>
               <p:nvSpPr>
                 <p:cNvPr id="35" name="TextBox 34">
@@ -4079,8 +4090,8 @@
             </p:sp>
           </mc:Fallback>
         </mc:AlternateContent>
-        <mc:AlternateContent xmlns:mc="http://schemas.openxmlformats.org/markup-compatibility/2006">
-          <mc:Choice xmlns:a14="http://schemas.microsoft.com/office/drawing/2010/main" Requires="a14">
+        <mc:AlternateContent xmlns:mc="http://schemas.openxmlformats.org/markup-compatibility/2006" xmlns:a14="http://schemas.microsoft.com/office/drawing/2010/main">
+          <mc:Choice Requires="a14">
             <p:sp>
               <p:nvSpPr>
                 <p:cNvPr id="54" name="TextBox 53">
@@ -4109,6 +4120,7 @@
                 </a:bodyPr>
                 <a:lstStyle/>
                 <a:p>
+                  <a:pPr/>
                   <a14:m>
                     <m:oMathPara xmlns:m="http://schemas.openxmlformats.org/officeDocument/2006/math">
                       <m:oMathParaPr>
@@ -4172,7 +4184,7 @@
               </p:txBody>
             </p:sp>
           </mc:Choice>
-          <mc:Fallback>
+          <mc:Fallback xmlns="">
             <p:sp>
               <p:nvSpPr>
                 <p:cNvPr id="54" name="TextBox 53">
@@ -4218,8 +4230,8 @@
           </mc:Fallback>
         </mc:AlternateContent>
       </p:grpSp>
-      <mc:AlternateContent xmlns:mc="http://schemas.openxmlformats.org/markup-compatibility/2006">
-        <mc:Choice xmlns:a14="http://schemas.microsoft.com/office/drawing/2010/main" Requires="a14">
+      <mc:AlternateContent xmlns:mc="http://schemas.openxmlformats.org/markup-compatibility/2006" xmlns:a14="http://schemas.microsoft.com/office/drawing/2010/main">
+        <mc:Choice Requires="a14">
           <p:sp>
             <p:nvSpPr>
               <p:cNvPr id="56" name="TextBox 55">
@@ -4248,6 +4260,7 @@
               </a:bodyPr>
               <a:lstStyle/>
               <a:p>
+                <a:pPr/>
                 <a14:m>
                   <m:oMathPara xmlns:m="http://schemas.openxmlformats.org/officeDocument/2006/math">
                     <m:oMathParaPr>
@@ -4295,7 +4308,7 @@
             </p:txBody>
           </p:sp>
         </mc:Choice>
-        <mc:Fallback>
+        <mc:Fallback xmlns="">
           <p:sp>
             <p:nvSpPr>
               <p:cNvPr id="56" name="TextBox 55">
@@ -4432,8 +4445,8 @@
           </a:p>
         </p:txBody>
       </p:sp>
-      <mc:AlternateContent xmlns:mc="http://schemas.openxmlformats.org/markup-compatibility/2006">
-        <mc:Choice xmlns:a14="http://schemas.microsoft.com/office/drawing/2010/main" Requires="a14">
+      <mc:AlternateContent xmlns:mc="http://schemas.openxmlformats.org/markup-compatibility/2006" xmlns:a14="http://schemas.microsoft.com/office/drawing/2010/main">
+        <mc:Choice Requires="a14">
           <p:sp>
             <p:nvSpPr>
               <p:cNvPr id="66" name="TextBox 65">
@@ -4462,6 +4475,7 @@
               </a:bodyPr>
               <a:lstStyle/>
               <a:p>
+                <a:pPr/>
                 <a14:m>
                   <m:oMathPara xmlns:m="http://schemas.openxmlformats.org/officeDocument/2006/math">
                     <m:oMathParaPr>
@@ -4501,7 +4515,7 @@
             </p:txBody>
           </p:sp>
         </mc:Choice>
-        <mc:Fallback>
+        <mc:Fallback xmlns="">
           <p:sp>
             <p:nvSpPr>
               <p:cNvPr id="66" name="TextBox 65">
@@ -4591,8 +4605,8 @@
           </a:fontRef>
         </p:style>
       </p:cxnSp>
-      <mc:AlternateContent xmlns:mc="http://schemas.openxmlformats.org/markup-compatibility/2006">
-        <mc:Choice xmlns:a14="http://schemas.microsoft.com/office/drawing/2010/main" Requires="a14">
+      <mc:AlternateContent xmlns:mc="http://schemas.openxmlformats.org/markup-compatibility/2006" xmlns:a14="http://schemas.microsoft.com/office/drawing/2010/main">
+        <mc:Choice Requires="a14">
           <p:sp>
             <p:nvSpPr>
               <p:cNvPr id="83" name="TextBox 82">
@@ -4621,6 +4635,7 @@
               </a:bodyPr>
               <a:lstStyle/>
               <a:p>
+                <a:pPr/>
                 <a14:m>
                   <m:oMathPara xmlns:m="http://schemas.openxmlformats.org/officeDocument/2006/math">
                     <m:oMathParaPr>
@@ -4642,7 +4657,7 @@
             </p:txBody>
           </p:sp>
         </mc:Choice>
-        <mc:Fallback>
+        <mc:Fallback xmlns="">
           <p:sp>
             <p:nvSpPr>
               <p:cNvPr id="83" name="TextBox 82">
@@ -4687,8 +4702,8 @@
           </p:sp>
         </mc:Fallback>
       </mc:AlternateContent>
-      <mc:AlternateContent xmlns:mc="http://schemas.openxmlformats.org/markup-compatibility/2006">
-        <mc:Choice xmlns:a14="http://schemas.microsoft.com/office/drawing/2010/main" Requires="a14">
+      <mc:AlternateContent xmlns:mc="http://schemas.openxmlformats.org/markup-compatibility/2006" xmlns:a14="http://schemas.microsoft.com/office/drawing/2010/main">
+        <mc:Choice Requires="a14">
           <p:sp>
             <p:nvSpPr>
               <p:cNvPr id="84" name="TextBox 83">
@@ -4717,6 +4732,7 @@
               </a:bodyPr>
               <a:lstStyle/>
               <a:p>
+                <a:pPr/>
                 <a14:m>
                   <m:oMathPara xmlns:m="http://schemas.openxmlformats.org/officeDocument/2006/math">
                     <m:oMathParaPr>
@@ -4756,7 +4772,7 @@
             </p:txBody>
           </p:sp>
         </mc:Choice>
-        <mc:Fallback>
+        <mc:Fallback xmlns="">
           <p:sp>
             <p:nvSpPr>
               <p:cNvPr id="84" name="TextBox 83">
@@ -4876,8 +4892,8 @@
           </a:fontRef>
         </p:style>
       </p:cxnSp>
-      <mc:AlternateContent xmlns:mc="http://schemas.openxmlformats.org/markup-compatibility/2006">
-        <mc:Choice xmlns:a14="http://schemas.microsoft.com/office/drawing/2010/main" Requires="a14">
+      <mc:AlternateContent xmlns:mc="http://schemas.openxmlformats.org/markup-compatibility/2006" xmlns:a14="http://schemas.microsoft.com/office/drawing/2010/main">
+        <mc:Choice Requires="a14">
           <p:sp>
             <p:nvSpPr>
               <p:cNvPr id="98" name="TextBox 97">
@@ -4906,6 +4922,7 @@
               </a:bodyPr>
               <a:lstStyle/>
               <a:p>
+                <a:pPr/>
                 <a14:m>
                   <m:oMathPara xmlns:m="http://schemas.openxmlformats.org/officeDocument/2006/math">
                     <m:oMathParaPr>
@@ -4953,7 +4970,7 @@
             </p:txBody>
           </p:sp>
         </mc:Choice>
-        <mc:Fallback>
+        <mc:Fallback xmlns="">
           <p:sp>
             <p:nvSpPr>
               <p:cNvPr id="98" name="TextBox 97">
@@ -5044,8 +5061,8 @@
           </a:fontRef>
         </p:style>
       </p:cxnSp>
-      <mc:AlternateContent xmlns:mc="http://schemas.openxmlformats.org/markup-compatibility/2006">
-        <mc:Choice xmlns:a14="http://schemas.microsoft.com/office/drawing/2010/main" Requires="a14">
+      <mc:AlternateContent xmlns:mc="http://schemas.openxmlformats.org/markup-compatibility/2006" xmlns:a14="http://schemas.microsoft.com/office/drawing/2010/main">
+        <mc:Choice Requires="a14">
           <p:sp>
             <p:nvSpPr>
               <p:cNvPr id="103" name="TextBox 102">
@@ -5074,6 +5091,7 @@
               </a:bodyPr>
               <a:lstStyle/>
               <a:p>
+                <a:pPr/>
                 <a14:m>
                   <m:oMathPara xmlns:m="http://schemas.openxmlformats.org/officeDocument/2006/math">
                     <m:oMathParaPr>
@@ -5121,7 +5139,7 @@
             </p:txBody>
           </p:sp>
         </mc:Choice>
-        <mc:Fallback>
+        <mc:Fallback xmlns="">
           <p:sp>
             <p:nvSpPr>
               <p:cNvPr id="103" name="TextBox 102">
@@ -5232,8 +5250,8 @@
             </a:p>
           </p:txBody>
         </p:sp>
-        <mc:AlternateContent xmlns:mc="http://schemas.openxmlformats.org/markup-compatibility/2006">
-          <mc:Choice xmlns:a14="http://schemas.microsoft.com/office/drawing/2010/main" Requires="a14">
+        <mc:AlternateContent xmlns:mc="http://schemas.openxmlformats.org/markup-compatibility/2006" xmlns:a14="http://schemas.microsoft.com/office/drawing/2010/main">
+          <mc:Choice Requires="a14">
             <p:sp>
               <p:nvSpPr>
                 <p:cNvPr id="19" name="TextBox 18">
@@ -5262,6 +5280,7 @@
                 </a:bodyPr>
                 <a:lstStyle/>
                 <a:p>
+                  <a:pPr/>
                   <a14:m>
                     <m:oMathPara xmlns:m="http://schemas.openxmlformats.org/officeDocument/2006/math">
                       <m:oMathParaPr>
@@ -5341,7 +5360,7 @@
               </p:txBody>
             </p:sp>
           </mc:Choice>
-          <mc:Fallback>
+          <mc:Fallback xmlns="">
             <p:sp>
               <p:nvSpPr>
                 <p:cNvPr id="19" name="TextBox 18">
@@ -5386,8 +5405,8 @@
             </p:sp>
           </mc:Fallback>
         </mc:AlternateContent>
-        <mc:AlternateContent xmlns:mc="http://schemas.openxmlformats.org/markup-compatibility/2006">
-          <mc:Choice xmlns:a14="http://schemas.microsoft.com/office/drawing/2010/main" Requires="a14">
+        <mc:AlternateContent xmlns:mc="http://schemas.openxmlformats.org/markup-compatibility/2006" xmlns:a14="http://schemas.microsoft.com/office/drawing/2010/main">
+          <mc:Choice Requires="a14">
             <p:sp>
               <p:nvSpPr>
                 <p:cNvPr id="20" name="TextBox 19">
@@ -5416,6 +5435,7 @@
                 </a:bodyPr>
                 <a:lstStyle/>
                 <a:p>
+                  <a:pPr/>
                   <a14:m>
                     <m:oMathPara xmlns:m="http://schemas.openxmlformats.org/officeDocument/2006/math">
                       <m:oMathParaPr>
@@ -5479,7 +5499,7 @@
               </p:txBody>
             </p:sp>
           </mc:Choice>
-          <mc:Fallback>
+          <mc:Fallback xmlns="">
             <p:sp>
               <p:nvSpPr>
                 <p:cNvPr id="20" name="TextBox 19">
@@ -5524,8 +5544,8 @@
             </p:sp>
           </mc:Fallback>
         </mc:AlternateContent>
-        <mc:AlternateContent xmlns:mc="http://schemas.openxmlformats.org/markup-compatibility/2006">
-          <mc:Choice xmlns:a14="http://schemas.microsoft.com/office/drawing/2010/main" Requires="a14">
+        <mc:AlternateContent xmlns:mc="http://schemas.openxmlformats.org/markup-compatibility/2006" xmlns:a14="http://schemas.microsoft.com/office/drawing/2010/main">
+          <mc:Choice Requires="a14">
             <p:sp>
               <p:nvSpPr>
                 <p:cNvPr id="21" name="TextBox 20">
@@ -5554,6 +5574,7 @@
                 </a:bodyPr>
                 <a:lstStyle/>
                 <a:p>
+                  <a:pPr/>
                   <a14:m>
                     <m:oMathPara xmlns:m="http://schemas.openxmlformats.org/officeDocument/2006/math">
                       <m:oMathParaPr>
@@ -5617,7 +5638,7 @@
               </p:txBody>
             </p:sp>
           </mc:Choice>
-          <mc:Fallback>
+          <mc:Fallback xmlns="">
             <p:sp>
               <p:nvSpPr>
                 <p:cNvPr id="21" name="TextBox 20">
@@ -5681,6 +5702,1337 @@
   <p:cSld>
     <p:spTree>
       <p:nvGrpSpPr>
+        <p:cNvPr id="1" name="">
+          <a:extLst>
+            <a:ext uri="{FF2B5EF4-FFF2-40B4-BE49-F238E27FC236}">
+              <a16:creationId xmlns:a16="http://schemas.microsoft.com/office/drawing/2014/main" id="{072135C2-ACE0-B0DF-3F4F-D5BCDD53D08D}"/>
+            </a:ext>
+          </a:extLst>
+        </p:cNvPr>
+        <p:cNvGrpSpPr/>
+        <p:nvPr/>
+      </p:nvGrpSpPr>
+      <p:grpSpPr>
+        <a:xfrm>
+          <a:off x="0" y="0"/>
+          <a:ext cx="0" cy="0"/>
+          <a:chOff x="0" y="0"/>
+          <a:chExt cx="0" cy="0"/>
+        </a:xfrm>
+      </p:grpSpPr>
+      <p:sp>
+        <p:nvSpPr>
+          <p:cNvPr id="86" name="Title 85">
+            <a:extLst>
+              <a:ext uri="{FF2B5EF4-FFF2-40B4-BE49-F238E27FC236}">
+                <a16:creationId xmlns:a16="http://schemas.microsoft.com/office/drawing/2014/main" id="{F9D277DE-7AF9-447B-6514-46CE24D27007}"/>
+              </a:ext>
+            </a:extLst>
+          </p:cNvPr>
+          <p:cNvSpPr>
+            <a:spLocks noGrp="1"/>
+          </p:cNvSpPr>
+          <p:nvPr>
+            <p:ph type="title"/>
+          </p:nvPr>
+        </p:nvSpPr>
+        <p:spPr/>
+        <p:txBody>
+          <a:bodyPr/>
+          <a:lstStyle/>
+          <a:p>
+            <a:r>
+              <a:rPr lang="en-US" dirty="0"/>
+              <a:t>Herbert’s Network 1</a:t>
+            </a:r>
+          </a:p>
+        </p:txBody>
+      </p:sp>
+      <mc:AlternateContent xmlns:mc="http://schemas.openxmlformats.org/markup-compatibility/2006">
+        <mc:Choice xmlns:a14="http://schemas.microsoft.com/office/drawing/2010/main" Requires="a14">
+          <p:sp>
+            <p:nvSpPr>
+              <p:cNvPr id="2" name="TextBox 1">
+                <a:extLst>
+                  <a:ext uri="{FF2B5EF4-FFF2-40B4-BE49-F238E27FC236}">
+                    <a16:creationId xmlns:a16="http://schemas.microsoft.com/office/drawing/2014/main" id="{712054EA-695C-AAD9-B4C5-BA230CFCBE5C}"/>
+                  </a:ext>
+                </a:extLst>
+              </p:cNvPr>
+              <p:cNvSpPr txBox="1"/>
+              <p:nvPr/>
+            </p:nvSpPr>
+            <p:spPr>
+              <a:xfrm>
+                <a:off x="2535704" y="2974427"/>
+                <a:ext cx="1035989" cy="281937"/>
+              </a:xfrm>
+              <a:prstGeom prst="rect">
+                <a:avLst/>
+              </a:prstGeom>
+              <a:noFill/>
+            </p:spPr>
+            <p:txBody>
+              <a:bodyPr wrap="none" lIns="0" tIns="0" rIns="0" bIns="0" rtlCol="0">
+                <a:spAutoFit/>
+              </a:bodyPr>
+              <a:lstStyle/>
+              <a:p>
+                <a14:m>
+                  <m:oMathPara xmlns:m="http://schemas.openxmlformats.org/officeDocument/2006/math">
+                    <m:oMathParaPr>
+                      <m:jc m:val="centerGroup"/>
+                    </m:oMathParaPr>
+                    <m:oMath xmlns:m="http://schemas.openxmlformats.org/officeDocument/2006/math">
+                      <m:sSub>
+                        <m:sSubPr>
+                          <m:ctrlPr>
+                            <a:rPr lang="en-US" b="0" i="1" smtClean="0">
+                              <a:latin typeface="Cambria Math" panose="02040503050406030204" pitchFamily="18" charset="0"/>
+                            </a:rPr>
+                          </m:ctrlPr>
+                        </m:sSubPr>
+                        <m:e>
+                          <m:r>
+                            <a:rPr lang="en-US" b="0" i="1" smtClean="0">
+                              <a:latin typeface="Cambria Math" panose="02040503050406030204" pitchFamily="18" charset="0"/>
+                            </a:rPr>
+                            <m:t>𝑋</m:t>
+                          </m:r>
+                        </m:e>
+                        <m:sub>
+                          <m:r>
+                            <a:rPr lang="en-US" b="0" i="1" smtClean="0">
+                              <a:latin typeface="Cambria Math" panose="02040503050406030204" pitchFamily="18" charset="0"/>
+                            </a:rPr>
+                            <m:t>0</m:t>
+                          </m:r>
+                        </m:sub>
+                      </m:sSub>
+                      <m:sSup>
+                        <m:sSupPr>
+                          <m:ctrlPr>
+                            <a:rPr lang="en-US" b="0" i="1" smtClean="0">
+                              <a:latin typeface="Cambria Math" panose="02040503050406030204" pitchFamily="18" charset="0"/>
+                            </a:rPr>
+                          </m:ctrlPr>
+                        </m:sSupPr>
+                        <m:e>
+                          <m:r>
+                            <a:rPr lang="en-US" b="0" i="1" smtClean="0">
+                              <a:latin typeface="Cambria Math" panose="02040503050406030204" pitchFamily="18" charset="0"/>
+                            </a:rPr>
+                            <m:t>→</m:t>
+                          </m:r>
+                        </m:e>
+                        <m:sup>
+                          <m:sSub>
+                            <m:sSubPr>
+                              <m:ctrlPr>
+                                <a:rPr lang="en-US" b="0" i="1" smtClean="0">
+                                  <a:latin typeface="Cambria Math" panose="02040503050406030204" pitchFamily="18" charset="0"/>
+                                </a:rPr>
+                              </m:ctrlPr>
+                            </m:sSubPr>
+                            <m:e>
+                              <m:r>
+                                <a:rPr lang="en-US" b="0" i="1" smtClean="0">
+                                  <a:latin typeface="Cambria Math" panose="02040503050406030204" pitchFamily="18" charset="0"/>
+                                </a:rPr>
+                                <m:t>𝑘</m:t>
+                              </m:r>
+                            </m:e>
+                            <m:sub>
+                              <m:r>
+                                <a:rPr lang="en-US" b="0" i="1" smtClean="0">
+                                  <a:latin typeface="Cambria Math" panose="02040503050406030204" pitchFamily="18" charset="0"/>
+                                </a:rPr>
+                                <m:t>1</m:t>
+                              </m:r>
+                            </m:sub>
+                          </m:sSub>
+                        </m:sup>
+                      </m:sSup>
+                      <m:sSub>
+                        <m:sSubPr>
+                          <m:ctrlPr>
+                            <a:rPr lang="en-US" b="0" i="1" smtClean="0">
+                              <a:latin typeface="Cambria Math" panose="02040503050406030204" pitchFamily="18" charset="0"/>
+                            </a:rPr>
+                          </m:ctrlPr>
+                        </m:sSubPr>
+                        <m:e>
+                          <m:r>
+                            <a:rPr lang="en-US" b="0" i="1" smtClean="0">
+                              <a:latin typeface="Cambria Math" panose="02040503050406030204" pitchFamily="18" charset="0"/>
+                            </a:rPr>
+                            <m:t>𝑆</m:t>
+                          </m:r>
+                        </m:e>
+                        <m:sub>
+                          <m:r>
+                            <a:rPr lang="en-US" b="0" i="1" smtClean="0">
+                              <a:latin typeface="Cambria Math" panose="02040503050406030204" pitchFamily="18" charset="0"/>
+                            </a:rPr>
+                            <m:t>1</m:t>
+                          </m:r>
+                        </m:sub>
+                      </m:sSub>
+                    </m:oMath>
+                  </m:oMathPara>
+                </a14:m>
+                <a:endParaRPr lang="en-US" dirty="0"/>
+              </a:p>
+            </p:txBody>
+          </p:sp>
+        </mc:Choice>
+        <mc:Fallback>
+          <p:sp>
+            <p:nvSpPr>
+              <p:cNvPr id="2" name="TextBox 1">
+                <a:extLst>
+                  <a:ext uri="{FF2B5EF4-FFF2-40B4-BE49-F238E27FC236}">
+                    <a16:creationId xmlns:a16="http://schemas.microsoft.com/office/drawing/2014/main" id="{712054EA-695C-AAD9-B4C5-BA230CFCBE5C}"/>
+                  </a:ext>
+                </a:extLst>
+              </p:cNvPr>
+              <p:cNvSpPr txBox="1">
+                <a:spLocks noRot="1" noChangeAspect="1" noMove="1" noResize="1" noEditPoints="1" noAdjustHandles="1" noChangeArrowheads="1" noChangeShapeType="1" noTextEdit="1"/>
+              </p:cNvSpPr>
+              <p:nvPr/>
+            </p:nvSpPr>
+            <p:spPr>
+              <a:xfrm>
+                <a:off x="2535704" y="2974427"/>
+                <a:ext cx="1035989" cy="281937"/>
+              </a:xfrm>
+              <a:prstGeom prst="rect">
+                <a:avLst/>
+              </a:prstGeom>
+              <a:blipFill>
+                <a:blip r:embed="rId2"/>
+                <a:stretch>
+                  <a:fillRect l="-4819" t="-4348" r="-1205" b="-13043"/>
+                </a:stretch>
+              </a:blipFill>
+            </p:spPr>
+            <p:txBody>
+              <a:bodyPr/>
+              <a:lstStyle/>
+              <a:p>
+                <a:r>
+                  <a:rPr lang="en-US">
+                    <a:noFill/>
+                  </a:rPr>
+                  <a:t> </a:t>
+                </a:r>
+              </a:p>
+            </p:txBody>
+          </p:sp>
+        </mc:Fallback>
+      </mc:AlternateContent>
+      <p:sp>
+        <p:nvSpPr>
+          <p:cNvPr id="3" name="Rectangle 2">
+            <a:extLst>
+              <a:ext uri="{FF2B5EF4-FFF2-40B4-BE49-F238E27FC236}">
+                <a16:creationId xmlns:a16="http://schemas.microsoft.com/office/drawing/2014/main" id="{15C50A65-66D7-E2C2-C438-C26F47E845F0}"/>
+              </a:ext>
+            </a:extLst>
+          </p:cNvPr>
+          <p:cNvSpPr/>
+          <p:nvPr/>
+        </p:nvSpPr>
+        <p:spPr>
+          <a:xfrm>
+            <a:off x="2353453" y="2646196"/>
+            <a:ext cx="1364383" cy="1554532"/>
+          </a:xfrm>
+          <a:prstGeom prst="rect">
+            <a:avLst/>
+          </a:prstGeom>
+          <a:noFill/>
+          <a:ln>
+            <a:solidFill>
+              <a:schemeClr val="tx1"/>
+            </a:solidFill>
+          </a:ln>
+        </p:spPr>
+        <p:style>
+          <a:lnRef idx="2">
+            <a:schemeClr val="accent1">
+              <a:shade val="15000"/>
+            </a:schemeClr>
+          </a:lnRef>
+          <a:fillRef idx="1">
+            <a:schemeClr val="accent1"/>
+          </a:fillRef>
+          <a:effectRef idx="0">
+            <a:schemeClr val="accent1"/>
+          </a:effectRef>
+          <a:fontRef idx="minor">
+            <a:schemeClr val="lt1"/>
+          </a:fontRef>
+        </p:style>
+        <p:txBody>
+          <a:bodyPr rtlCol="0" anchor="ctr"/>
+          <a:lstStyle/>
+          <a:p>
+            <a:pPr algn="ctr"/>
+            <a:endParaRPr lang="en-US" b="0" dirty="0">
+              <a:solidFill>
+                <a:schemeClr val="tx1"/>
+              </a:solidFill>
+            </a:endParaRPr>
+          </a:p>
+          <a:p>
+            <a:pPr algn="ctr"/>
+            <a:endParaRPr lang="en-US" dirty="0">
+              <a:solidFill>
+                <a:schemeClr val="tx1"/>
+              </a:solidFill>
+            </a:endParaRPr>
+          </a:p>
+        </p:txBody>
+      </p:sp>
+      <mc:AlternateContent xmlns:mc="http://schemas.openxmlformats.org/markup-compatibility/2006">
+        <mc:Choice xmlns:a14="http://schemas.microsoft.com/office/drawing/2010/main" Requires="a14">
+          <p:sp>
+            <p:nvSpPr>
+              <p:cNvPr id="4" name="TextBox 3">
+                <a:extLst>
+                  <a:ext uri="{FF2B5EF4-FFF2-40B4-BE49-F238E27FC236}">
+                    <a16:creationId xmlns:a16="http://schemas.microsoft.com/office/drawing/2014/main" id="{9687416C-175E-9ECA-A33B-83B07FAD8F32}"/>
+                  </a:ext>
+                </a:extLst>
+              </p:cNvPr>
+              <p:cNvSpPr txBox="1"/>
+              <p:nvPr/>
+            </p:nvSpPr>
+            <p:spPr>
+              <a:xfrm>
+                <a:off x="3995787" y="2912642"/>
+                <a:ext cx="1133452" cy="415178"/>
+              </a:xfrm>
+              <a:prstGeom prst="rect">
+                <a:avLst/>
+              </a:prstGeom>
+              <a:noFill/>
+            </p:spPr>
+            <p:txBody>
+              <a:bodyPr wrap="none" lIns="0" tIns="0" rIns="0" bIns="0" rtlCol="0">
+                <a:spAutoFit/>
+              </a:bodyPr>
+              <a:lstStyle/>
+              <a:p>
+                <a14:m>
+                  <m:oMathPara xmlns:m="http://schemas.openxmlformats.org/officeDocument/2006/math">
+                    <m:oMathParaPr>
+                      <m:jc m:val="centerGroup"/>
+                    </m:oMathParaPr>
+                    <m:oMath xmlns:m="http://schemas.openxmlformats.org/officeDocument/2006/math">
+                      <m:sSub>
+                        <m:sSubPr>
+                          <m:ctrlPr>
+                            <a:rPr lang="en-US" b="0" i="1" smtClean="0">
+                              <a:latin typeface="Cambria Math" panose="02040503050406030204" pitchFamily="18" charset="0"/>
+                            </a:rPr>
+                          </m:ctrlPr>
+                        </m:sSubPr>
+                        <m:e>
+                          <m:r>
+                            <a:rPr lang="en-US" b="0" i="1" smtClean="0">
+                              <a:latin typeface="Cambria Math" panose="02040503050406030204" pitchFamily="18" charset="0"/>
+                            </a:rPr>
+                            <m:t>𝑆</m:t>
+                          </m:r>
+                        </m:e>
+                        <m:sub>
+                          <m:r>
+                            <a:rPr lang="en-US" b="0" i="1" smtClean="0">
+                              <a:latin typeface="Cambria Math" panose="02040503050406030204" pitchFamily="18" charset="0"/>
+                            </a:rPr>
+                            <m:t>1</m:t>
+                          </m:r>
+                        </m:sub>
+                      </m:sSub>
+                      <m:sSubSup>
+                        <m:sSubSupPr>
+                          <m:ctrlPr>
+                            <a:rPr lang="en-US" b="0" i="1" smtClean="0">
+                              <a:latin typeface="Cambria Math" panose="02040503050406030204" pitchFamily="18" charset="0"/>
+                            </a:rPr>
+                          </m:ctrlPr>
+                        </m:sSubSupPr>
+                        <m:e>
+                          <m:r>
+                            <a:rPr lang="en-US" b="0" i="1" smtClean="0">
+                              <a:latin typeface="Cambria Math" panose="02040503050406030204" pitchFamily="18" charset="0"/>
+                            </a:rPr>
+                            <m:t>↔</m:t>
+                          </m:r>
+                        </m:e>
+                        <m:sub>
+                          <m:sSub>
+                            <m:sSubPr>
+                              <m:ctrlPr>
+                                <a:rPr lang="en-US" b="0" i="1" smtClean="0">
+                                  <a:latin typeface="Cambria Math" panose="02040503050406030204" pitchFamily="18" charset="0"/>
+                                </a:rPr>
+                              </m:ctrlPr>
+                            </m:sSubPr>
+                            <m:e>
+                              <m:r>
+                                <a:rPr lang="en-US" b="0" i="1" smtClean="0">
+                                  <a:latin typeface="Cambria Math" panose="02040503050406030204" pitchFamily="18" charset="0"/>
+                                </a:rPr>
+                                <m:t>𝑘</m:t>
+                              </m:r>
+                            </m:e>
+                            <m:sub>
+                              <m:r>
+                                <a:rPr lang="en-US" b="0" i="1" smtClean="0">
+                                  <a:latin typeface="Cambria Math" panose="02040503050406030204" pitchFamily="18" charset="0"/>
+                                </a:rPr>
+                                <m:t>2</m:t>
+                              </m:r>
+                            </m:sub>
+                          </m:sSub>
+                          <m:r>
+                            <a:rPr lang="en-US" b="0" i="1" smtClean="0">
+                              <a:latin typeface="Cambria Math" panose="02040503050406030204" pitchFamily="18" charset="0"/>
+                            </a:rPr>
+                            <m:t>𝑏</m:t>
+                          </m:r>
+                        </m:sub>
+                        <m:sup>
+                          <m:sSub>
+                            <m:sSubPr>
+                              <m:ctrlPr>
+                                <a:rPr lang="en-US" b="0" i="1" smtClean="0">
+                                  <a:latin typeface="Cambria Math" panose="02040503050406030204" pitchFamily="18" charset="0"/>
+                                </a:rPr>
+                              </m:ctrlPr>
+                            </m:sSubPr>
+                            <m:e>
+                              <m:r>
+                                <a:rPr lang="en-US" b="0" i="1" smtClean="0">
+                                  <a:latin typeface="Cambria Math" panose="02040503050406030204" pitchFamily="18" charset="0"/>
+                                </a:rPr>
+                                <m:t>𝑘</m:t>
+                              </m:r>
+                            </m:e>
+                            <m:sub>
+                              <m:r>
+                                <a:rPr lang="en-US" b="0" i="1" smtClean="0">
+                                  <a:latin typeface="Cambria Math" panose="02040503050406030204" pitchFamily="18" charset="0"/>
+                                </a:rPr>
+                                <m:t>2</m:t>
+                              </m:r>
+                              <m:r>
+                                <a:rPr lang="en-US" b="0" i="1" smtClean="0">
+                                  <a:latin typeface="Cambria Math" panose="02040503050406030204" pitchFamily="18" charset="0"/>
+                                </a:rPr>
+                                <m:t>𝑓</m:t>
+                              </m:r>
+                            </m:sub>
+                          </m:sSub>
+                        </m:sup>
+                      </m:sSubSup>
+                      <m:sSub>
+                        <m:sSubPr>
+                          <m:ctrlPr>
+                            <a:rPr lang="en-US" b="0" i="1" smtClean="0">
+                              <a:latin typeface="Cambria Math" panose="02040503050406030204" pitchFamily="18" charset="0"/>
+                            </a:rPr>
+                          </m:ctrlPr>
+                        </m:sSubPr>
+                        <m:e>
+                          <m:r>
+                            <a:rPr lang="en-US" b="0" i="1" smtClean="0">
+                              <a:latin typeface="Cambria Math" panose="02040503050406030204" pitchFamily="18" charset="0"/>
+                            </a:rPr>
+                            <m:t>𝑆</m:t>
+                          </m:r>
+                        </m:e>
+                        <m:sub>
+                          <m:r>
+                            <a:rPr lang="en-US" b="0" i="1" smtClean="0">
+                              <a:latin typeface="Cambria Math" panose="02040503050406030204" pitchFamily="18" charset="0"/>
+                            </a:rPr>
+                            <m:t>2</m:t>
+                          </m:r>
+                        </m:sub>
+                      </m:sSub>
+                    </m:oMath>
+                  </m:oMathPara>
+                </a14:m>
+                <a:endParaRPr lang="en-US" dirty="0"/>
+              </a:p>
+            </p:txBody>
+          </p:sp>
+        </mc:Choice>
+        <mc:Fallback>
+          <p:sp>
+            <p:nvSpPr>
+              <p:cNvPr id="4" name="TextBox 3">
+                <a:extLst>
+                  <a:ext uri="{FF2B5EF4-FFF2-40B4-BE49-F238E27FC236}">
+                    <a16:creationId xmlns:a16="http://schemas.microsoft.com/office/drawing/2014/main" id="{9687416C-175E-9ECA-A33B-83B07FAD8F32}"/>
+                  </a:ext>
+                </a:extLst>
+              </p:cNvPr>
+              <p:cNvSpPr txBox="1">
+                <a:spLocks noRot="1" noChangeAspect="1" noMove="1" noResize="1" noEditPoints="1" noAdjustHandles="1" noChangeArrowheads="1" noChangeShapeType="1" noTextEdit="1"/>
+              </p:cNvSpPr>
+              <p:nvPr/>
+            </p:nvSpPr>
+            <p:spPr>
+              <a:xfrm>
+                <a:off x="3995787" y="2912642"/>
+                <a:ext cx="1133452" cy="415178"/>
+              </a:xfrm>
+              <a:prstGeom prst="rect">
+                <a:avLst/>
+              </a:prstGeom>
+              <a:blipFill>
+                <a:blip r:embed="rId3"/>
+                <a:stretch>
+                  <a:fillRect l="-3333" t="-2941" r="-1111" b="-8824"/>
+                </a:stretch>
+              </a:blipFill>
+            </p:spPr>
+            <p:txBody>
+              <a:bodyPr/>
+              <a:lstStyle/>
+              <a:p>
+                <a:r>
+                  <a:rPr lang="en-US">
+                    <a:noFill/>
+                  </a:rPr>
+                  <a:t> </a:t>
+                </a:r>
+              </a:p>
+            </p:txBody>
+          </p:sp>
+        </mc:Fallback>
+      </mc:AlternateContent>
+      <p:sp>
+        <p:nvSpPr>
+          <p:cNvPr id="5" name="Rectangle 4">
+            <a:extLst>
+              <a:ext uri="{FF2B5EF4-FFF2-40B4-BE49-F238E27FC236}">
+                <a16:creationId xmlns:a16="http://schemas.microsoft.com/office/drawing/2014/main" id="{3F813B22-6FEE-8A28-88B6-13E47EC730EE}"/>
+              </a:ext>
+            </a:extLst>
+          </p:cNvPr>
+          <p:cNvSpPr/>
+          <p:nvPr/>
+        </p:nvSpPr>
+        <p:spPr>
+          <a:xfrm>
+            <a:off x="3793650" y="2646197"/>
+            <a:ext cx="1494126" cy="1554532"/>
+          </a:xfrm>
+          <a:prstGeom prst="rect">
+            <a:avLst/>
+          </a:prstGeom>
+          <a:noFill/>
+          <a:ln>
+            <a:solidFill>
+              <a:schemeClr val="tx1"/>
+            </a:solidFill>
+          </a:ln>
+        </p:spPr>
+        <p:style>
+          <a:lnRef idx="2">
+            <a:schemeClr val="accent1">
+              <a:shade val="15000"/>
+            </a:schemeClr>
+          </a:lnRef>
+          <a:fillRef idx="1">
+            <a:schemeClr val="accent1"/>
+          </a:fillRef>
+          <a:effectRef idx="0">
+            <a:schemeClr val="accent1"/>
+          </a:effectRef>
+          <a:fontRef idx="minor">
+            <a:schemeClr val="lt1"/>
+          </a:fontRef>
+        </p:style>
+        <p:txBody>
+          <a:bodyPr rtlCol="0" anchor="ctr"/>
+          <a:lstStyle/>
+          <a:p>
+            <a:pPr algn="ctr"/>
+            <a:endParaRPr lang="en-US"/>
+          </a:p>
+        </p:txBody>
+      </p:sp>
+      <p:sp>
+        <p:nvSpPr>
+          <p:cNvPr id="6" name="TextBox 5">
+            <a:extLst>
+              <a:ext uri="{FF2B5EF4-FFF2-40B4-BE49-F238E27FC236}">
+                <a16:creationId xmlns:a16="http://schemas.microsoft.com/office/drawing/2014/main" id="{1C59699B-DB34-DA73-3416-116B3955BB75}"/>
+              </a:ext>
+            </a:extLst>
+          </p:cNvPr>
+          <p:cNvSpPr txBox="1"/>
+          <p:nvPr/>
+        </p:nvSpPr>
+        <p:spPr>
+          <a:xfrm>
+            <a:off x="2631536" y="2318719"/>
+            <a:ext cx="998991" cy="338554"/>
+          </a:xfrm>
+          <a:prstGeom prst="rect">
+            <a:avLst/>
+          </a:prstGeom>
+          <a:noFill/>
+        </p:spPr>
+        <p:txBody>
+          <a:bodyPr wrap="none" rtlCol="0">
+            <a:spAutoFit/>
+          </a:bodyPr>
+          <a:lstStyle/>
+          <a:p>
+            <a:r>
+              <a:rPr lang="en-US" sz="1600" b="1" dirty="0"/>
+              <a:t>Module 1</a:t>
+            </a:r>
+          </a:p>
+        </p:txBody>
+      </p:sp>
+      <p:sp>
+        <p:nvSpPr>
+          <p:cNvPr id="7" name="TextBox 6">
+            <a:extLst>
+              <a:ext uri="{FF2B5EF4-FFF2-40B4-BE49-F238E27FC236}">
+                <a16:creationId xmlns:a16="http://schemas.microsoft.com/office/drawing/2014/main" id="{59B8DCB6-6D0C-0E3E-73C9-0DD0ECA670F9}"/>
+              </a:ext>
+            </a:extLst>
+          </p:cNvPr>
+          <p:cNvSpPr txBox="1"/>
+          <p:nvPr/>
+        </p:nvSpPr>
+        <p:spPr>
+          <a:xfrm>
+            <a:off x="3786562" y="2318719"/>
+            <a:ext cx="998991" cy="338554"/>
+          </a:xfrm>
+          <a:prstGeom prst="rect">
+            <a:avLst/>
+          </a:prstGeom>
+          <a:noFill/>
+        </p:spPr>
+        <p:txBody>
+          <a:bodyPr wrap="none" rtlCol="0">
+            <a:spAutoFit/>
+          </a:bodyPr>
+          <a:lstStyle/>
+          <a:p>
+            <a:r>
+              <a:rPr lang="en-US" sz="1600" b="1" dirty="0"/>
+              <a:t>Module 2</a:t>
+            </a:r>
+          </a:p>
+        </p:txBody>
+      </p:sp>
+      <p:sp>
+        <p:nvSpPr>
+          <p:cNvPr id="8" name="Oval 7">
+            <a:extLst>
+              <a:ext uri="{FF2B5EF4-FFF2-40B4-BE49-F238E27FC236}">
+                <a16:creationId xmlns:a16="http://schemas.microsoft.com/office/drawing/2014/main" id="{DFE45E57-E368-2BAD-B17E-241A0086C8B4}"/>
+              </a:ext>
+            </a:extLst>
+          </p:cNvPr>
+          <p:cNvSpPr/>
+          <p:nvPr/>
+        </p:nvSpPr>
+        <p:spPr>
+          <a:xfrm>
+            <a:off x="2353453" y="3026057"/>
+            <a:ext cx="182880" cy="178676"/>
+          </a:xfrm>
+          <a:prstGeom prst="ellipse">
+            <a:avLst/>
+          </a:prstGeom>
+          <a:solidFill>
+            <a:srgbClr val="00B050"/>
+          </a:solidFill>
+          <a:ln>
+            <a:noFill/>
+          </a:ln>
+        </p:spPr>
+        <p:style>
+          <a:lnRef idx="2">
+            <a:schemeClr val="accent1">
+              <a:shade val="15000"/>
+            </a:schemeClr>
+          </a:lnRef>
+          <a:fillRef idx="1">
+            <a:schemeClr val="accent1"/>
+          </a:fillRef>
+          <a:effectRef idx="0">
+            <a:schemeClr val="accent1"/>
+          </a:effectRef>
+          <a:fontRef idx="minor">
+            <a:schemeClr val="lt1"/>
+          </a:fontRef>
+        </p:style>
+        <p:txBody>
+          <a:bodyPr rtlCol="0" anchor="ctr"/>
+          <a:lstStyle/>
+          <a:p>
+            <a:pPr algn="ctr"/>
+            <a:endParaRPr lang="en-US"/>
+          </a:p>
+        </p:txBody>
+      </p:sp>
+      <p:sp>
+        <p:nvSpPr>
+          <p:cNvPr id="10" name="Oval 9">
+            <a:extLst>
+              <a:ext uri="{FF2B5EF4-FFF2-40B4-BE49-F238E27FC236}">
+                <a16:creationId xmlns:a16="http://schemas.microsoft.com/office/drawing/2014/main" id="{F6CD079D-A63F-CDDF-0C32-ACADFA7390CF}"/>
+              </a:ext>
+            </a:extLst>
+          </p:cNvPr>
+          <p:cNvSpPr/>
+          <p:nvPr/>
+        </p:nvSpPr>
+        <p:spPr>
+          <a:xfrm>
+            <a:off x="3519110" y="3026057"/>
+            <a:ext cx="182880" cy="178676"/>
+          </a:xfrm>
+          <a:prstGeom prst="ellipse">
+            <a:avLst/>
+          </a:prstGeom>
+          <a:solidFill>
+            <a:srgbClr val="FF0000"/>
+          </a:solidFill>
+          <a:ln>
+            <a:noFill/>
+          </a:ln>
+        </p:spPr>
+        <p:style>
+          <a:lnRef idx="2">
+            <a:schemeClr val="accent1">
+              <a:shade val="15000"/>
+            </a:schemeClr>
+          </a:lnRef>
+          <a:fillRef idx="1">
+            <a:schemeClr val="accent1"/>
+          </a:fillRef>
+          <a:effectRef idx="0">
+            <a:schemeClr val="accent1"/>
+          </a:effectRef>
+          <a:fontRef idx="minor">
+            <a:schemeClr val="lt1"/>
+          </a:fontRef>
+        </p:style>
+        <p:txBody>
+          <a:bodyPr rtlCol="0" anchor="ctr"/>
+          <a:lstStyle/>
+          <a:p>
+            <a:pPr algn="ctr"/>
+            <a:endParaRPr lang="en-US"/>
+          </a:p>
+        </p:txBody>
+      </p:sp>
+      <p:sp>
+        <p:nvSpPr>
+          <p:cNvPr id="14" name="Oval 13">
+            <a:extLst>
+              <a:ext uri="{FF2B5EF4-FFF2-40B4-BE49-F238E27FC236}">
+                <a16:creationId xmlns:a16="http://schemas.microsoft.com/office/drawing/2014/main" id="{DE4A96DF-C310-786F-123D-FBB2136DBF77}"/>
+              </a:ext>
+            </a:extLst>
+          </p:cNvPr>
+          <p:cNvSpPr/>
+          <p:nvPr/>
+        </p:nvSpPr>
+        <p:spPr>
+          <a:xfrm>
+            <a:off x="3828026" y="3043250"/>
+            <a:ext cx="182880" cy="178676"/>
+          </a:xfrm>
+          <a:prstGeom prst="ellipse">
+            <a:avLst/>
+          </a:prstGeom>
+          <a:solidFill>
+            <a:srgbClr val="00B050"/>
+          </a:solidFill>
+          <a:ln>
+            <a:noFill/>
+          </a:ln>
+        </p:spPr>
+        <p:style>
+          <a:lnRef idx="2">
+            <a:schemeClr val="accent1">
+              <a:shade val="15000"/>
+            </a:schemeClr>
+          </a:lnRef>
+          <a:fillRef idx="1">
+            <a:schemeClr val="accent1"/>
+          </a:fillRef>
+          <a:effectRef idx="0">
+            <a:schemeClr val="accent1"/>
+          </a:effectRef>
+          <a:fontRef idx="minor">
+            <a:schemeClr val="lt1"/>
+          </a:fontRef>
+        </p:style>
+        <p:txBody>
+          <a:bodyPr rtlCol="0" anchor="ctr"/>
+          <a:lstStyle/>
+          <a:p>
+            <a:pPr algn="ctr"/>
+            <a:endParaRPr lang="en-US"/>
+          </a:p>
+        </p:txBody>
+      </p:sp>
+      <p:sp>
+        <p:nvSpPr>
+          <p:cNvPr id="15" name="Oval 14">
+            <a:extLst>
+              <a:ext uri="{FF2B5EF4-FFF2-40B4-BE49-F238E27FC236}">
+                <a16:creationId xmlns:a16="http://schemas.microsoft.com/office/drawing/2014/main" id="{1A7F4A15-3975-2927-3E5B-A985DED4F914}"/>
+              </a:ext>
+            </a:extLst>
+          </p:cNvPr>
+          <p:cNvSpPr/>
+          <p:nvPr/>
+        </p:nvSpPr>
+        <p:spPr>
+          <a:xfrm>
+            <a:off x="5104896" y="3043250"/>
+            <a:ext cx="182880" cy="178676"/>
+          </a:xfrm>
+          <a:prstGeom prst="ellipse">
+            <a:avLst/>
+          </a:prstGeom>
+          <a:solidFill>
+            <a:srgbClr val="FF0000"/>
+          </a:solidFill>
+          <a:ln>
+            <a:noFill/>
+          </a:ln>
+        </p:spPr>
+        <p:style>
+          <a:lnRef idx="2">
+            <a:schemeClr val="accent1">
+              <a:shade val="15000"/>
+            </a:schemeClr>
+          </a:lnRef>
+          <a:fillRef idx="1">
+            <a:schemeClr val="accent1"/>
+          </a:fillRef>
+          <a:effectRef idx="0">
+            <a:schemeClr val="accent1"/>
+          </a:effectRef>
+          <a:fontRef idx="minor">
+            <a:schemeClr val="lt1"/>
+          </a:fontRef>
+        </p:style>
+        <p:txBody>
+          <a:bodyPr rtlCol="0" anchor="ctr"/>
+          <a:lstStyle/>
+          <a:p>
+            <a:pPr algn="ctr"/>
+            <a:endParaRPr lang="en-US"/>
+          </a:p>
+        </p:txBody>
+      </p:sp>
+      <mc:AlternateContent xmlns:mc="http://schemas.openxmlformats.org/markup-compatibility/2006">
+        <mc:Choice xmlns:a14="http://schemas.microsoft.com/office/drawing/2010/main" Requires="a14">
+          <p:sp>
+            <p:nvSpPr>
+              <p:cNvPr id="27" name="TextBox 26">
+                <a:extLst>
+                  <a:ext uri="{FF2B5EF4-FFF2-40B4-BE49-F238E27FC236}">
+                    <a16:creationId xmlns:a16="http://schemas.microsoft.com/office/drawing/2014/main" id="{0B75FC26-1395-A015-3BFF-8BC2C96BB353}"/>
+                  </a:ext>
+                </a:extLst>
+              </p:cNvPr>
+              <p:cNvSpPr txBox="1"/>
+              <p:nvPr/>
+            </p:nvSpPr>
+            <p:spPr>
+              <a:xfrm>
+                <a:off x="3047011" y="3782767"/>
+                <a:ext cx="670825" cy="553998"/>
+              </a:xfrm>
+              <a:prstGeom prst="rect">
+                <a:avLst/>
+              </a:prstGeom>
+              <a:noFill/>
+            </p:spPr>
+            <p:txBody>
+              <a:bodyPr wrap="none" lIns="0" tIns="0" rIns="0" bIns="0" rtlCol="0">
+                <a:spAutoFit/>
+              </a:bodyPr>
+              <a:lstStyle/>
+              <a:p>
+                <a14:m>
+                  <m:oMathPara xmlns:m="http://schemas.openxmlformats.org/officeDocument/2006/math">
+                    <m:oMathParaPr>
+                      <m:jc m:val="centerGroup"/>
+                    </m:oMathParaPr>
+                    <m:oMath xmlns:m="http://schemas.openxmlformats.org/officeDocument/2006/math">
+                      <m:r>
+                        <a:rPr lang="en-US" b="0" i="1" smtClean="0">
+                          <a:latin typeface="Cambria Math" panose="02040503050406030204" pitchFamily="18" charset="0"/>
+                        </a:rPr>
+                        <m:t>∅</m:t>
+                      </m:r>
+                    </m:oMath>
+                  </m:oMathPara>
+                </a14:m>
+                <a:endParaRPr lang="en-US" b="0" dirty="0"/>
+              </a:p>
+              <a:p>
+                <a:endParaRPr lang="en-US" dirty="0"/>
+              </a:p>
+            </p:txBody>
+          </p:sp>
+        </mc:Choice>
+        <mc:Fallback>
+          <p:sp>
+            <p:nvSpPr>
+              <p:cNvPr id="27" name="TextBox 26">
+                <a:extLst>
+                  <a:ext uri="{FF2B5EF4-FFF2-40B4-BE49-F238E27FC236}">
+                    <a16:creationId xmlns:a16="http://schemas.microsoft.com/office/drawing/2014/main" id="{0B75FC26-1395-A015-3BFF-8BC2C96BB353}"/>
+                  </a:ext>
+                </a:extLst>
+              </p:cNvPr>
+              <p:cNvSpPr txBox="1">
+                <a:spLocks noRot="1" noChangeAspect="1" noMove="1" noResize="1" noEditPoints="1" noAdjustHandles="1" noChangeArrowheads="1" noChangeShapeType="1" noTextEdit="1"/>
+              </p:cNvSpPr>
+              <p:nvPr/>
+            </p:nvSpPr>
+            <p:spPr>
+              <a:xfrm>
+                <a:off x="3047011" y="3782767"/>
+                <a:ext cx="670825" cy="553998"/>
+              </a:xfrm>
+              <a:prstGeom prst="rect">
+                <a:avLst/>
+              </a:prstGeom>
+              <a:blipFill>
+                <a:blip r:embed="rId4"/>
+                <a:stretch>
+                  <a:fillRect/>
+                </a:stretch>
+              </a:blipFill>
+            </p:spPr>
+            <p:txBody>
+              <a:bodyPr/>
+              <a:lstStyle/>
+              <a:p>
+                <a:r>
+                  <a:rPr lang="en-US">
+                    <a:noFill/>
+                  </a:rPr>
+                  <a:t> </a:t>
+                </a:r>
+              </a:p>
+            </p:txBody>
+          </p:sp>
+        </mc:Fallback>
+      </mc:AlternateContent>
+      <mc:AlternateContent xmlns:mc="http://schemas.openxmlformats.org/markup-compatibility/2006">
+        <mc:Choice xmlns:a14="http://schemas.microsoft.com/office/drawing/2010/main" Requires="a14">
+          <p:sp>
+            <p:nvSpPr>
+              <p:cNvPr id="28" name="TextBox 27">
+                <a:extLst>
+                  <a:ext uri="{FF2B5EF4-FFF2-40B4-BE49-F238E27FC236}">
+                    <a16:creationId xmlns:a16="http://schemas.microsoft.com/office/drawing/2014/main" id="{EFE64C12-1B5B-B94B-B5EC-610A98BAEF18}"/>
+                  </a:ext>
+                </a:extLst>
+              </p:cNvPr>
+              <p:cNvSpPr txBox="1"/>
+              <p:nvPr/>
+            </p:nvSpPr>
+            <p:spPr>
+              <a:xfrm rot="5400000">
+                <a:off x="3130579" y="3365048"/>
+                <a:ext cx="542328" cy="281937"/>
+              </a:xfrm>
+              <a:prstGeom prst="rect">
+                <a:avLst/>
+              </a:prstGeom>
+              <a:noFill/>
+            </p:spPr>
+            <p:txBody>
+              <a:bodyPr wrap="none" lIns="0" tIns="0" rIns="0" bIns="0" rtlCol="0">
+                <a:spAutoFit/>
+              </a:bodyPr>
+              <a:lstStyle/>
+              <a:p>
+                <a14:m>
+                  <m:oMathPara xmlns:m="http://schemas.openxmlformats.org/officeDocument/2006/math">
+                    <m:oMathParaPr>
+                      <m:jc m:val="centerGroup"/>
+                    </m:oMathParaPr>
+                    <m:oMath xmlns:m="http://schemas.openxmlformats.org/officeDocument/2006/math">
+                      <m:sSup>
+                        <m:sSupPr>
+                          <m:ctrlPr>
+                            <a:rPr lang="en-US" b="0" i="1" smtClean="0">
+                              <a:latin typeface="Cambria Math" panose="02040503050406030204" pitchFamily="18" charset="0"/>
+                            </a:rPr>
+                          </m:ctrlPr>
+                        </m:sSupPr>
+                        <m:e>
+                          <m:r>
+                            <a:rPr lang="en-US" b="0" i="1" smtClean="0">
+                              <a:latin typeface="Cambria Math" panose="02040503050406030204" pitchFamily="18" charset="0"/>
+                            </a:rPr>
+                            <m:t>→</m:t>
+                          </m:r>
+                        </m:e>
+                        <m:sup>
+                          <m:sSub>
+                            <m:sSubPr>
+                              <m:ctrlPr>
+                                <a:rPr lang="en-US" b="0" i="1" smtClean="0">
+                                  <a:latin typeface="Cambria Math" panose="02040503050406030204" pitchFamily="18" charset="0"/>
+                                </a:rPr>
+                              </m:ctrlPr>
+                            </m:sSubPr>
+                            <m:e>
+                              <m:r>
+                                <a:rPr lang="en-US" b="0" i="1" smtClean="0">
+                                  <a:latin typeface="Cambria Math" panose="02040503050406030204" pitchFamily="18" charset="0"/>
+                                </a:rPr>
+                                <m:t>𝑘</m:t>
+                              </m:r>
+                            </m:e>
+                            <m:sub>
+                              <m:r>
+                                <a:rPr lang="en-US" b="0" i="1" smtClean="0">
+                                  <a:latin typeface="Cambria Math" panose="02040503050406030204" pitchFamily="18" charset="0"/>
+                                </a:rPr>
+                                <m:t>1</m:t>
+                              </m:r>
+                              <m:r>
+                                <a:rPr lang="en-US" b="0" i="1" smtClean="0">
+                                  <a:latin typeface="Cambria Math" panose="02040503050406030204" pitchFamily="18" charset="0"/>
+                                </a:rPr>
+                                <m:t>𝑑</m:t>
+                              </m:r>
+                            </m:sub>
+                          </m:sSub>
+                        </m:sup>
+                      </m:sSup>
+                    </m:oMath>
+                  </m:oMathPara>
+                </a14:m>
+                <a:endParaRPr lang="en-US" dirty="0"/>
+              </a:p>
+            </p:txBody>
+          </p:sp>
+        </mc:Choice>
+        <mc:Fallback>
+          <p:sp>
+            <p:nvSpPr>
+              <p:cNvPr id="28" name="TextBox 27">
+                <a:extLst>
+                  <a:ext uri="{FF2B5EF4-FFF2-40B4-BE49-F238E27FC236}">
+                    <a16:creationId xmlns:a16="http://schemas.microsoft.com/office/drawing/2014/main" id="{EFE64C12-1B5B-B94B-B5EC-610A98BAEF18}"/>
+                  </a:ext>
+                </a:extLst>
+              </p:cNvPr>
+              <p:cNvSpPr txBox="1">
+                <a:spLocks noRot="1" noChangeAspect="1" noMove="1" noResize="1" noEditPoints="1" noAdjustHandles="1" noChangeArrowheads="1" noChangeShapeType="1" noTextEdit="1"/>
+              </p:cNvSpPr>
+              <p:nvPr/>
+            </p:nvSpPr>
+            <p:spPr>
+              <a:xfrm rot="5400000">
+                <a:off x="3130579" y="3365048"/>
+                <a:ext cx="542328" cy="281937"/>
+              </a:xfrm>
+              <a:prstGeom prst="rect">
+                <a:avLst/>
+              </a:prstGeom>
+              <a:blipFill>
+                <a:blip r:embed="rId5"/>
+                <a:stretch>
+                  <a:fillRect t="-4545" r="-4348" b="-2273"/>
+                </a:stretch>
+              </a:blipFill>
+            </p:spPr>
+            <p:txBody>
+              <a:bodyPr/>
+              <a:lstStyle/>
+              <a:p>
+                <a:r>
+                  <a:rPr lang="en-US">
+                    <a:noFill/>
+                  </a:rPr>
+                  <a:t> </a:t>
+                </a:r>
+              </a:p>
+            </p:txBody>
+          </p:sp>
+        </mc:Fallback>
+      </mc:AlternateContent>
+      <mc:AlternateContent xmlns:mc="http://schemas.openxmlformats.org/markup-compatibility/2006">
+        <mc:Choice xmlns:a14="http://schemas.microsoft.com/office/drawing/2010/main" Requires="a14">
+          <p:sp>
+            <p:nvSpPr>
+              <p:cNvPr id="29" name="TextBox 28">
+                <a:extLst>
+                  <a:ext uri="{FF2B5EF4-FFF2-40B4-BE49-F238E27FC236}">
+                    <a16:creationId xmlns:a16="http://schemas.microsoft.com/office/drawing/2014/main" id="{C124B3D4-7CDF-7A56-299F-1DB2F557D06A}"/>
+                  </a:ext>
+                </a:extLst>
+              </p:cNvPr>
+              <p:cNvSpPr txBox="1"/>
+              <p:nvPr/>
+            </p:nvSpPr>
+            <p:spPr>
+              <a:xfrm>
+                <a:off x="4620436" y="3799240"/>
+                <a:ext cx="670825" cy="553998"/>
+              </a:xfrm>
+              <a:prstGeom prst="rect">
+                <a:avLst/>
+              </a:prstGeom>
+              <a:noFill/>
+            </p:spPr>
+            <p:txBody>
+              <a:bodyPr wrap="none" lIns="0" tIns="0" rIns="0" bIns="0" rtlCol="0">
+                <a:spAutoFit/>
+              </a:bodyPr>
+              <a:lstStyle/>
+              <a:p>
+                <a14:m>
+                  <m:oMathPara xmlns:m="http://schemas.openxmlformats.org/officeDocument/2006/math">
+                    <m:oMathParaPr>
+                      <m:jc m:val="centerGroup"/>
+                    </m:oMathParaPr>
+                    <m:oMath xmlns:m="http://schemas.openxmlformats.org/officeDocument/2006/math">
+                      <m:r>
+                        <a:rPr lang="en-US" b="0" i="1" smtClean="0">
+                          <a:latin typeface="Cambria Math" panose="02040503050406030204" pitchFamily="18" charset="0"/>
+                        </a:rPr>
+                        <m:t>∅</m:t>
+                      </m:r>
+                    </m:oMath>
+                  </m:oMathPara>
+                </a14:m>
+                <a:endParaRPr lang="en-US" b="0" dirty="0"/>
+              </a:p>
+              <a:p>
+                <a:endParaRPr lang="en-US" dirty="0"/>
+              </a:p>
+            </p:txBody>
+          </p:sp>
+        </mc:Choice>
+        <mc:Fallback>
+          <p:sp>
+            <p:nvSpPr>
+              <p:cNvPr id="29" name="TextBox 28">
+                <a:extLst>
+                  <a:ext uri="{FF2B5EF4-FFF2-40B4-BE49-F238E27FC236}">
+                    <a16:creationId xmlns:a16="http://schemas.microsoft.com/office/drawing/2014/main" id="{C124B3D4-7CDF-7A56-299F-1DB2F557D06A}"/>
+                  </a:ext>
+                </a:extLst>
+              </p:cNvPr>
+              <p:cNvSpPr txBox="1">
+                <a:spLocks noRot="1" noChangeAspect="1" noMove="1" noResize="1" noEditPoints="1" noAdjustHandles="1" noChangeArrowheads="1" noChangeShapeType="1" noTextEdit="1"/>
+              </p:cNvSpPr>
+              <p:nvPr/>
+            </p:nvSpPr>
+            <p:spPr>
+              <a:xfrm>
+                <a:off x="4620436" y="3799240"/>
+                <a:ext cx="670825" cy="553998"/>
+              </a:xfrm>
+              <a:prstGeom prst="rect">
+                <a:avLst/>
+              </a:prstGeom>
+              <a:blipFill>
+                <a:blip r:embed="rId6"/>
+                <a:stretch>
+                  <a:fillRect/>
+                </a:stretch>
+              </a:blipFill>
+            </p:spPr>
+            <p:txBody>
+              <a:bodyPr/>
+              <a:lstStyle/>
+              <a:p>
+                <a:r>
+                  <a:rPr lang="en-US">
+                    <a:noFill/>
+                  </a:rPr>
+                  <a:t> </a:t>
+                </a:r>
+              </a:p>
+            </p:txBody>
+          </p:sp>
+        </mc:Fallback>
+      </mc:AlternateContent>
+      <mc:AlternateContent xmlns:mc="http://schemas.openxmlformats.org/markup-compatibility/2006">
+        <mc:Choice xmlns:a14="http://schemas.microsoft.com/office/drawing/2010/main" Requires="a14">
+          <p:sp>
+            <p:nvSpPr>
+              <p:cNvPr id="30" name="TextBox 29">
+                <a:extLst>
+                  <a:ext uri="{FF2B5EF4-FFF2-40B4-BE49-F238E27FC236}">
+                    <a16:creationId xmlns:a16="http://schemas.microsoft.com/office/drawing/2014/main" id="{03CD3CC7-7895-3480-08EC-1FFEBE1F3F70}"/>
+                  </a:ext>
+                </a:extLst>
+              </p:cNvPr>
+              <p:cNvSpPr txBox="1"/>
+              <p:nvPr/>
+            </p:nvSpPr>
+            <p:spPr>
+              <a:xfrm rot="5400000">
+                <a:off x="4751293" y="3430949"/>
+                <a:ext cx="447750" cy="281937"/>
+              </a:xfrm>
+              <a:prstGeom prst="rect">
+                <a:avLst/>
+              </a:prstGeom>
+              <a:noFill/>
+            </p:spPr>
+            <p:txBody>
+              <a:bodyPr wrap="none" lIns="0" tIns="0" rIns="0" bIns="0" rtlCol="0">
+                <a:spAutoFit/>
+              </a:bodyPr>
+              <a:lstStyle/>
+              <a:p>
+                <a14:m>
+                  <m:oMathPara xmlns:m="http://schemas.openxmlformats.org/officeDocument/2006/math">
+                    <m:oMathParaPr>
+                      <m:jc m:val="centerGroup"/>
+                    </m:oMathParaPr>
+                    <m:oMath xmlns:m="http://schemas.openxmlformats.org/officeDocument/2006/math">
+                      <m:sSup>
+                        <m:sSupPr>
+                          <m:ctrlPr>
+                            <a:rPr lang="en-US" b="0" i="1" smtClean="0">
+                              <a:latin typeface="Cambria Math" panose="02040503050406030204" pitchFamily="18" charset="0"/>
+                            </a:rPr>
+                          </m:ctrlPr>
+                        </m:sSupPr>
+                        <m:e>
+                          <m:r>
+                            <a:rPr lang="en-US" b="0" i="1" smtClean="0">
+                              <a:latin typeface="Cambria Math" panose="02040503050406030204" pitchFamily="18" charset="0"/>
+                            </a:rPr>
+                            <m:t>→</m:t>
+                          </m:r>
+                        </m:e>
+                        <m:sup>
+                          <m:sSub>
+                            <m:sSubPr>
+                              <m:ctrlPr>
+                                <a:rPr lang="en-US" b="0" i="1" smtClean="0">
+                                  <a:latin typeface="Cambria Math" panose="02040503050406030204" pitchFamily="18" charset="0"/>
+                                </a:rPr>
+                              </m:ctrlPr>
+                            </m:sSubPr>
+                            <m:e>
+                              <m:r>
+                                <a:rPr lang="en-US" b="0" i="1" smtClean="0">
+                                  <a:latin typeface="Cambria Math" panose="02040503050406030204" pitchFamily="18" charset="0"/>
+                                </a:rPr>
+                                <m:t>𝑘</m:t>
+                              </m:r>
+                            </m:e>
+                            <m:sub>
+                              <m:r>
+                                <a:rPr lang="en-US" b="0" i="1" smtClean="0">
+                                  <a:latin typeface="Cambria Math" panose="02040503050406030204" pitchFamily="18" charset="0"/>
+                                </a:rPr>
+                                <m:t>3</m:t>
+                              </m:r>
+                            </m:sub>
+                          </m:sSub>
+                        </m:sup>
+                      </m:sSup>
+                    </m:oMath>
+                  </m:oMathPara>
+                </a14:m>
+                <a:endParaRPr lang="en-US" dirty="0"/>
+              </a:p>
+            </p:txBody>
+          </p:sp>
+        </mc:Choice>
+        <mc:Fallback>
+          <p:sp>
+            <p:nvSpPr>
+              <p:cNvPr id="30" name="TextBox 29">
+                <a:extLst>
+                  <a:ext uri="{FF2B5EF4-FFF2-40B4-BE49-F238E27FC236}">
+                    <a16:creationId xmlns:a16="http://schemas.microsoft.com/office/drawing/2014/main" id="{03CD3CC7-7895-3480-08EC-1FFEBE1F3F70}"/>
+                  </a:ext>
+                </a:extLst>
+              </p:cNvPr>
+              <p:cNvSpPr txBox="1">
+                <a:spLocks noRot="1" noChangeAspect="1" noMove="1" noResize="1" noEditPoints="1" noAdjustHandles="1" noChangeArrowheads="1" noChangeShapeType="1" noTextEdit="1"/>
+              </p:cNvSpPr>
+              <p:nvPr/>
+            </p:nvSpPr>
+            <p:spPr>
+              <a:xfrm rot="5400000">
+                <a:off x="4751293" y="3430949"/>
+                <a:ext cx="447750" cy="281937"/>
+              </a:xfrm>
+              <a:prstGeom prst="rect">
+                <a:avLst/>
+              </a:prstGeom>
+              <a:blipFill>
+                <a:blip r:embed="rId7"/>
+                <a:stretch>
+                  <a:fillRect t="-5405" r="-8696"/>
+                </a:stretch>
+              </a:blipFill>
+            </p:spPr>
+            <p:txBody>
+              <a:bodyPr/>
+              <a:lstStyle/>
+              <a:p>
+                <a:r>
+                  <a:rPr lang="en-US">
+                    <a:noFill/>
+                  </a:rPr>
+                  <a:t> </a:t>
+                </a:r>
+              </a:p>
+            </p:txBody>
+          </p:sp>
+        </mc:Fallback>
+      </mc:AlternateContent>
+    </p:spTree>
+    <p:extLst>
+      <p:ext uri="{BB962C8B-B14F-4D97-AF65-F5344CB8AC3E}">
+        <p14:creationId xmlns:p14="http://schemas.microsoft.com/office/powerpoint/2010/main" val="187463409"/>
+      </p:ext>
+    </p:extLst>
+  </p:cSld>
+  <p:clrMapOvr>
+    <a:masterClrMapping/>
+  </p:clrMapOvr>
+</p:sld>
+</file>
+
+<file path=ppt/slides/slide4.xml><?xml version="1.0" encoding="utf-8"?>
+<p:sld xmlns:a="http://schemas.openxmlformats.org/drawingml/2006/main" xmlns:r="http://schemas.openxmlformats.org/officeDocument/2006/relationships" xmlns:p="http://schemas.openxmlformats.org/presentationml/2006/main">
+  <p:cSld>
+    <p:spTree>
+      <p:nvGrpSpPr>
         <p:cNvPr id="1" name=""/>
         <p:cNvGrpSpPr/>
         <p:nvPr/>
@@ -5693,8 +7045,63 @@
           <a:chExt cx="0" cy="0"/>
         </a:xfrm>
       </p:grpSpPr>
-      <mc:AlternateContent xmlns:mc="http://schemas.openxmlformats.org/markup-compatibility/2006">
-        <mc:Choice xmlns:a14="http://schemas.microsoft.com/office/drawing/2010/main" Requires="a14">
+      <p:sp>
+        <p:nvSpPr>
+          <p:cNvPr id="2" name="Title 1">
+            <a:extLst>
+              <a:ext uri="{FF2B5EF4-FFF2-40B4-BE49-F238E27FC236}">
+                <a16:creationId xmlns:a16="http://schemas.microsoft.com/office/drawing/2014/main" id="{6AD3C062-AEED-94F7-89E4-E3F6C3E0EF80}"/>
+              </a:ext>
+            </a:extLst>
+          </p:cNvPr>
+          <p:cNvSpPr>
+            <a:spLocks noGrp="1"/>
+          </p:cNvSpPr>
+          <p:nvPr>
+            <p:ph type="title"/>
+          </p:nvPr>
+        </p:nvSpPr>
+        <p:spPr/>
+        <p:txBody>
+          <a:bodyPr/>
+          <a:lstStyle/>
+          <a:p>
+            <a:endParaRPr lang="en-US"/>
+          </a:p>
+        </p:txBody>
+      </p:sp>
+    </p:spTree>
+    <p:extLst>
+      <p:ext uri="{BB962C8B-B14F-4D97-AF65-F5344CB8AC3E}">
+        <p14:creationId xmlns:p14="http://schemas.microsoft.com/office/powerpoint/2010/main" val="1731835274"/>
+      </p:ext>
+    </p:extLst>
+  </p:cSld>
+  <p:clrMapOvr>
+    <a:masterClrMapping/>
+  </p:clrMapOvr>
+</p:sld>
+</file>
+
+<file path=ppt/slides/slide5.xml><?xml version="1.0" encoding="utf-8"?>
+<p:sld xmlns:a="http://schemas.openxmlformats.org/drawingml/2006/main" xmlns:r="http://schemas.openxmlformats.org/officeDocument/2006/relationships" xmlns:p="http://schemas.openxmlformats.org/presentationml/2006/main">
+  <p:cSld>
+    <p:spTree>
+      <p:nvGrpSpPr>
+        <p:cNvPr id="1" name=""/>
+        <p:cNvGrpSpPr/>
+        <p:nvPr/>
+      </p:nvGrpSpPr>
+      <p:grpSpPr>
+        <a:xfrm>
+          <a:off x="0" y="0"/>
+          <a:ext cx="0" cy="0"/>
+          <a:chOff x="0" y="0"/>
+          <a:chExt cx="0" cy="0"/>
+        </a:xfrm>
+      </p:grpSpPr>
+      <mc:AlternateContent xmlns:mc="http://schemas.openxmlformats.org/markup-compatibility/2006" xmlns:a14="http://schemas.microsoft.com/office/drawing/2010/main">
+        <mc:Choice Requires="a14">
           <p:sp>
             <p:nvSpPr>
               <p:cNvPr id="33" name="TextBox 32">
@@ -5723,6 +7130,7 @@
               </a:bodyPr>
               <a:lstStyle/>
               <a:p>
+                <a:pPr/>
                 <a14:m>
                   <m:oMathPara xmlns:m="http://schemas.openxmlformats.org/officeDocument/2006/math">
                     <m:oMathParaPr>
@@ -5777,7 +7185,7 @@
             </p:txBody>
           </p:sp>
         </mc:Choice>
-        <mc:Fallback>
+        <mc:Fallback xmlns="">
           <p:sp>
             <p:nvSpPr>
               <p:cNvPr id="33" name="TextBox 32">
@@ -5822,8 +7230,8 @@
           </p:sp>
         </mc:Fallback>
       </mc:AlternateContent>
-      <mc:AlternateContent xmlns:mc="http://schemas.openxmlformats.org/markup-compatibility/2006">
-        <mc:Choice xmlns:a14="http://schemas.microsoft.com/office/drawing/2010/main" Requires="a14">
+      <mc:AlternateContent xmlns:mc="http://schemas.openxmlformats.org/markup-compatibility/2006" xmlns:a14="http://schemas.microsoft.com/office/drawing/2010/main">
+        <mc:Choice Requires="a14">
           <p:sp>
             <p:nvSpPr>
               <p:cNvPr id="35" name="TextBox 34">
@@ -5852,6 +7260,7 @@
               </a:bodyPr>
               <a:lstStyle/>
               <a:p>
+                <a:pPr/>
                 <a14:m>
                   <m:oMathPara xmlns:m="http://schemas.openxmlformats.org/officeDocument/2006/math">
                     <m:oMathParaPr>
@@ -5922,7 +7331,7 @@
             </p:txBody>
           </p:sp>
         </mc:Choice>
-        <mc:Fallback>
+        <mc:Fallback xmlns="">
           <p:sp>
             <p:nvSpPr>
               <p:cNvPr id="35" name="TextBox 34">
@@ -6012,8 +7421,8 @@
           </a:fontRef>
         </p:style>
       </p:cxnSp>
-      <mc:AlternateContent xmlns:mc="http://schemas.openxmlformats.org/markup-compatibility/2006">
-        <mc:Choice xmlns:a14="http://schemas.microsoft.com/office/drawing/2010/main" Requires="a14">
+      <mc:AlternateContent xmlns:mc="http://schemas.openxmlformats.org/markup-compatibility/2006" xmlns:a14="http://schemas.microsoft.com/office/drawing/2010/main">
+        <mc:Choice Requires="a14">
           <p:sp>
             <p:nvSpPr>
               <p:cNvPr id="37" name="TextBox 36">
@@ -6042,6 +7451,7 @@
               </a:bodyPr>
               <a:lstStyle/>
               <a:p>
+                <a:pPr/>
                 <a14:m>
                   <m:oMathPara xmlns:m="http://schemas.openxmlformats.org/officeDocument/2006/math">
                     <m:oMathParaPr>
@@ -6081,7 +7491,7 @@
             </p:txBody>
           </p:sp>
         </mc:Choice>
-        <mc:Fallback>
+        <mc:Fallback xmlns="">
           <p:sp>
             <p:nvSpPr>
               <p:cNvPr id="37" name="TextBox 36">
@@ -6126,8 +7536,8 @@
           </p:sp>
         </mc:Fallback>
       </mc:AlternateContent>
-      <mc:AlternateContent xmlns:mc="http://schemas.openxmlformats.org/markup-compatibility/2006">
-        <mc:Choice xmlns:a14="http://schemas.microsoft.com/office/drawing/2010/main" Requires="a14">
+      <mc:AlternateContent xmlns:mc="http://schemas.openxmlformats.org/markup-compatibility/2006" xmlns:a14="http://schemas.microsoft.com/office/drawing/2010/main">
+        <mc:Choice Requires="a14">
           <p:sp>
             <p:nvSpPr>
               <p:cNvPr id="54" name="TextBox 53">
@@ -6156,6 +7566,7 @@
               </a:bodyPr>
               <a:lstStyle/>
               <a:p>
+                <a:pPr/>
                 <a14:m>
                   <m:oMathPara xmlns:m="http://schemas.openxmlformats.org/officeDocument/2006/math">
                     <m:oMathParaPr>
@@ -6226,7 +7637,7 @@
             </p:txBody>
           </p:sp>
         </mc:Choice>
-        <mc:Fallback>
+        <mc:Fallback xmlns="">
           <p:sp>
             <p:nvSpPr>
               <p:cNvPr id="54" name="TextBox 53">
@@ -6363,8 +7774,8 @@
           </a:p>
         </p:txBody>
       </p:sp>
-      <mc:AlternateContent xmlns:mc="http://schemas.openxmlformats.org/markup-compatibility/2006">
-        <mc:Choice xmlns:a14="http://schemas.microsoft.com/office/drawing/2010/main" Requires="a14">
+      <mc:AlternateContent xmlns:mc="http://schemas.openxmlformats.org/markup-compatibility/2006" xmlns:a14="http://schemas.microsoft.com/office/drawing/2010/main">
+        <mc:Choice Requires="a14">
           <p:sp>
             <p:nvSpPr>
               <p:cNvPr id="66" name="TextBox 65">
@@ -6393,6 +7804,7 @@
               </a:bodyPr>
               <a:lstStyle/>
               <a:p>
+                <a:pPr/>
                 <a14:m>
                   <m:oMathPara xmlns:m="http://schemas.openxmlformats.org/officeDocument/2006/math">
                     <m:oMathParaPr>
@@ -6432,7 +7844,7 @@
             </p:txBody>
           </p:sp>
         </mc:Choice>
-        <mc:Fallback>
+        <mc:Fallback xmlns="">
           <p:sp>
             <p:nvSpPr>
               <p:cNvPr id="66" name="TextBox 65">
@@ -6477,8 +7889,8 @@
           </p:sp>
         </mc:Fallback>
       </mc:AlternateContent>
-      <mc:AlternateContent xmlns:mc="http://schemas.openxmlformats.org/markup-compatibility/2006">
-        <mc:Choice xmlns:a14="http://schemas.microsoft.com/office/drawing/2010/main" Requires="a14">
+      <mc:AlternateContent xmlns:mc="http://schemas.openxmlformats.org/markup-compatibility/2006" xmlns:a14="http://schemas.microsoft.com/office/drawing/2010/main">
+        <mc:Choice Requires="a14">
           <p:sp>
             <p:nvSpPr>
               <p:cNvPr id="68" name="TextBox 67">
@@ -6507,6 +7919,7 @@
               </a:bodyPr>
               <a:lstStyle/>
               <a:p>
+                <a:pPr/>
                 <a14:m>
                   <m:oMathPara xmlns:m="http://schemas.openxmlformats.org/officeDocument/2006/math">
                     <m:oMathParaPr>
@@ -6546,7 +7959,7 @@
             </p:txBody>
           </p:sp>
         </mc:Choice>
-        <mc:Fallback>
+        <mc:Fallback xmlns="">
           <p:sp>
             <p:nvSpPr>
               <p:cNvPr id="68" name="TextBox 67">
@@ -6682,8 +8095,8 @@
           </a:fontRef>
         </p:style>
       </p:cxnSp>
-      <mc:AlternateContent xmlns:mc="http://schemas.openxmlformats.org/markup-compatibility/2006">
-        <mc:Choice xmlns:a14="http://schemas.microsoft.com/office/drawing/2010/main" Requires="a14">
+      <mc:AlternateContent xmlns:mc="http://schemas.openxmlformats.org/markup-compatibility/2006" xmlns:a14="http://schemas.microsoft.com/office/drawing/2010/main">
+        <mc:Choice Requires="a14">
           <p:sp>
             <p:nvSpPr>
               <p:cNvPr id="76" name="TextBox 75">
@@ -6712,6 +8125,7 @@
               </a:bodyPr>
               <a:lstStyle/>
               <a:p>
+                <a:pPr/>
                 <a14:m>
                   <m:oMathPara xmlns:m="http://schemas.openxmlformats.org/officeDocument/2006/math">
                     <m:oMathParaPr>
@@ -6751,7 +8165,7 @@
             </p:txBody>
           </p:sp>
         </mc:Choice>
-        <mc:Fallback>
+        <mc:Fallback xmlns="">
           <p:sp>
             <p:nvSpPr>
               <p:cNvPr id="76" name="TextBox 75">
@@ -6796,8 +8210,8 @@
           </p:sp>
         </mc:Fallback>
       </mc:AlternateContent>
-      <mc:AlternateContent xmlns:mc="http://schemas.openxmlformats.org/markup-compatibility/2006">
-        <mc:Choice xmlns:a14="http://schemas.microsoft.com/office/drawing/2010/main" Requires="a14">
+      <mc:AlternateContent xmlns:mc="http://schemas.openxmlformats.org/markup-compatibility/2006" xmlns:a14="http://schemas.microsoft.com/office/drawing/2010/main">
+        <mc:Choice Requires="a14">
           <p:sp>
             <p:nvSpPr>
               <p:cNvPr id="77" name="TextBox 76">
@@ -6826,6 +8240,7 @@
               </a:bodyPr>
               <a:lstStyle/>
               <a:p>
+                <a:pPr/>
                 <a14:m>
                   <m:oMathPara xmlns:m="http://schemas.openxmlformats.org/officeDocument/2006/math">
                     <m:oMathParaPr>
@@ -6871,7 +8286,7 @@
             </p:txBody>
           </p:sp>
         </mc:Choice>
-        <mc:Fallback>
+        <mc:Fallback xmlns="">
           <p:sp>
             <p:nvSpPr>
               <p:cNvPr id="77" name="TextBox 76">
@@ -6961,8 +8376,8 @@
           </a:fontRef>
         </p:style>
       </p:cxnSp>
-      <mc:AlternateContent xmlns:mc="http://schemas.openxmlformats.org/markup-compatibility/2006">
-        <mc:Choice xmlns:a14="http://schemas.microsoft.com/office/drawing/2010/main" Requires="a14">
+      <mc:AlternateContent xmlns:mc="http://schemas.openxmlformats.org/markup-compatibility/2006" xmlns:a14="http://schemas.microsoft.com/office/drawing/2010/main">
+        <mc:Choice Requires="a14">
           <p:sp>
             <p:nvSpPr>
               <p:cNvPr id="83" name="TextBox 82">
@@ -6991,6 +8406,7 @@
               </a:bodyPr>
               <a:lstStyle/>
               <a:p>
+                <a:pPr/>
                 <a14:m>
                   <m:oMathPara xmlns:m="http://schemas.openxmlformats.org/officeDocument/2006/math">
                     <m:oMathParaPr>
@@ -7012,7 +8428,7 @@
             </p:txBody>
           </p:sp>
         </mc:Choice>
-        <mc:Fallback>
+        <mc:Fallback xmlns="">
           <p:sp>
             <p:nvSpPr>
               <p:cNvPr id="83" name="TextBox 82">
@@ -7085,8 +8501,8 @@
           </a:p>
         </p:txBody>
       </p:sp>
-      <mc:AlternateContent xmlns:mc="http://schemas.openxmlformats.org/markup-compatibility/2006">
-        <mc:Choice xmlns:a14="http://schemas.microsoft.com/office/drawing/2010/main" Requires="a14">
+      <mc:AlternateContent xmlns:mc="http://schemas.openxmlformats.org/markup-compatibility/2006" xmlns:a14="http://schemas.microsoft.com/office/drawing/2010/main">
+        <mc:Choice Requires="a14">
           <p:sp>
             <p:nvSpPr>
               <p:cNvPr id="2" name="TextBox 1">
@@ -7115,6 +8531,7 @@
               </a:bodyPr>
               <a:lstStyle/>
               <a:p>
+                <a:pPr/>
                 <a14:m>
                   <m:oMathPara xmlns:m="http://schemas.openxmlformats.org/officeDocument/2006/math">
                     <m:oMathParaPr>
@@ -7154,7 +8571,7 @@
             </p:txBody>
           </p:sp>
         </mc:Choice>
-        <mc:Fallback>
+        <mc:Fallback xmlns="">
           <p:sp>
             <p:nvSpPr>
               <p:cNvPr id="2" name="TextBox 1">
@@ -7199,8 +8616,8 @@
           </p:sp>
         </mc:Fallback>
       </mc:AlternateContent>
-      <mc:AlternateContent xmlns:mc="http://schemas.openxmlformats.org/markup-compatibility/2006">
-        <mc:Choice xmlns:a14="http://schemas.microsoft.com/office/drawing/2010/main" Requires="a14">
+      <mc:AlternateContent xmlns:mc="http://schemas.openxmlformats.org/markup-compatibility/2006" xmlns:a14="http://schemas.microsoft.com/office/drawing/2010/main">
+        <mc:Choice Requires="a14">
           <p:sp>
             <p:nvSpPr>
               <p:cNvPr id="3" name="TextBox 2">
@@ -7229,6 +8646,7 @@
               </a:bodyPr>
               <a:lstStyle/>
               <a:p>
+                <a:pPr/>
                 <a14:m>
                   <m:oMathPara xmlns:m="http://schemas.openxmlformats.org/officeDocument/2006/math">
                     <m:oMathParaPr>
@@ -7279,7 +8697,7 @@
             </p:txBody>
           </p:sp>
         </mc:Choice>
-        <mc:Fallback>
+        <mc:Fallback xmlns="">
           <p:sp>
             <p:nvSpPr>
               <p:cNvPr id="3" name="TextBox 2">
@@ -7324,8 +8742,8 @@
           </p:sp>
         </mc:Fallback>
       </mc:AlternateContent>
-      <mc:AlternateContent xmlns:mc="http://schemas.openxmlformats.org/markup-compatibility/2006">
-        <mc:Choice xmlns:a14="http://schemas.microsoft.com/office/drawing/2010/main" Requires="a14">
+      <mc:AlternateContent xmlns:mc="http://schemas.openxmlformats.org/markup-compatibility/2006" xmlns:a14="http://schemas.microsoft.com/office/drawing/2010/main">
+        <mc:Choice Requires="a14">
           <p:sp>
             <p:nvSpPr>
               <p:cNvPr id="5" name="TextBox 4">
@@ -7354,6 +8772,7 @@
               </a:bodyPr>
               <a:lstStyle/>
               <a:p>
+                <a:pPr/>
                 <a14:m>
                   <m:oMathPara xmlns:m="http://schemas.openxmlformats.org/officeDocument/2006/math">
                     <m:oMathParaPr>
@@ -7393,7 +8812,7 @@
             </p:txBody>
           </p:sp>
         </mc:Choice>
-        <mc:Fallback>
+        <mc:Fallback xmlns="">
           <p:sp>
             <p:nvSpPr>
               <p:cNvPr id="5" name="TextBox 4">
@@ -7503,8 +8922,8 @@
             </a:fontRef>
           </p:style>
         </p:cxnSp>
-        <mc:AlternateContent xmlns:mc="http://schemas.openxmlformats.org/markup-compatibility/2006">
-          <mc:Choice xmlns:a14="http://schemas.microsoft.com/office/drawing/2010/main" Requires="a14">
+        <mc:AlternateContent xmlns:mc="http://schemas.openxmlformats.org/markup-compatibility/2006" xmlns:a14="http://schemas.microsoft.com/office/drawing/2010/main">
+          <mc:Choice Requires="a14">
             <p:sp>
               <p:nvSpPr>
                 <p:cNvPr id="8" name="TextBox 7">
@@ -7533,6 +8952,7 @@
                 </a:bodyPr>
                 <a:lstStyle/>
                 <a:p>
+                  <a:pPr/>
                   <a14:m>
                     <m:oMathPara xmlns:m="http://schemas.openxmlformats.org/officeDocument/2006/math">
                       <m:oMathParaPr>
@@ -7554,7 +8974,7 @@
               </p:txBody>
             </p:sp>
           </mc:Choice>
-          <mc:Fallback>
+          <mc:Fallback xmlns="">
             <p:sp>
               <p:nvSpPr>
                 <p:cNvPr id="8" name="TextBox 7">
@@ -7599,8 +9019,8 @@
             </p:sp>
           </mc:Fallback>
         </mc:AlternateContent>
-        <mc:AlternateContent xmlns:mc="http://schemas.openxmlformats.org/markup-compatibility/2006">
-          <mc:Choice xmlns:a14="http://schemas.microsoft.com/office/drawing/2010/main" Requires="a14">
+        <mc:AlternateContent xmlns:mc="http://schemas.openxmlformats.org/markup-compatibility/2006" xmlns:a14="http://schemas.microsoft.com/office/drawing/2010/main">
+          <mc:Choice Requires="a14">
             <p:sp>
               <p:nvSpPr>
                 <p:cNvPr id="10" name="TextBox 9">
@@ -7629,6 +9049,7 @@
                 </a:bodyPr>
                 <a:lstStyle/>
                 <a:p>
+                  <a:pPr/>
                   <a14:m>
                     <m:oMathPara xmlns:m="http://schemas.openxmlformats.org/officeDocument/2006/math">
                       <m:oMathParaPr>
@@ -7679,7 +9100,7 @@
               </p:txBody>
             </p:sp>
           </mc:Choice>
-          <mc:Fallback>
+          <mc:Fallback xmlns="">
             <p:sp>
               <p:nvSpPr>
                 <p:cNvPr id="10" name="TextBox 9">
@@ -7769,8 +9190,8 @@
           </a:fontRef>
         </p:style>
       </p:cxnSp>
-      <mc:AlternateContent xmlns:mc="http://schemas.openxmlformats.org/markup-compatibility/2006">
-        <mc:Choice xmlns:a14="http://schemas.microsoft.com/office/drawing/2010/main" Requires="a14">
+      <mc:AlternateContent xmlns:mc="http://schemas.openxmlformats.org/markup-compatibility/2006" xmlns:a14="http://schemas.microsoft.com/office/drawing/2010/main">
+        <mc:Choice Requires="a14">
           <p:sp>
             <p:nvSpPr>
               <p:cNvPr id="13" name="TextBox 12">
@@ -7799,6 +9220,7 @@
               </a:bodyPr>
               <a:lstStyle/>
               <a:p>
+                <a:pPr/>
                 <a14:m>
                   <m:oMathPara xmlns:m="http://schemas.openxmlformats.org/officeDocument/2006/math">
                     <m:oMathParaPr>
@@ -7838,7 +9260,7 @@
             </p:txBody>
           </p:sp>
         </mc:Choice>
-        <mc:Fallback>
+        <mc:Fallback xmlns="">
           <p:sp>
             <p:nvSpPr>
               <p:cNvPr id="13" name="TextBox 12">
@@ -8125,8 +9547,8 @@
             </a:fontRef>
           </p:style>
         </p:cxnSp>
-        <mc:AlternateContent xmlns:mc="http://schemas.openxmlformats.org/markup-compatibility/2006">
-          <mc:Choice xmlns:a14="http://schemas.microsoft.com/office/drawing/2010/main" Requires="a14">
+        <mc:AlternateContent xmlns:mc="http://schemas.openxmlformats.org/markup-compatibility/2006" xmlns:a14="http://schemas.microsoft.com/office/drawing/2010/main">
+          <mc:Choice Requires="a14">
             <p:sp>
               <p:nvSpPr>
                 <p:cNvPr id="21" name="TextBox 20">
@@ -8155,6 +9577,7 @@
                 </a:bodyPr>
                 <a:lstStyle/>
                 <a:p>
+                  <a:pPr/>
                   <a14:m>
                     <m:oMathPara xmlns:m="http://schemas.openxmlformats.org/officeDocument/2006/math">
                       <m:oMathParaPr>
@@ -8176,7 +9599,7 @@
               </p:txBody>
             </p:sp>
           </mc:Choice>
-          <mc:Fallback>
+          <mc:Fallback xmlns="">
             <p:sp>
               <p:nvSpPr>
                 <p:cNvPr id="21" name="TextBox 20">
@@ -8221,8 +9644,8 @@
             </p:sp>
           </mc:Fallback>
         </mc:AlternateContent>
-        <mc:AlternateContent xmlns:mc="http://schemas.openxmlformats.org/markup-compatibility/2006">
-          <mc:Choice xmlns:a14="http://schemas.microsoft.com/office/drawing/2010/main" Requires="a14">
+        <mc:AlternateContent xmlns:mc="http://schemas.openxmlformats.org/markup-compatibility/2006" xmlns:a14="http://schemas.microsoft.com/office/drawing/2010/main">
+          <mc:Choice Requires="a14">
             <p:sp>
               <p:nvSpPr>
                 <p:cNvPr id="22" name="TextBox 21">
@@ -8251,6 +9674,7 @@
                 </a:bodyPr>
                 <a:lstStyle/>
                 <a:p>
+                  <a:pPr/>
                   <a14:m>
                     <m:oMathPara xmlns:m="http://schemas.openxmlformats.org/officeDocument/2006/math">
                       <m:oMathParaPr>
@@ -8301,7 +9725,7 @@
               </p:txBody>
             </p:sp>
           </mc:Choice>
-          <mc:Fallback>
+          <mc:Fallback xmlns="">
             <p:sp>
               <p:nvSpPr>
                 <p:cNvPr id="22" name="TextBox 21">
@@ -8360,7 +9784,7 @@
 </p:sld>
 </file>
 
-<file path=ppt/slides/slide4.xml><?xml version="1.0" encoding="utf-8"?>
+<file path=ppt/slides/slide6.xml><?xml version="1.0" encoding="utf-8"?>
 <p:sld xmlns:a="http://schemas.openxmlformats.org/drawingml/2006/main" xmlns:r="http://schemas.openxmlformats.org/officeDocument/2006/relationships" xmlns:p="http://schemas.openxmlformats.org/presentationml/2006/main">
   <p:cSld>
     <p:spTree>
@@ -8513,8 +9937,8 @@
           </a:fontRef>
         </p:style>
       </p:cxnSp>
-      <mc:AlternateContent xmlns:mc="http://schemas.openxmlformats.org/markup-compatibility/2006">
-        <mc:Choice xmlns:a14="http://schemas.microsoft.com/office/drawing/2010/main" Requires="a14">
+      <mc:AlternateContent xmlns:mc="http://schemas.openxmlformats.org/markup-compatibility/2006" xmlns:a14="http://schemas.microsoft.com/office/drawing/2010/main">
+        <mc:Choice Requires="a14">
           <p:sp>
             <p:nvSpPr>
               <p:cNvPr id="28" name="TextBox 27">
@@ -8543,6 +9967,7 @@
               </a:bodyPr>
               <a:lstStyle/>
               <a:p>
+                <a:pPr/>
                 <a14:m>
                   <m:oMathPara xmlns:m="http://schemas.openxmlformats.org/officeDocument/2006/math">
                     <m:oMathParaPr>
@@ -8582,7 +10007,7 @@
             </p:txBody>
           </p:sp>
         </mc:Choice>
-        <mc:Fallback>
+        <mc:Fallback xmlns="">
           <p:sp>
             <p:nvSpPr>
               <p:cNvPr id="28" name="TextBox 27">
@@ -8627,8 +10052,8 @@
           </p:sp>
         </mc:Fallback>
       </mc:AlternateContent>
-      <mc:AlternateContent xmlns:mc="http://schemas.openxmlformats.org/markup-compatibility/2006">
-        <mc:Choice xmlns:a14="http://schemas.microsoft.com/office/drawing/2010/main" Requires="a14">
+      <mc:AlternateContent xmlns:mc="http://schemas.openxmlformats.org/markup-compatibility/2006" xmlns:a14="http://schemas.microsoft.com/office/drawing/2010/main">
+        <mc:Choice Requires="a14">
           <p:sp>
             <p:nvSpPr>
               <p:cNvPr id="33" name="TextBox 32">
@@ -8657,6 +10082,7 @@
               </a:bodyPr>
               <a:lstStyle/>
               <a:p>
+                <a:pPr/>
                 <a14:m>
                   <m:oMathPara xmlns:m="http://schemas.openxmlformats.org/officeDocument/2006/math">
                     <m:oMathParaPr>
@@ -8711,7 +10137,7 @@
             </p:txBody>
           </p:sp>
         </mc:Choice>
-        <mc:Fallback>
+        <mc:Fallback xmlns="">
           <p:sp>
             <p:nvSpPr>
               <p:cNvPr id="33" name="TextBox 32">
@@ -8756,8 +10182,8 @@
           </p:sp>
         </mc:Fallback>
       </mc:AlternateContent>
-      <mc:AlternateContent xmlns:mc="http://schemas.openxmlformats.org/markup-compatibility/2006">
-        <mc:Choice xmlns:a14="http://schemas.microsoft.com/office/drawing/2010/main" Requires="a14">
+      <mc:AlternateContent xmlns:mc="http://schemas.openxmlformats.org/markup-compatibility/2006" xmlns:a14="http://schemas.microsoft.com/office/drawing/2010/main">
+        <mc:Choice Requires="a14">
           <p:sp>
             <p:nvSpPr>
               <p:cNvPr id="34" name="TextBox 33">
@@ -8786,6 +10212,7 @@
               </a:bodyPr>
               <a:lstStyle/>
               <a:p>
+                <a:pPr/>
                 <a14:m>
                   <m:oMathPara xmlns:m="http://schemas.openxmlformats.org/officeDocument/2006/math">
                     <m:oMathParaPr>
@@ -8825,7 +10252,7 @@
             </p:txBody>
           </p:sp>
         </mc:Choice>
-        <mc:Fallback>
+        <mc:Fallback xmlns="">
           <p:sp>
             <p:nvSpPr>
               <p:cNvPr id="34" name="TextBox 33">
@@ -8870,8 +10297,8 @@
           </p:sp>
         </mc:Fallback>
       </mc:AlternateContent>
-      <mc:AlternateContent xmlns:mc="http://schemas.openxmlformats.org/markup-compatibility/2006">
-        <mc:Choice xmlns:a14="http://schemas.microsoft.com/office/drawing/2010/main" Requires="a14">
+      <mc:AlternateContent xmlns:mc="http://schemas.openxmlformats.org/markup-compatibility/2006" xmlns:a14="http://schemas.microsoft.com/office/drawing/2010/main">
+        <mc:Choice Requires="a14">
           <p:sp>
             <p:nvSpPr>
               <p:cNvPr id="35" name="TextBox 34">
@@ -8900,6 +10327,7 @@
               </a:bodyPr>
               <a:lstStyle/>
               <a:p>
+                <a:pPr/>
                 <a14:m>
                   <m:oMathPara xmlns:m="http://schemas.openxmlformats.org/officeDocument/2006/math">
                     <m:oMathParaPr>
@@ -8970,7 +10398,7 @@
             </p:txBody>
           </p:sp>
         </mc:Choice>
-        <mc:Fallback>
+        <mc:Fallback xmlns="">
           <p:sp>
             <p:nvSpPr>
               <p:cNvPr id="35" name="TextBox 34">
@@ -9060,8 +10488,8 @@
           </a:fontRef>
         </p:style>
       </p:cxnSp>
-      <mc:AlternateContent xmlns:mc="http://schemas.openxmlformats.org/markup-compatibility/2006">
-        <mc:Choice xmlns:a14="http://schemas.microsoft.com/office/drawing/2010/main" Requires="a14">
+      <mc:AlternateContent xmlns:mc="http://schemas.openxmlformats.org/markup-compatibility/2006" xmlns:a14="http://schemas.microsoft.com/office/drawing/2010/main">
+        <mc:Choice Requires="a14">
           <p:sp>
             <p:nvSpPr>
               <p:cNvPr id="37" name="TextBox 36">
@@ -9090,6 +10518,7 @@
               </a:bodyPr>
               <a:lstStyle/>
               <a:p>
+                <a:pPr/>
                 <a14:m>
                   <m:oMathPara xmlns:m="http://schemas.openxmlformats.org/officeDocument/2006/math">
                     <m:oMathParaPr>
@@ -9129,7 +10558,7 @@
             </p:txBody>
           </p:sp>
         </mc:Choice>
-        <mc:Fallback>
+        <mc:Fallback xmlns="">
           <p:sp>
             <p:nvSpPr>
               <p:cNvPr id="37" name="TextBox 36">
@@ -9174,8 +10603,8 @@
           </p:sp>
         </mc:Fallback>
       </mc:AlternateContent>
-      <mc:AlternateContent xmlns:mc="http://schemas.openxmlformats.org/markup-compatibility/2006">
-        <mc:Choice xmlns:a14="http://schemas.microsoft.com/office/drawing/2010/main" Requires="a14">
+      <mc:AlternateContent xmlns:mc="http://schemas.openxmlformats.org/markup-compatibility/2006" xmlns:a14="http://schemas.microsoft.com/office/drawing/2010/main">
+        <mc:Choice Requires="a14">
           <p:sp>
             <p:nvSpPr>
               <p:cNvPr id="40" name="TextBox 39">
@@ -9204,6 +10633,7 @@
               </a:bodyPr>
               <a:lstStyle/>
               <a:p>
+                <a:pPr/>
                 <a14:m>
                   <m:oMathPara xmlns:m="http://schemas.openxmlformats.org/officeDocument/2006/math">
                     <m:oMathParaPr>
@@ -9243,7 +10673,7 @@
             </p:txBody>
           </p:sp>
         </mc:Choice>
-        <mc:Fallback>
+        <mc:Fallback xmlns="">
           <p:sp>
             <p:nvSpPr>
               <p:cNvPr id="40" name="TextBox 39">
@@ -9288,8 +10718,8 @@
           </p:sp>
         </mc:Fallback>
       </mc:AlternateContent>
-      <mc:AlternateContent xmlns:mc="http://schemas.openxmlformats.org/markup-compatibility/2006">
-        <mc:Choice xmlns:a14="http://schemas.microsoft.com/office/drawing/2010/main" Requires="a14">
+      <mc:AlternateContent xmlns:mc="http://schemas.openxmlformats.org/markup-compatibility/2006" xmlns:a14="http://schemas.microsoft.com/office/drawing/2010/main">
+        <mc:Choice Requires="a14">
           <p:sp>
             <p:nvSpPr>
               <p:cNvPr id="54" name="TextBox 53">
@@ -9318,6 +10748,7 @@
               </a:bodyPr>
               <a:lstStyle/>
               <a:p>
+                <a:pPr/>
                 <a14:m>
                   <m:oMathPara xmlns:m="http://schemas.openxmlformats.org/officeDocument/2006/math">
                     <m:oMathParaPr>
@@ -9388,7 +10819,7 @@
             </p:txBody>
           </p:sp>
         </mc:Choice>
-        <mc:Fallback>
+        <mc:Fallback xmlns="">
           <p:sp>
             <p:nvSpPr>
               <p:cNvPr id="54" name="TextBox 53">
@@ -9433,8 +10864,8 @@
           </p:sp>
         </mc:Fallback>
       </mc:AlternateContent>
-      <mc:AlternateContent xmlns:mc="http://schemas.openxmlformats.org/markup-compatibility/2006">
-        <mc:Choice xmlns:a14="http://schemas.microsoft.com/office/drawing/2010/main" Requires="a14">
+      <mc:AlternateContent xmlns:mc="http://schemas.openxmlformats.org/markup-compatibility/2006" xmlns:a14="http://schemas.microsoft.com/office/drawing/2010/main">
+        <mc:Choice Requires="a14">
           <p:sp>
             <p:nvSpPr>
               <p:cNvPr id="56" name="TextBox 55">
@@ -9463,6 +10894,7 @@
               </a:bodyPr>
               <a:lstStyle/>
               <a:p>
+                <a:pPr/>
                 <a14:m>
                   <m:oMathPara xmlns:m="http://schemas.openxmlformats.org/officeDocument/2006/math">
                     <m:oMathParaPr>
@@ -9502,7 +10934,7 @@
             </p:txBody>
           </p:sp>
         </mc:Choice>
-        <mc:Fallback>
+        <mc:Fallback xmlns="">
           <p:sp>
             <p:nvSpPr>
               <p:cNvPr id="56" name="TextBox 55">
@@ -9639,8 +11071,8 @@
           </a:p>
         </p:txBody>
       </p:sp>
-      <mc:AlternateContent xmlns:mc="http://schemas.openxmlformats.org/markup-compatibility/2006">
-        <mc:Choice xmlns:a14="http://schemas.microsoft.com/office/drawing/2010/main" Requires="a14">
+      <mc:AlternateContent xmlns:mc="http://schemas.openxmlformats.org/markup-compatibility/2006" xmlns:a14="http://schemas.microsoft.com/office/drawing/2010/main">
+        <mc:Choice Requires="a14">
           <p:sp>
             <p:nvSpPr>
               <p:cNvPr id="66" name="TextBox 65">
@@ -9669,6 +11101,7 @@
               </a:bodyPr>
               <a:lstStyle/>
               <a:p>
+                <a:pPr/>
                 <a14:m>
                   <m:oMathPara xmlns:m="http://schemas.openxmlformats.org/officeDocument/2006/math">
                     <m:oMathParaPr>
@@ -9708,7 +11141,7 @@
             </p:txBody>
           </p:sp>
         </mc:Choice>
-        <mc:Fallback>
+        <mc:Fallback xmlns="">
           <p:sp>
             <p:nvSpPr>
               <p:cNvPr id="66" name="TextBox 65">
@@ -9753,8 +11186,8 @@
           </p:sp>
         </mc:Fallback>
       </mc:AlternateContent>
-      <mc:AlternateContent xmlns:mc="http://schemas.openxmlformats.org/markup-compatibility/2006">
-        <mc:Choice xmlns:a14="http://schemas.microsoft.com/office/drawing/2010/main" Requires="a14">
+      <mc:AlternateContent xmlns:mc="http://schemas.openxmlformats.org/markup-compatibility/2006" xmlns:a14="http://schemas.microsoft.com/office/drawing/2010/main">
+        <mc:Choice Requires="a14">
           <p:sp>
             <p:nvSpPr>
               <p:cNvPr id="68" name="TextBox 67">
@@ -9783,6 +11216,7 @@
               </a:bodyPr>
               <a:lstStyle/>
               <a:p>
+                <a:pPr/>
                 <a14:m>
                   <m:oMathPara xmlns:m="http://schemas.openxmlformats.org/officeDocument/2006/math">
                     <m:oMathParaPr>
@@ -9822,7 +11256,7 @@
             </p:txBody>
           </p:sp>
         </mc:Choice>
-        <mc:Fallback>
+        <mc:Fallback xmlns="">
           <p:sp>
             <p:nvSpPr>
               <p:cNvPr id="68" name="TextBox 67">
@@ -9959,8 +11393,8 @@
           </a:fontRef>
         </p:style>
       </p:cxnSp>
-      <mc:AlternateContent xmlns:mc="http://schemas.openxmlformats.org/markup-compatibility/2006">
-        <mc:Choice xmlns:a14="http://schemas.microsoft.com/office/drawing/2010/main" Requires="a14">
+      <mc:AlternateContent xmlns:mc="http://schemas.openxmlformats.org/markup-compatibility/2006" xmlns:a14="http://schemas.microsoft.com/office/drawing/2010/main">
+        <mc:Choice Requires="a14">
           <p:sp>
             <p:nvSpPr>
               <p:cNvPr id="76" name="TextBox 75">
@@ -9989,6 +11423,7 @@
               </a:bodyPr>
               <a:lstStyle/>
               <a:p>
+                <a:pPr/>
                 <a14:m>
                   <m:oMathPara xmlns:m="http://schemas.openxmlformats.org/officeDocument/2006/math">
                     <m:oMathParaPr>
@@ -10028,7 +11463,7 @@
             </p:txBody>
           </p:sp>
         </mc:Choice>
-        <mc:Fallback>
+        <mc:Fallback xmlns="">
           <p:sp>
             <p:nvSpPr>
               <p:cNvPr id="76" name="TextBox 75">
@@ -10073,8 +11508,8 @@
           </p:sp>
         </mc:Fallback>
       </mc:AlternateContent>
-      <mc:AlternateContent xmlns:mc="http://schemas.openxmlformats.org/markup-compatibility/2006">
-        <mc:Choice xmlns:a14="http://schemas.microsoft.com/office/drawing/2010/main" Requires="a14">
+      <mc:AlternateContent xmlns:mc="http://schemas.openxmlformats.org/markup-compatibility/2006" xmlns:a14="http://schemas.microsoft.com/office/drawing/2010/main">
+        <mc:Choice Requires="a14">
           <p:sp>
             <p:nvSpPr>
               <p:cNvPr id="77" name="TextBox 76">
@@ -10103,6 +11538,7 @@
               </a:bodyPr>
               <a:lstStyle/>
               <a:p>
+                <a:pPr/>
                 <a14:m>
                   <m:oMathPara xmlns:m="http://schemas.openxmlformats.org/officeDocument/2006/math">
                     <m:oMathParaPr>
@@ -10142,7 +11578,7 @@
             </p:txBody>
           </p:sp>
         </mc:Choice>
-        <mc:Fallback>
+        <mc:Fallback xmlns="">
           <p:sp>
             <p:nvSpPr>
               <p:cNvPr id="77" name="TextBox 76">
@@ -10233,8 +11669,8 @@
           </a:fontRef>
         </p:style>
       </p:cxnSp>
-      <mc:AlternateContent xmlns:mc="http://schemas.openxmlformats.org/markup-compatibility/2006">
-        <mc:Choice xmlns:a14="http://schemas.microsoft.com/office/drawing/2010/main" Requires="a14">
+      <mc:AlternateContent xmlns:mc="http://schemas.openxmlformats.org/markup-compatibility/2006" xmlns:a14="http://schemas.microsoft.com/office/drawing/2010/main">
+        <mc:Choice Requires="a14">
           <p:sp>
             <p:nvSpPr>
               <p:cNvPr id="83" name="TextBox 82">
@@ -10263,6 +11699,7 @@
               </a:bodyPr>
               <a:lstStyle/>
               <a:p>
+                <a:pPr/>
                 <a14:m>
                   <m:oMathPara xmlns:m="http://schemas.openxmlformats.org/officeDocument/2006/math">
                     <m:oMathParaPr>
@@ -10284,7 +11721,7 @@
             </p:txBody>
           </p:sp>
         </mc:Choice>
-        <mc:Fallback>
+        <mc:Fallback xmlns="">
           <p:sp>
             <p:nvSpPr>
               <p:cNvPr id="83" name="TextBox 82">
@@ -10329,8 +11766,8 @@
           </p:sp>
         </mc:Fallback>
       </mc:AlternateContent>
-      <mc:AlternateContent xmlns:mc="http://schemas.openxmlformats.org/markup-compatibility/2006">
-        <mc:Choice xmlns:a14="http://schemas.microsoft.com/office/drawing/2010/main" Requires="a14">
+      <mc:AlternateContent xmlns:mc="http://schemas.openxmlformats.org/markup-compatibility/2006" xmlns:a14="http://schemas.microsoft.com/office/drawing/2010/main">
+        <mc:Choice Requires="a14">
           <p:sp>
             <p:nvSpPr>
               <p:cNvPr id="84" name="TextBox 83">
@@ -10359,6 +11796,7 @@
               </a:bodyPr>
               <a:lstStyle/>
               <a:p>
+                <a:pPr/>
                 <a14:m>
                   <m:oMathPara xmlns:m="http://schemas.openxmlformats.org/officeDocument/2006/math">
                     <m:oMathParaPr>
@@ -10398,7 +11836,7 @@
             </p:txBody>
           </p:sp>
         </mc:Choice>
-        <mc:Fallback>
+        <mc:Fallback xmlns="">
           <p:sp>
             <p:nvSpPr>
               <p:cNvPr id="84" name="TextBox 83">
@@ -10484,7 +11922,7 @@
 </p:sld>
 </file>
 
-<file path=ppt/slides/slide5.xml><?xml version="1.0" encoding="utf-8"?>
+<file path=ppt/slides/slide7.xml><?xml version="1.0" encoding="utf-8"?>
 <p:sld xmlns:a="http://schemas.openxmlformats.org/drawingml/2006/main" xmlns:r="http://schemas.openxmlformats.org/officeDocument/2006/relationships" xmlns:p="http://schemas.openxmlformats.org/presentationml/2006/main">
   <p:cSld>
     <p:spTree>
@@ -10542,7 +11980,7 @@
 </p:sld>
 </file>
 
-<file path=ppt/slides/slide6.xml><?xml version="1.0" encoding="utf-8"?>
+<file path=ppt/slides/slide8.xml><?xml version="1.0" encoding="utf-8"?>
 <p:sld xmlns:a="http://schemas.openxmlformats.org/drawingml/2006/main" xmlns:r="http://schemas.openxmlformats.org/officeDocument/2006/relationships" xmlns:p="http://schemas.openxmlformats.org/presentationml/2006/main">
   <p:cSld>
     <p:spTree>
@@ -10651,8 +12089,8 @@
           </a:fontRef>
         </p:style>
       </p:cxnSp>
-      <mc:AlternateContent xmlns:mc="http://schemas.openxmlformats.org/markup-compatibility/2006">
-        <mc:Choice xmlns:a14="http://schemas.microsoft.com/office/drawing/2010/main" Requires="a14">
+      <mc:AlternateContent xmlns:mc="http://schemas.openxmlformats.org/markup-compatibility/2006" xmlns:a14="http://schemas.microsoft.com/office/drawing/2010/main">
+        <mc:Choice Requires="a14">
           <p:sp>
             <p:nvSpPr>
               <p:cNvPr id="33" name="TextBox 32">
@@ -10681,6 +12119,7 @@
               </a:bodyPr>
               <a:lstStyle/>
               <a:p>
+                <a:pPr/>
                 <a14:m>
                   <m:oMathPara xmlns:m="http://schemas.openxmlformats.org/officeDocument/2006/math">
                     <m:oMathParaPr>
@@ -10744,7 +12183,7 @@
             </p:txBody>
           </p:sp>
         </mc:Choice>
-        <mc:Fallback>
+        <mc:Fallback xmlns="">
           <p:sp>
             <p:nvSpPr>
               <p:cNvPr id="33" name="TextBox 32">
@@ -10789,8 +12228,8 @@
           </p:sp>
         </mc:Fallback>
       </mc:AlternateContent>
-      <mc:AlternateContent xmlns:mc="http://schemas.openxmlformats.org/markup-compatibility/2006">
-        <mc:Choice xmlns:a14="http://schemas.microsoft.com/office/drawing/2010/main" Requires="a14">
+      <mc:AlternateContent xmlns:mc="http://schemas.openxmlformats.org/markup-compatibility/2006" xmlns:a14="http://schemas.microsoft.com/office/drawing/2010/main">
+        <mc:Choice Requires="a14">
           <p:sp>
             <p:nvSpPr>
               <p:cNvPr id="34" name="TextBox 33">
@@ -10819,6 +12258,7 @@
               </a:bodyPr>
               <a:lstStyle/>
               <a:p>
+                <a:pPr/>
                 <a14:m>
                   <m:oMathPara xmlns:m="http://schemas.openxmlformats.org/officeDocument/2006/math">
                     <m:oMathParaPr>
@@ -10858,7 +12298,7 @@
             </p:txBody>
           </p:sp>
         </mc:Choice>
-        <mc:Fallback>
+        <mc:Fallback xmlns="">
           <p:sp>
             <p:nvSpPr>
               <p:cNvPr id="34" name="TextBox 33">
@@ -10903,8 +12343,8 @@
           </p:sp>
         </mc:Fallback>
       </mc:AlternateContent>
-      <mc:AlternateContent xmlns:mc="http://schemas.openxmlformats.org/markup-compatibility/2006">
-        <mc:Choice xmlns:a14="http://schemas.microsoft.com/office/drawing/2010/main" Requires="a14">
+      <mc:AlternateContent xmlns:mc="http://schemas.openxmlformats.org/markup-compatibility/2006" xmlns:a14="http://schemas.microsoft.com/office/drawing/2010/main">
+        <mc:Choice Requires="a14">
           <p:sp>
             <p:nvSpPr>
               <p:cNvPr id="35" name="TextBox 34">
@@ -10933,6 +12373,7 @@
               </a:bodyPr>
               <a:lstStyle/>
               <a:p>
+                <a:pPr/>
                 <a14:m>
                   <m:oMathPara xmlns:m="http://schemas.openxmlformats.org/officeDocument/2006/math">
                     <m:oMathParaPr>
@@ -11012,7 +12453,7 @@
             </p:txBody>
           </p:sp>
         </mc:Choice>
-        <mc:Fallback>
+        <mc:Fallback xmlns="">
           <p:sp>
             <p:nvSpPr>
               <p:cNvPr id="35" name="TextBox 34">
@@ -11103,8 +12544,8 @@
           </a:fontRef>
         </p:style>
       </p:cxnSp>
-      <mc:AlternateContent xmlns:mc="http://schemas.openxmlformats.org/markup-compatibility/2006">
-        <mc:Choice xmlns:a14="http://schemas.microsoft.com/office/drawing/2010/main" Requires="a14">
+      <mc:AlternateContent xmlns:mc="http://schemas.openxmlformats.org/markup-compatibility/2006" xmlns:a14="http://schemas.microsoft.com/office/drawing/2010/main">
+        <mc:Choice Requires="a14">
           <p:sp>
             <p:nvSpPr>
               <p:cNvPr id="37" name="TextBox 36">
@@ -11133,6 +12574,7 @@
               </a:bodyPr>
               <a:lstStyle/>
               <a:p>
+                <a:pPr/>
                 <a14:m>
                   <m:oMathPara xmlns:m="http://schemas.openxmlformats.org/officeDocument/2006/math">
                     <m:oMathParaPr>
@@ -11180,7 +12622,7 @@
             </p:txBody>
           </p:sp>
         </mc:Choice>
-        <mc:Fallback>
+        <mc:Fallback xmlns="">
           <p:sp>
             <p:nvSpPr>
               <p:cNvPr id="37" name="TextBox 36">
@@ -11225,8 +12667,8 @@
           </p:sp>
         </mc:Fallback>
       </mc:AlternateContent>
-      <mc:AlternateContent xmlns:mc="http://schemas.openxmlformats.org/markup-compatibility/2006">
-        <mc:Choice xmlns:a14="http://schemas.microsoft.com/office/drawing/2010/main" Requires="a14">
+      <mc:AlternateContent xmlns:mc="http://schemas.openxmlformats.org/markup-compatibility/2006" xmlns:a14="http://schemas.microsoft.com/office/drawing/2010/main">
+        <mc:Choice Requires="a14">
           <p:sp>
             <p:nvSpPr>
               <p:cNvPr id="40" name="TextBox 39">
@@ -11255,6 +12697,7 @@
               </a:bodyPr>
               <a:lstStyle/>
               <a:p>
+                <a:pPr/>
                 <a14:m>
                   <m:oMathPara xmlns:m="http://schemas.openxmlformats.org/officeDocument/2006/math">
                     <m:oMathParaPr>
@@ -11294,7 +12737,7 @@
             </p:txBody>
           </p:sp>
         </mc:Choice>
-        <mc:Fallback>
+        <mc:Fallback xmlns="">
           <p:sp>
             <p:nvSpPr>
               <p:cNvPr id="40" name="TextBox 39">
@@ -11339,8 +12782,8 @@
           </p:sp>
         </mc:Fallback>
       </mc:AlternateContent>
-      <mc:AlternateContent xmlns:mc="http://schemas.openxmlformats.org/markup-compatibility/2006">
-        <mc:Choice xmlns:a14="http://schemas.microsoft.com/office/drawing/2010/main" Requires="a14">
+      <mc:AlternateContent xmlns:mc="http://schemas.openxmlformats.org/markup-compatibility/2006" xmlns:a14="http://schemas.microsoft.com/office/drawing/2010/main">
+        <mc:Choice Requires="a14">
           <p:sp>
             <p:nvSpPr>
               <p:cNvPr id="54" name="TextBox 53">
@@ -11369,6 +12812,7 @@
               </a:bodyPr>
               <a:lstStyle/>
               <a:p>
+                <a:pPr/>
                 <a14:m>
                   <m:oMathPara xmlns:m="http://schemas.openxmlformats.org/officeDocument/2006/math">
                     <m:oMathParaPr>
@@ -11448,7 +12892,7 @@
             </p:txBody>
           </p:sp>
         </mc:Choice>
-        <mc:Fallback>
+        <mc:Fallback xmlns="">
           <p:sp>
             <p:nvSpPr>
               <p:cNvPr id="54" name="TextBox 53">
@@ -11493,8 +12937,8 @@
           </p:sp>
         </mc:Fallback>
       </mc:AlternateContent>
-      <mc:AlternateContent xmlns:mc="http://schemas.openxmlformats.org/markup-compatibility/2006">
-        <mc:Choice xmlns:a14="http://schemas.microsoft.com/office/drawing/2010/main" Requires="a14">
+      <mc:AlternateContent xmlns:mc="http://schemas.openxmlformats.org/markup-compatibility/2006" xmlns:a14="http://schemas.microsoft.com/office/drawing/2010/main">
+        <mc:Choice Requires="a14">
           <p:sp>
             <p:nvSpPr>
               <p:cNvPr id="56" name="TextBox 55">
@@ -11523,6 +12967,7 @@
               </a:bodyPr>
               <a:lstStyle/>
               <a:p>
+                <a:pPr/>
                 <a14:m>
                   <m:oMathPara xmlns:m="http://schemas.openxmlformats.org/officeDocument/2006/math">
                     <m:oMathParaPr>
@@ -11570,7 +13015,7 @@
             </p:txBody>
           </p:sp>
         </mc:Choice>
-        <mc:Fallback>
+        <mc:Fallback xmlns="">
           <p:sp>
             <p:nvSpPr>
               <p:cNvPr id="56" name="TextBox 55">
@@ -11707,8 +13152,8 @@
           </a:p>
         </p:txBody>
       </p:sp>
-      <mc:AlternateContent xmlns:mc="http://schemas.openxmlformats.org/markup-compatibility/2006">
-        <mc:Choice xmlns:a14="http://schemas.microsoft.com/office/drawing/2010/main" Requires="a14">
+      <mc:AlternateContent xmlns:mc="http://schemas.openxmlformats.org/markup-compatibility/2006" xmlns:a14="http://schemas.microsoft.com/office/drawing/2010/main">
+        <mc:Choice Requires="a14">
           <p:sp>
             <p:nvSpPr>
               <p:cNvPr id="66" name="TextBox 65">
@@ -11737,6 +13182,7 @@
               </a:bodyPr>
               <a:lstStyle/>
               <a:p>
+                <a:pPr/>
                 <a14:m>
                   <m:oMathPara xmlns:m="http://schemas.openxmlformats.org/officeDocument/2006/math">
                     <m:oMathParaPr>
@@ -11776,7 +13222,7 @@
             </p:txBody>
           </p:sp>
         </mc:Choice>
-        <mc:Fallback>
+        <mc:Fallback xmlns="">
           <p:sp>
             <p:nvSpPr>
               <p:cNvPr id="66" name="TextBox 65">
@@ -11821,8 +13267,8 @@
           </p:sp>
         </mc:Fallback>
       </mc:AlternateContent>
-      <mc:AlternateContent xmlns:mc="http://schemas.openxmlformats.org/markup-compatibility/2006">
-        <mc:Choice xmlns:a14="http://schemas.microsoft.com/office/drawing/2010/main" Requires="a14">
+      <mc:AlternateContent xmlns:mc="http://schemas.openxmlformats.org/markup-compatibility/2006" xmlns:a14="http://schemas.microsoft.com/office/drawing/2010/main">
+        <mc:Choice Requires="a14">
           <p:sp>
             <p:nvSpPr>
               <p:cNvPr id="68" name="TextBox 67">
@@ -11851,6 +13297,7 @@
               </a:bodyPr>
               <a:lstStyle/>
               <a:p>
+                <a:pPr/>
                 <a14:m>
                   <m:oMathPara xmlns:m="http://schemas.openxmlformats.org/officeDocument/2006/math">
                     <m:oMathParaPr>
@@ -11890,7 +13337,7 @@
             </p:txBody>
           </p:sp>
         </mc:Choice>
-        <mc:Fallback>
+        <mc:Fallback xmlns="">
           <p:sp>
             <p:nvSpPr>
               <p:cNvPr id="68" name="TextBox 67">
@@ -12027,8 +13474,8 @@
           </a:fontRef>
         </p:style>
       </p:cxnSp>
-      <mc:AlternateContent xmlns:mc="http://schemas.openxmlformats.org/markup-compatibility/2006">
-        <mc:Choice xmlns:a14="http://schemas.microsoft.com/office/drawing/2010/main" Requires="a14">
+      <mc:AlternateContent xmlns:mc="http://schemas.openxmlformats.org/markup-compatibility/2006" xmlns:a14="http://schemas.microsoft.com/office/drawing/2010/main">
+        <mc:Choice Requires="a14">
           <p:sp>
             <p:nvSpPr>
               <p:cNvPr id="76" name="TextBox 75">
@@ -12057,6 +13504,7 @@
               </a:bodyPr>
               <a:lstStyle/>
               <a:p>
+                <a:pPr/>
                 <a14:m>
                   <m:oMathPara xmlns:m="http://schemas.openxmlformats.org/officeDocument/2006/math">
                     <m:oMathParaPr>
@@ -12096,7 +13544,7 @@
             </p:txBody>
           </p:sp>
         </mc:Choice>
-        <mc:Fallback>
+        <mc:Fallback xmlns="">
           <p:sp>
             <p:nvSpPr>
               <p:cNvPr id="76" name="TextBox 75">
@@ -12141,8 +13589,8 @@
           </p:sp>
         </mc:Fallback>
       </mc:AlternateContent>
-      <mc:AlternateContent xmlns:mc="http://schemas.openxmlformats.org/markup-compatibility/2006">
-        <mc:Choice xmlns:a14="http://schemas.microsoft.com/office/drawing/2010/main" Requires="a14">
+      <mc:AlternateContent xmlns:mc="http://schemas.openxmlformats.org/markup-compatibility/2006" xmlns:a14="http://schemas.microsoft.com/office/drawing/2010/main">
+        <mc:Choice Requires="a14">
           <p:sp>
             <p:nvSpPr>
               <p:cNvPr id="77" name="TextBox 76">
@@ -12171,6 +13619,7 @@
               </a:bodyPr>
               <a:lstStyle/>
               <a:p>
+                <a:pPr/>
                 <a14:m>
                   <m:oMathPara xmlns:m="http://schemas.openxmlformats.org/officeDocument/2006/math">
                     <m:oMathParaPr>
@@ -12210,7 +13659,7 @@
             </p:txBody>
           </p:sp>
         </mc:Choice>
-        <mc:Fallback>
+        <mc:Fallback xmlns="">
           <p:sp>
             <p:nvSpPr>
               <p:cNvPr id="77" name="TextBox 76">
@@ -12301,8 +13750,8 @@
           </a:fontRef>
         </p:style>
       </p:cxnSp>
-      <mc:AlternateContent xmlns:mc="http://schemas.openxmlformats.org/markup-compatibility/2006">
-        <mc:Choice xmlns:a14="http://schemas.microsoft.com/office/drawing/2010/main" Requires="a14">
+      <mc:AlternateContent xmlns:mc="http://schemas.openxmlformats.org/markup-compatibility/2006" xmlns:a14="http://schemas.microsoft.com/office/drawing/2010/main">
+        <mc:Choice Requires="a14">
           <p:sp>
             <p:nvSpPr>
               <p:cNvPr id="83" name="TextBox 82">
@@ -12331,6 +13780,7 @@
               </a:bodyPr>
               <a:lstStyle/>
               <a:p>
+                <a:pPr/>
                 <a14:m>
                   <m:oMathPara xmlns:m="http://schemas.openxmlformats.org/officeDocument/2006/math">
                     <m:oMathParaPr>
@@ -12352,7 +13802,7 @@
             </p:txBody>
           </p:sp>
         </mc:Choice>
-        <mc:Fallback>
+        <mc:Fallback xmlns="">
           <p:sp>
             <p:nvSpPr>
               <p:cNvPr id="83" name="TextBox 82">
@@ -12397,8 +13847,8 @@
           </p:sp>
         </mc:Fallback>
       </mc:AlternateContent>
-      <mc:AlternateContent xmlns:mc="http://schemas.openxmlformats.org/markup-compatibility/2006">
-        <mc:Choice xmlns:a14="http://schemas.microsoft.com/office/drawing/2010/main" Requires="a14">
+      <mc:AlternateContent xmlns:mc="http://schemas.openxmlformats.org/markup-compatibility/2006" xmlns:a14="http://schemas.microsoft.com/office/drawing/2010/main">
+        <mc:Choice Requires="a14">
           <p:sp>
             <p:nvSpPr>
               <p:cNvPr id="84" name="TextBox 83">
@@ -12427,6 +13877,7 @@
               </a:bodyPr>
               <a:lstStyle/>
               <a:p>
+                <a:pPr/>
                 <a14:m>
                   <m:oMathPara xmlns:m="http://schemas.openxmlformats.org/officeDocument/2006/math">
                     <m:oMathParaPr>
@@ -12466,7 +13917,7 @@
             </p:txBody>
           </p:sp>
         </mc:Choice>
-        <mc:Fallback>
+        <mc:Fallback xmlns="">
           <p:sp>
             <p:nvSpPr>
               <p:cNvPr id="84" name="TextBox 83">
@@ -12585,8 +14036,8 @@
           </a:p>
         </p:txBody>
       </p:sp>
-      <mc:AlternateContent xmlns:mc="http://schemas.openxmlformats.org/markup-compatibility/2006">
-        <mc:Choice xmlns:a14="http://schemas.microsoft.com/office/drawing/2010/main" Requires="a14">
+      <mc:AlternateContent xmlns:mc="http://schemas.openxmlformats.org/markup-compatibility/2006" xmlns:a14="http://schemas.microsoft.com/office/drawing/2010/main">
+        <mc:Choice Requires="a14">
           <p:sp>
             <p:nvSpPr>
               <p:cNvPr id="89" name="TextBox 88">
@@ -12615,6 +14066,7 @@
               </a:bodyPr>
               <a:lstStyle/>
               <a:p>
+                <a:pPr/>
                 <a14:m>
                   <m:oMathPara xmlns:m="http://schemas.openxmlformats.org/officeDocument/2006/math">
                     <m:oMathParaPr>
@@ -12678,7 +14130,7 @@
             </p:txBody>
           </p:sp>
         </mc:Choice>
-        <mc:Fallback>
+        <mc:Fallback xmlns="">
           <p:sp>
             <p:nvSpPr>
               <p:cNvPr id="89" name="TextBox 88">
@@ -12723,8 +14175,8 @@
           </p:sp>
         </mc:Fallback>
       </mc:AlternateContent>
-      <mc:AlternateContent xmlns:mc="http://schemas.openxmlformats.org/markup-compatibility/2006">
-        <mc:Choice xmlns:a14="http://schemas.microsoft.com/office/drawing/2010/main" Requires="a14">
+      <mc:AlternateContent xmlns:mc="http://schemas.openxmlformats.org/markup-compatibility/2006" xmlns:a14="http://schemas.microsoft.com/office/drawing/2010/main">
+        <mc:Choice Requires="a14">
           <p:sp>
             <p:nvSpPr>
               <p:cNvPr id="90" name="TextBox 89">
@@ -12753,6 +14205,7 @@
               </a:bodyPr>
               <a:lstStyle/>
               <a:p>
+                <a:pPr/>
                 <a14:m>
                   <m:oMathPara xmlns:m="http://schemas.openxmlformats.org/officeDocument/2006/math">
                     <m:oMathParaPr>
@@ -12832,7 +14285,7 @@
             </p:txBody>
           </p:sp>
         </mc:Choice>
-        <mc:Fallback>
+        <mc:Fallback xmlns="">
           <p:sp>
             <p:nvSpPr>
               <p:cNvPr id="90" name="TextBox 89">
@@ -12877,8 +14330,8 @@
           </p:sp>
         </mc:Fallback>
       </mc:AlternateContent>
-      <mc:AlternateContent xmlns:mc="http://schemas.openxmlformats.org/markup-compatibility/2006">
-        <mc:Choice xmlns:a14="http://schemas.microsoft.com/office/drawing/2010/main" Requires="a14">
+      <mc:AlternateContent xmlns:mc="http://schemas.openxmlformats.org/markup-compatibility/2006" xmlns:a14="http://schemas.microsoft.com/office/drawing/2010/main">
+        <mc:Choice Requires="a14">
           <p:sp>
             <p:nvSpPr>
               <p:cNvPr id="91" name="TextBox 90">
@@ -12907,6 +14360,7 @@
               </a:bodyPr>
               <a:lstStyle/>
               <a:p>
+                <a:pPr/>
                 <a14:m>
                   <m:oMathPara xmlns:m="http://schemas.openxmlformats.org/officeDocument/2006/math">
                     <m:oMathParaPr>
@@ -12986,7 +14440,7 @@
             </p:txBody>
           </p:sp>
         </mc:Choice>
-        <mc:Fallback>
+        <mc:Fallback xmlns="">
           <p:sp>
             <p:nvSpPr>
               <p:cNvPr id="91" name="TextBox 90">
@@ -13077,8 +14531,8 @@
           </a:fontRef>
         </p:style>
       </p:cxnSp>
-      <mc:AlternateContent xmlns:mc="http://schemas.openxmlformats.org/markup-compatibility/2006">
-        <mc:Choice xmlns:a14="http://schemas.microsoft.com/office/drawing/2010/main" Requires="a14">
+      <mc:AlternateContent xmlns:mc="http://schemas.openxmlformats.org/markup-compatibility/2006" xmlns:a14="http://schemas.microsoft.com/office/drawing/2010/main">
+        <mc:Choice Requires="a14">
           <p:sp>
             <p:nvSpPr>
               <p:cNvPr id="98" name="TextBox 97">
@@ -13107,6 +14561,7 @@
               </a:bodyPr>
               <a:lstStyle/>
               <a:p>
+                <a:pPr/>
                 <a14:m>
                   <m:oMathPara xmlns:m="http://schemas.openxmlformats.org/officeDocument/2006/math">
                     <m:oMathParaPr>
@@ -13154,7 +14609,7 @@
             </p:txBody>
           </p:sp>
         </mc:Choice>
-        <mc:Fallback>
+        <mc:Fallback xmlns="">
           <p:sp>
             <p:nvSpPr>
               <p:cNvPr id="98" name="TextBox 97">
@@ -13244,8 +14699,8 @@
           </a:fontRef>
         </p:style>
       </p:cxnSp>
-      <mc:AlternateContent xmlns:mc="http://schemas.openxmlformats.org/markup-compatibility/2006">
-        <mc:Choice xmlns:a14="http://schemas.microsoft.com/office/drawing/2010/main" Requires="a14">
+      <mc:AlternateContent xmlns:mc="http://schemas.openxmlformats.org/markup-compatibility/2006" xmlns:a14="http://schemas.microsoft.com/office/drawing/2010/main">
+        <mc:Choice Requires="a14">
           <p:sp>
             <p:nvSpPr>
               <p:cNvPr id="103" name="TextBox 102">
@@ -13274,6 +14729,7 @@
               </a:bodyPr>
               <a:lstStyle/>
               <a:p>
+                <a:pPr/>
                 <a14:m>
                   <m:oMathPara xmlns:m="http://schemas.openxmlformats.org/officeDocument/2006/math">
                     <m:oMathParaPr>
@@ -13321,7 +14777,7 @@
             </p:txBody>
           </p:sp>
         </mc:Choice>
-        <mc:Fallback>
+        <mc:Fallback xmlns="">
           <p:sp>
             <p:nvSpPr>
               <p:cNvPr id="103" name="TextBox 102">

</xml_diff>

<commit_message>
Updated figures and presentation
</commit_message>
<xml_diff>
--- a/docs/figures.pptx
+++ b/docs/figures.pptx
@@ -9,15 +9,16 @@
     <p:sldId id="265" r:id="rId3"/>
     <p:sldId id="267" r:id="rId4"/>
     <p:sldId id="268" r:id="rId5"/>
-    <p:sldId id="266" r:id="rId6"/>
-    <p:sldId id="259" r:id="rId7"/>
-    <p:sldId id="263" r:id="rId8"/>
-    <p:sldId id="262" r:id="rId9"/>
-    <p:sldId id="264" r:id="rId10"/>
-    <p:sldId id="258" r:id="rId11"/>
-    <p:sldId id="261" r:id="rId12"/>
-    <p:sldId id="260" r:id="rId13"/>
-    <p:sldId id="257" r:id="rId14"/>
+    <p:sldId id="269" r:id="rId6"/>
+    <p:sldId id="266" r:id="rId7"/>
+    <p:sldId id="259" r:id="rId8"/>
+    <p:sldId id="263" r:id="rId9"/>
+    <p:sldId id="262" r:id="rId10"/>
+    <p:sldId id="264" r:id="rId11"/>
+    <p:sldId id="258" r:id="rId12"/>
+    <p:sldId id="261" r:id="rId13"/>
+    <p:sldId id="260" r:id="rId14"/>
+    <p:sldId id="257" r:id="rId15"/>
   </p:sldIdLst>
   <p:sldSz cx="12192000" cy="6858000"/>
   <p:notesSz cx="6858000" cy="9144000"/>
@@ -3409,6 +3410,1041 @@
   <p:cSld>
     <p:spTree>
       <p:nvGrpSpPr>
+        <p:cNvPr id="1" name="">
+          <a:extLst>
+            <a:ext uri="{FF2B5EF4-FFF2-40B4-BE49-F238E27FC236}">
+              <a16:creationId xmlns:a16="http://schemas.microsoft.com/office/drawing/2014/main" id="{476B5D77-D685-C424-9CA2-EC4A3293D9DD}"/>
+            </a:ext>
+          </a:extLst>
+        </p:cNvPr>
+        <p:cNvGrpSpPr/>
+        <p:nvPr/>
+      </p:nvGrpSpPr>
+      <p:grpSpPr>
+        <a:xfrm>
+          <a:off x="0" y="0"/>
+          <a:ext cx="0" cy="0"/>
+          <a:chOff x="0" y="0"/>
+          <a:chExt cx="0" cy="0"/>
+        </a:xfrm>
+      </p:grpSpPr>
+      <p:pic>
+        <p:nvPicPr>
+          <p:cNvPr id="15" name="Picture 14">
+            <a:extLst>
+              <a:ext uri="{FF2B5EF4-FFF2-40B4-BE49-F238E27FC236}">
+                <a16:creationId xmlns:a16="http://schemas.microsoft.com/office/drawing/2014/main" id="{2BB9B683-2259-2487-0FB1-94E9B4503A8C}"/>
+              </a:ext>
+            </a:extLst>
+          </p:cNvPr>
+          <p:cNvPicPr>
+            <a:picLocks noChangeAspect="1"/>
+          </p:cNvPicPr>
+          <p:nvPr/>
+        </p:nvPicPr>
+        <p:blipFill>
+          <a:blip r:embed="rId2"/>
+          <a:stretch>
+            <a:fillRect/>
+          </a:stretch>
+        </p:blipFill>
+        <p:spPr>
+          <a:xfrm>
+            <a:off x="1761981" y="1600200"/>
+            <a:ext cx="1392389" cy="3657600"/>
+          </a:xfrm>
+          <a:prstGeom prst="rect">
+            <a:avLst/>
+          </a:prstGeom>
+        </p:spPr>
+      </p:pic>
+      <p:pic>
+        <p:nvPicPr>
+          <p:cNvPr id="17" name="Picture 16">
+            <a:extLst>
+              <a:ext uri="{FF2B5EF4-FFF2-40B4-BE49-F238E27FC236}">
+                <a16:creationId xmlns:a16="http://schemas.microsoft.com/office/drawing/2014/main" id="{30B4CCDB-C456-3238-4EA9-BABE44498B7F}"/>
+              </a:ext>
+            </a:extLst>
+          </p:cNvPr>
+          <p:cNvPicPr>
+            <a:picLocks noChangeAspect="1"/>
+          </p:cNvPicPr>
+          <p:nvPr/>
+        </p:nvPicPr>
+        <p:blipFill>
+          <a:blip r:embed="rId3"/>
+          <a:stretch>
+            <a:fillRect/>
+          </a:stretch>
+        </p:blipFill>
+        <p:spPr>
+          <a:xfrm>
+            <a:off x="5493760" y="1691640"/>
+            <a:ext cx="1130337" cy="3474720"/>
+          </a:xfrm>
+          <a:prstGeom prst="rect">
+            <a:avLst/>
+          </a:prstGeom>
+        </p:spPr>
+      </p:pic>
+      <mc:AlternateContent xmlns:mc="http://schemas.openxmlformats.org/markup-compatibility/2006" xmlns:a14="http://schemas.microsoft.com/office/drawing/2010/main">
+        <mc:Choice Requires="a14">
+          <p:sp>
+            <p:nvSpPr>
+              <p:cNvPr id="22" name="TextBox 21">
+                <a:extLst>
+                  <a:ext uri="{FF2B5EF4-FFF2-40B4-BE49-F238E27FC236}">
+                    <a16:creationId xmlns:a16="http://schemas.microsoft.com/office/drawing/2014/main" id="{E443F7E9-CF42-0AF7-B386-2598FE890044}"/>
+                  </a:ext>
+                </a:extLst>
+              </p:cNvPr>
+              <p:cNvSpPr txBox="1"/>
+              <p:nvPr/>
+            </p:nvSpPr>
+            <p:spPr>
+              <a:xfrm>
+                <a:off x="5412627" y="1513700"/>
+                <a:ext cx="293863" cy="276999"/>
+              </a:xfrm>
+              <a:prstGeom prst="rect">
+                <a:avLst/>
+              </a:prstGeom>
+              <a:noFill/>
+            </p:spPr>
+            <p:txBody>
+              <a:bodyPr wrap="none" lIns="0" tIns="0" rIns="0" bIns="0" rtlCol="0">
+                <a:spAutoFit/>
+              </a:bodyPr>
+              <a:lstStyle/>
+              <a:p>
+                <a:pPr/>
+                <a14:m>
+                  <m:oMathPara xmlns:m="http://schemas.openxmlformats.org/officeDocument/2006/math">
+                    <m:oMathParaPr>
+                      <m:jc m:val="centerGroup"/>
+                    </m:oMathParaPr>
+                    <m:oMath xmlns:m="http://schemas.openxmlformats.org/officeDocument/2006/math">
+                      <m:sSub>
+                        <m:sSubPr>
+                          <m:ctrlPr>
+                            <a:rPr lang="en-US" b="0" i="1" smtClean="0">
+                              <a:latin typeface="Cambria Math" panose="02040503050406030204" pitchFamily="18" charset="0"/>
+                            </a:rPr>
+                          </m:ctrlPr>
+                        </m:sSubPr>
+                        <m:e>
+                          <m:r>
+                            <a:rPr lang="en-US" b="0" i="1" smtClean="0">
+                              <a:latin typeface="Cambria Math" panose="02040503050406030204" pitchFamily="18" charset="0"/>
+                            </a:rPr>
+                            <m:t>𝑋</m:t>
+                          </m:r>
+                        </m:e>
+                        <m:sub>
+                          <m:r>
+                            <a:rPr lang="en-US" b="0" i="1" smtClean="0">
+                              <a:latin typeface="Cambria Math" panose="02040503050406030204" pitchFamily="18" charset="0"/>
+                            </a:rPr>
+                            <m:t>1</m:t>
+                          </m:r>
+                        </m:sub>
+                      </m:sSub>
+                    </m:oMath>
+                  </m:oMathPara>
+                </a14:m>
+                <a:endParaRPr lang="en-US" dirty="0"/>
+              </a:p>
+            </p:txBody>
+          </p:sp>
+        </mc:Choice>
+        <mc:Fallback xmlns="">
+          <p:sp>
+            <p:nvSpPr>
+              <p:cNvPr id="22" name="TextBox 21">
+                <a:extLst>
+                  <a:ext uri="{FF2B5EF4-FFF2-40B4-BE49-F238E27FC236}">
+                    <a16:creationId xmlns:a16="http://schemas.microsoft.com/office/drawing/2014/main" id="{E443F7E9-CF42-0AF7-B386-2598FE890044}"/>
+                  </a:ext>
+                </a:extLst>
+              </p:cNvPr>
+              <p:cNvSpPr txBox="1">
+                <a:spLocks noRot="1" noChangeAspect="1" noMove="1" noResize="1" noEditPoints="1" noAdjustHandles="1" noChangeArrowheads="1" noChangeShapeType="1" noTextEdit="1"/>
+              </p:cNvSpPr>
+              <p:nvPr/>
+            </p:nvSpPr>
+            <p:spPr>
+              <a:xfrm>
+                <a:off x="5412627" y="1513700"/>
+                <a:ext cx="293863" cy="276999"/>
+              </a:xfrm>
+              <a:prstGeom prst="rect">
+                <a:avLst/>
+              </a:prstGeom>
+              <a:blipFill>
+                <a:blip r:embed="rId4"/>
+                <a:stretch>
+                  <a:fillRect l="-20833" r="-4167" b="-8696"/>
+                </a:stretch>
+              </a:blipFill>
+            </p:spPr>
+            <p:txBody>
+              <a:bodyPr/>
+              <a:lstStyle/>
+              <a:p>
+                <a:r>
+                  <a:rPr lang="en-US">
+                    <a:noFill/>
+                  </a:rPr>
+                  <a:t> </a:t>
+                </a:r>
+              </a:p>
+            </p:txBody>
+          </p:sp>
+        </mc:Fallback>
+      </mc:AlternateContent>
+      <mc:AlternateContent xmlns:mc="http://schemas.openxmlformats.org/markup-compatibility/2006" xmlns:a14="http://schemas.microsoft.com/office/drawing/2010/main">
+        <mc:Choice Requires="a14">
+          <p:sp>
+            <p:nvSpPr>
+              <p:cNvPr id="24" name="TextBox 23">
+                <a:extLst>
+                  <a:ext uri="{FF2B5EF4-FFF2-40B4-BE49-F238E27FC236}">
+                    <a16:creationId xmlns:a16="http://schemas.microsoft.com/office/drawing/2014/main" id="{F8777DE3-5E3D-C514-4D85-A6CE1CBE3F04}"/>
+                  </a:ext>
+                </a:extLst>
+              </p:cNvPr>
+              <p:cNvSpPr txBox="1"/>
+              <p:nvPr/>
+            </p:nvSpPr>
+            <p:spPr>
+              <a:xfrm>
+                <a:off x="1863795" y="4681160"/>
+                <a:ext cx="293863" cy="276999"/>
+              </a:xfrm>
+              <a:prstGeom prst="rect">
+                <a:avLst/>
+              </a:prstGeom>
+              <a:noFill/>
+            </p:spPr>
+            <p:txBody>
+              <a:bodyPr wrap="none" lIns="0" tIns="0" rIns="0" bIns="0" rtlCol="0">
+                <a:spAutoFit/>
+              </a:bodyPr>
+              <a:lstStyle/>
+              <a:p>
+                <a:pPr/>
+                <a14:m>
+                  <m:oMathPara xmlns:m="http://schemas.openxmlformats.org/officeDocument/2006/math">
+                    <m:oMathParaPr>
+                      <m:jc m:val="centerGroup"/>
+                    </m:oMathParaPr>
+                    <m:oMath xmlns:m="http://schemas.openxmlformats.org/officeDocument/2006/math">
+                      <m:sSub>
+                        <m:sSubPr>
+                          <m:ctrlPr>
+                            <a:rPr lang="en-US" b="0" i="1" smtClean="0">
+                              <a:latin typeface="Cambria Math" panose="02040503050406030204" pitchFamily="18" charset="0"/>
+                            </a:rPr>
+                          </m:ctrlPr>
+                        </m:sSubPr>
+                        <m:e>
+                          <m:r>
+                            <a:rPr lang="en-US" b="0" i="1" smtClean="0">
+                              <a:latin typeface="Cambria Math" panose="02040503050406030204" pitchFamily="18" charset="0"/>
+                            </a:rPr>
+                            <m:t>𝑋</m:t>
+                          </m:r>
+                        </m:e>
+                        <m:sub>
+                          <m:r>
+                            <a:rPr lang="en-US" b="0" i="1" smtClean="0">
+                              <a:latin typeface="Cambria Math" panose="02040503050406030204" pitchFamily="18" charset="0"/>
+                            </a:rPr>
+                            <m:t>1</m:t>
+                          </m:r>
+                        </m:sub>
+                      </m:sSub>
+                    </m:oMath>
+                  </m:oMathPara>
+                </a14:m>
+                <a:endParaRPr lang="en-US" dirty="0"/>
+              </a:p>
+            </p:txBody>
+          </p:sp>
+        </mc:Choice>
+        <mc:Fallback xmlns="">
+          <p:sp>
+            <p:nvSpPr>
+              <p:cNvPr id="24" name="TextBox 23">
+                <a:extLst>
+                  <a:ext uri="{FF2B5EF4-FFF2-40B4-BE49-F238E27FC236}">
+                    <a16:creationId xmlns:a16="http://schemas.microsoft.com/office/drawing/2014/main" id="{F8777DE3-5E3D-C514-4D85-A6CE1CBE3F04}"/>
+                  </a:ext>
+                </a:extLst>
+              </p:cNvPr>
+              <p:cNvSpPr txBox="1">
+                <a:spLocks noRot="1" noChangeAspect="1" noMove="1" noResize="1" noEditPoints="1" noAdjustHandles="1" noChangeArrowheads="1" noChangeShapeType="1" noTextEdit="1"/>
+              </p:cNvSpPr>
+              <p:nvPr/>
+            </p:nvSpPr>
+            <p:spPr>
+              <a:xfrm>
+                <a:off x="1863795" y="4681160"/>
+                <a:ext cx="293863" cy="276999"/>
+              </a:xfrm>
+              <a:prstGeom prst="rect">
+                <a:avLst/>
+              </a:prstGeom>
+              <a:blipFill>
+                <a:blip r:embed="rId5"/>
+                <a:stretch>
+                  <a:fillRect l="-16667" r="-8333" b="-13043"/>
+                </a:stretch>
+              </a:blipFill>
+            </p:spPr>
+            <p:txBody>
+              <a:bodyPr/>
+              <a:lstStyle/>
+              <a:p>
+                <a:r>
+                  <a:rPr lang="en-US">
+                    <a:noFill/>
+                  </a:rPr>
+                  <a:t> </a:t>
+                </a:r>
+              </a:p>
+            </p:txBody>
+          </p:sp>
+        </mc:Fallback>
+      </mc:AlternateContent>
+      <mc:AlternateContent xmlns:mc="http://schemas.openxmlformats.org/markup-compatibility/2006" xmlns:a14="http://schemas.microsoft.com/office/drawing/2010/main">
+        <mc:Choice Requires="a14">
+          <p:sp>
+            <p:nvSpPr>
+              <p:cNvPr id="25" name="Rectangle 24">
+                <a:extLst>
+                  <a:ext uri="{FF2B5EF4-FFF2-40B4-BE49-F238E27FC236}">
+                    <a16:creationId xmlns:a16="http://schemas.microsoft.com/office/drawing/2014/main" id="{C7AEA308-BE30-3F96-8043-BF55377A5161}"/>
+                  </a:ext>
+                </a:extLst>
+              </p:cNvPr>
+              <p:cNvSpPr>
+                <a:spLocks/>
+              </p:cNvSpPr>
+              <p:nvPr/>
+            </p:nvSpPr>
+            <p:spPr>
+              <a:xfrm>
+                <a:off x="2922362" y="2150074"/>
+                <a:ext cx="1188720" cy="1188720"/>
+              </a:xfrm>
+              <a:prstGeom prst="rect">
+                <a:avLst/>
+              </a:prstGeom>
+            </p:spPr>
+            <p:style>
+              <a:lnRef idx="2">
+                <a:schemeClr val="accent1">
+                  <a:shade val="15000"/>
+                </a:schemeClr>
+              </a:lnRef>
+              <a:fillRef idx="1">
+                <a:schemeClr val="accent1"/>
+              </a:fillRef>
+              <a:effectRef idx="0">
+                <a:schemeClr val="accent1"/>
+              </a:effectRef>
+              <a:fontRef idx="minor">
+                <a:schemeClr val="lt1"/>
+              </a:fontRef>
+            </p:style>
+            <p:txBody>
+              <a:bodyPr rtlCol="0" anchor="ctr"/>
+              <a:lstStyle/>
+              <a:p>
+                <a:pPr algn="ctr"/>
+                <a14:m>
+                  <m:oMathPara xmlns:m="http://schemas.openxmlformats.org/officeDocument/2006/math">
+                    <m:oMathParaPr>
+                      <m:jc m:val="centerGroup"/>
+                    </m:oMathParaPr>
+                    <m:oMath xmlns:m="http://schemas.openxmlformats.org/officeDocument/2006/math">
+                      <m:r>
+                        <a:rPr lang="en-US" i="1" smtClean="0">
+                          <a:latin typeface="Cambria Math" panose="02040503050406030204" pitchFamily="18" charset="0"/>
+                          <a:ea typeface="Cambria Math" panose="02040503050406030204" pitchFamily="18" charset="0"/>
+                        </a:rPr>
+                        <m:t>ℳ</m:t>
+                      </m:r>
+                      <m:r>
+                        <a:rPr lang="en-US" b="0" i="1" baseline="-25000" smtClean="0">
+                          <a:latin typeface="Cambria Math" panose="02040503050406030204" pitchFamily="18" charset="0"/>
+                          <a:ea typeface="Cambria Math" panose="02040503050406030204" pitchFamily="18" charset="0"/>
+                        </a:rPr>
+                        <m:t>1</m:t>
+                      </m:r>
+                      <m:r>
+                        <a:rPr lang="en-US" b="0" i="1" smtClean="0">
+                          <a:latin typeface="Cambria Math" panose="02040503050406030204" pitchFamily="18" charset="0"/>
+                          <a:ea typeface="Cambria Math" panose="02040503050406030204" pitchFamily="18" charset="0"/>
+                        </a:rPr>
+                        <m:t>−</m:t>
+                      </m:r>
+                      <m:sSub>
+                        <m:sSubPr>
+                          <m:ctrlPr>
+                            <a:rPr lang="en-US" b="0" i="1" smtClean="0">
+                              <a:latin typeface="Cambria Math" panose="02040503050406030204" pitchFamily="18" charset="0"/>
+                              <a:ea typeface="Cambria Math" panose="02040503050406030204" pitchFamily="18" charset="0"/>
+                            </a:rPr>
+                          </m:ctrlPr>
+                        </m:sSubPr>
+                        <m:e>
+                          <m:r>
+                            <a:rPr lang="en-US" b="0" i="1" smtClean="0">
+                              <a:latin typeface="Cambria Math" panose="02040503050406030204" pitchFamily="18" charset="0"/>
+                              <a:ea typeface="Cambria Math" panose="02040503050406030204" pitchFamily="18" charset="0"/>
+                            </a:rPr>
+                            <m:t>𝑋</m:t>
+                          </m:r>
+                        </m:e>
+                        <m:sub>
+                          <m:r>
+                            <a:rPr lang="en-US" b="0" i="1" smtClean="0">
+                              <a:latin typeface="Cambria Math" panose="02040503050406030204" pitchFamily="18" charset="0"/>
+                              <a:ea typeface="Cambria Math" panose="02040503050406030204" pitchFamily="18" charset="0"/>
+                            </a:rPr>
+                            <m:t>1</m:t>
+                          </m:r>
+                        </m:sub>
+                      </m:sSub>
+                    </m:oMath>
+                  </m:oMathPara>
+                </a14:m>
+                <a:endParaRPr lang="en-US" dirty="0"/>
+              </a:p>
+            </p:txBody>
+          </p:sp>
+        </mc:Choice>
+        <mc:Fallback xmlns="">
+          <p:sp>
+            <p:nvSpPr>
+              <p:cNvPr id="25" name="Rectangle 24">
+                <a:extLst>
+                  <a:ext uri="{FF2B5EF4-FFF2-40B4-BE49-F238E27FC236}">
+                    <a16:creationId xmlns:a16="http://schemas.microsoft.com/office/drawing/2014/main" id="{C7AEA308-BE30-3F96-8043-BF55377A5161}"/>
+                  </a:ext>
+                </a:extLst>
+              </p:cNvPr>
+              <p:cNvSpPr>
+                <a:spLocks noRot="1" noChangeAspect="1" noMove="1" noResize="1" noEditPoints="1" noAdjustHandles="1" noChangeArrowheads="1" noChangeShapeType="1" noTextEdit="1"/>
+              </p:cNvSpPr>
+              <p:nvPr/>
+            </p:nvSpPr>
+            <p:spPr>
+              <a:xfrm>
+                <a:off x="2922362" y="2150074"/>
+                <a:ext cx="1188720" cy="1188720"/>
+              </a:xfrm>
+              <a:prstGeom prst="rect">
+                <a:avLst/>
+              </a:prstGeom>
+              <a:blipFill>
+                <a:blip r:embed="rId6"/>
+                <a:stretch>
+                  <a:fillRect/>
+                </a:stretch>
+              </a:blipFill>
+            </p:spPr>
+            <p:txBody>
+              <a:bodyPr/>
+              <a:lstStyle/>
+              <a:p>
+                <a:r>
+                  <a:rPr lang="en-US">
+                    <a:noFill/>
+                  </a:rPr>
+                  <a:t> </a:t>
+                </a:r>
+              </a:p>
+            </p:txBody>
+          </p:sp>
+        </mc:Fallback>
+      </mc:AlternateContent>
+      <mc:AlternateContent xmlns:mc="http://schemas.openxmlformats.org/markup-compatibility/2006" xmlns:a14="http://schemas.microsoft.com/office/drawing/2010/main">
+        <mc:Choice Requires="a14">
+          <p:sp>
+            <p:nvSpPr>
+              <p:cNvPr id="28" name="Rectangle 27">
+                <a:extLst>
+                  <a:ext uri="{FF2B5EF4-FFF2-40B4-BE49-F238E27FC236}">
+                    <a16:creationId xmlns:a16="http://schemas.microsoft.com/office/drawing/2014/main" id="{4AB347E8-7AF4-A6F5-665E-45B559168B5D}"/>
+                  </a:ext>
+                </a:extLst>
+              </p:cNvPr>
+              <p:cNvSpPr>
+                <a:spLocks/>
+              </p:cNvSpPr>
+              <p:nvPr/>
+            </p:nvSpPr>
+            <p:spPr>
+              <a:xfrm>
+                <a:off x="4125981" y="3365156"/>
+                <a:ext cx="1188720" cy="1188720"/>
+              </a:xfrm>
+              <a:prstGeom prst="rect">
+                <a:avLst/>
+              </a:prstGeom>
+              <a:solidFill>
+                <a:schemeClr val="accent2">
+                  <a:lumMod val="60000"/>
+                  <a:lumOff val="40000"/>
+                </a:schemeClr>
+              </a:solidFill>
+              <a:ln>
+                <a:noFill/>
+              </a:ln>
+            </p:spPr>
+            <p:style>
+              <a:lnRef idx="2">
+                <a:schemeClr val="accent1">
+                  <a:shade val="15000"/>
+                </a:schemeClr>
+              </a:lnRef>
+              <a:fillRef idx="1">
+                <a:schemeClr val="accent1"/>
+              </a:fillRef>
+              <a:effectRef idx="0">
+                <a:schemeClr val="accent1"/>
+              </a:effectRef>
+              <a:fontRef idx="minor">
+                <a:schemeClr val="lt1"/>
+              </a:fontRef>
+            </p:style>
+            <p:txBody>
+              <a:bodyPr rtlCol="0" anchor="ctr"/>
+              <a:lstStyle/>
+              <a:p>
+                <a:pPr algn="ctr"/>
+                <a14:m>
+                  <m:oMathPara xmlns:m="http://schemas.openxmlformats.org/officeDocument/2006/math">
+                    <m:oMathParaPr>
+                      <m:jc m:val="centerGroup"/>
+                    </m:oMathParaPr>
+                    <m:oMath xmlns:m="http://schemas.openxmlformats.org/officeDocument/2006/math">
+                      <m:r>
+                        <a:rPr lang="en-US" i="1" smtClean="0">
+                          <a:latin typeface="Cambria Math" panose="02040503050406030204" pitchFamily="18" charset="0"/>
+                          <a:ea typeface="Cambria Math" panose="02040503050406030204" pitchFamily="18" charset="0"/>
+                        </a:rPr>
+                        <m:t>ℳ</m:t>
+                      </m:r>
+                      <m:r>
+                        <a:rPr lang="en-US" b="0" i="1" baseline="-25000" smtClean="0">
+                          <a:latin typeface="Cambria Math" panose="02040503050406030204" pitchFamily="18" charset="0"/>
+                          <a:ea typeface="Cambria Math" panose="02040503050406030204" pitchFamily="18" charset="0"/>
+                        </a:rPr>
+                        <m:t>2</m:t>
+                      </m:r>
+                      <m:r>
+                        <a:rPr lang="en-US" b="0" i="0" smtClean="0">
+                          <a:latin typeface="Cambria Math" panose="02040503050406030204" pitchFamily="18" charset="0"/>
+                          <a:ea typeface="Cambria Math" panose="02040503050406030204" pitchFamily="18" charset="0"/>
+                        </a:rPr>
+                        <m:t>−</m:t>
+                      </m:r>
+                      <m:r>
+                        <m:rPr>
+                          <m:sty m:val="p"/>
+                        </m:rPr>
+                        <a:rPr lang="en-US" b="0" i="0" smtClean="0">
+                          <a:latin typeface="Cambria Math" panose="02040503050406030204" pitchFamily="18" charset="0"/>
+                          <a:ea typeface="Cambria Math" panose="02040503050406030204" pitchFamily="18" charset="0"/>
+                        </a:rPr>
+                        <m:t>X</m:t>
+                      </m:r>
+                      <m:r>
+                        <a:rPr lang="en-US" b="0" i="0" baseline="-25000" smtClean="0">
+                          <a:latin typeface="Cambria Math" panose="02040503050406030204" pitchFamily="18" charset="0"/>
+                          <a:ea typeface="Cambria Math" panose="02040503050406030204" pitchFamily="18" charset="0"/>
+                        </a:rPr>
+                        <m:t>1</m:t>
+                      </m:r>
+                    </m:oMath>
+                  </m:oMathPara>
+                </a14:m>
+                <a:endParaRPr lang="en-US" baseline="-25000" dirty="0"/>
+              </a:p>
+            </p:txBody>
+          </p:sp>
+        </mc:Choice>
+        <mc:Fallback xmlns="">
+          <p:sp>
+            <p:nvSpPr>
+              <p:cNvPr id="28" name="Rectangle 27">
+                <a:extLst>
+                  <a:ext uri="{FF2B5EF4-FFF2-40B4-BE49-F238E27FC236}">
+                    <a16:creationId xmlns:a16="http://schemas.microsoft.com/office/drawing/2014/main" id="{4AB347E8-7AF4-A6F5-665E-45B559168B5D}"/>
+                  </a:ext>
+                </a:extLst>
+              </p:cNvPr>
+              <p:cNvSpPr>
+                <a:spLocks noRot="1" noChangeAspect="1" noMove="1" noResize="1" noEditPoints="1" noAdjustHandles="1" noChangeArrowheads="1" noChangeShapeType="1" noTextEdit="1"/>
+              </p:cNvSpPr>
+              <p:nvPr/>
+            </p:nvSpPr>
+            <p:spPr>
+              <a:xfrm>
+                <a:off x="4125981" y="3365156"/>
+                <a:ext cx="1188720" cy="1188720"/>
+              </a:xfrm>
+              <a:prstGeom prst="rect">
+                <a:avLst/>
+              </a:prstGeom>
+              <a:blipFill>
+                <a:blip r:embed="rId7"/>
+                <a:stretch>
+                  <a:fillRect/>
+                </a:stretch>
+              </a:blipFill>
+              <a:ln>
+                <a:noFill/>
+              </a:ln>
+            </p:spPr>
+            <p:txBody>
+              <a:bodyPr/>
+              <a:lstStyle/>
+              <a:p>
+                <a:r>
+                  <a:rPr lang="en-US">
+                    <a:noFill/>
+                  </a:rPr>
+                  <a:t> </a:t>
+                </a:r>
+              </a:p>
+            </p:txBody>
+          </p:sp>
+        </mc:Fallback>
+      </mc:AlternateContent>
+      <p:sp>
+        <p:nvSpPr>
+          <p:cNvPr id="30" name="Title 29">
+            <a:extLst>
+              <a:ext uri="{FF2B5EF4-FFF2-40B4-BE49-F238E27FC236}">
+                <a16:creationId xmlns:a16="http://schemas.microsoft.com/office/drawing/2014/main" id="{84556FDF-D043-AC39-20A2-F718F0A89ADD}"/>
+              </a:ext>
+            </a:extLst>
+          </p:cNvPr>
+          <p:cNvSpPr>
+            <a:spLocks noGrp="1"/>
+          </p:cNvSpPr>
+          <p:nvPr>
+            <p:ph type="title"/>
+          </p:nvPr>
+        </p:nvSpPr>
+        <p:spPr/>
+        <p:txBody>
+          <a:bodyPr/>
+          <a:lstStyle/>
+          <a:p>
+            <a:r>
+              <a:rPr lang="en-US" dirty="0"/>
+              <a:t>Join Jacobian</a:t>
+            </a:r>
+          </a:p>
+        </p:txBody>
+      </p:sp>
+      <mc:AlternateContent xmlns:mc="http://schemas.openxmlformats.org/markup-compatibility/2006" xmlns:a14="http://schemas.microsoft.com/office/drawing/2010/main">
+        <mc:Choice Requires="a14">
+          <p:sp>
+            <p:nvSpPr>
+              <p:cNvPr id="2" name="Rectangle 1">
+                <a:extLst>
+                  <a:ext uri="{FF2B5EF4-FFF2-40B4-BE49-F238E27FC236}">
+                    <a16:creationId xmlns:a16="http://schemas.microsoft.com/office/drawing/2014/main" id="{C209E7F9-39BB-33E4-F812-00C4DAD25EEC}"/>
+                  </a:ext>
+                </a:extLst>
+              </p:cNvPr>
+              <p:cNvSpPr>
+                <a:spLocks/>
+              </p:cNvSpPr>
+              <p:nvPr/>
+            </p:nvSpPr>
+            <p:spPr>
+              <a:xfrm>
+                <a:off x="2865943" y="4641328"/>
+                <a:ext cx="1188720" cy="316831"/>
+              </a:xfrm>
+              <a:prstGeom prst="rect">
+                <a:avLst/>
+              </a:prstGeom>
+            </p:spPr>
+            <p:style>
+              <a:lnRef idx="2">
+                <a:schemeClr val="accent1">
+                  <a:shade val="15000"/>
+                </a:schemeClr>
+              </a:lnRef>
+              <a:fillRef idx="1">
+                <a:schemeClr val="accent1"/>
+              </a:fillRef>
+              <a:effectRef idx="0">
+                <a:schemeClr val="accent1"/>
+              </a:effectRef>
+              <a:fontRef idx="minor">
+                <a:schemeClr val="lt1"/>
+              </a:fontRef>
+            </p:style>
+            <p:txBody>
+              <a:bodyPr rtlCol="0" anchor="ctr"/>
+              <a:lstStyle/>
+              <a:p>
+                <a:pPr algn="ctr"/>
+                <a14:m>
+                  <m:oMathPara xmlns:m="http://schemas.openxmlformats.org/officeDocument/2006/math">
+                    <m:oMathParaPr>
+                      <m:jc m:val="centerGroup"/>
+                    </m:oMathParaPr>
+                    <m:oMath xmlns:m="http://schemas.openxmlformats.org/officeDocument/2006/math">
+                      <m:r>
+                        <a:rPr lang="en-US" i="1">
+                          <a:latin typeface="Cambria Math" panose="02040503050406030204" pitchFamily="18" charset="0"/>
+                          <a:ea typeface="Cambria Math" panose="02040503050406030204" pitchFamily="18" charset="0"/>
+                        </a:rPr>
+                        <m:t>ℳ</m:t>
+                      </m:r>
+                      <m:r>
+                        <a:rPr lang="en-US" i="1" baseline="-25000">
+                          <a:latin typeface="Cambria Math" panose="02040503050406030204" pitchFamily="18" charset="0"/>
+                          <a:ea typeface="Cambria Math" panose="02040503050406030204" pitchFamily="18" charset="0"/>
+                        </a:rPr>
+                        <m:t>1</m:t>
+                      </m:r>
+                      <m:r>
+                        <a:rPr lang="en-US" i="1">
+                          <a:latin typeface="Cambria Math" panose="02040503050406030204" pitchFamily="18" charset="0"/>
+                          <a:ea typeface="Cambria Math" panose="02040503050406030204" pitchFamily="18" charset="0"/>
+                        </a:rPr>
+                        <m:t>−</m:t>
+                      </m:r>
+                      <m:sSub>
+                        <m:sSubPr>
+                          <m:ctrlPr>
+                            <a:rPr lang="en-US" i="1">
+                              <a:latin typeface="Cambria Math" panose="02040503050406030204" pitchFamily="18" charset="0"/>
+                              <a:ea typeface="Cambria Math" panose="02040503050406030204" pitchFamily="18" charset="0"/>
+                            </a:rPr>
+                          </m:ctrlPr>
+                        </m:sSubPr>
+                        <m:e>
+                          <m:r>
+                            <a:rPr lang="en-US" i="1">
+                              <a:latin typeface="Cambria Math" panose="02040503050406030204" pitchFamily="18" charset="0"/>
+                              <a:ea typeface="Cambria Math" panose="02040503050406030204" pitchFamily="18" charset="0"/>
+                            </a:rPr>
+                            <m:t>𝑋</m:t>
+                          </m:r>
+                        </m:e>
+                        <m:sub>
+                          <m:r>
+                            <a:rPr lang="en-US" i="1">
+                              <a:latin typeface="Cambria Math" panose="02040503050406030204" pitchFamily="18" charset="0"/>
+                              <a:ea typeface="Cambria Math" panose="02040503050406030204" pitchFamily="18" charset="0"/>
+                            </a:rPr>
+                            <m:t>1</m:t>
+                          </m:r>
+                        </m:sub>
+                      </m:sSub>
+                    </m:oMath>
+                  </m:oMathPara>
+                </a14:m>
+                <a:endParaRPr lang="en-US" dirty="0"/>
+              </a:p>
+            </p:txBody>
+          </p:sp>
+        </mc:Choice>
+        <mc:Fallback xmlns="">
+          <p:sp>
+            <p:nvSpPr>
+              <p:cNvPr id="2" name="Rectangle 1">
+                <a:extLst>
+                  <a:ext uri="{FF2B5EF4-FFF2-40B4-BE49-F238E27FC236}">
+                    <a16:creationId xmlns:a16="http://schemas.microsoft.com/office/drawing/2014/main" id="{C209E7F9-39BB-33E4-F812-00C4DAD25EEC}"/>
+                  </a:ext>
+                </a:extLst>
+              </p:cNvPr>
+              <p:cNvSpPr>
+                <a:spLocks noRot="1" noChangeAspect="1" noMove="1" noResize="1" noEditPoints="1" noAdjustHandles="1" noChangeArrowheads="1" noChangeShapeType="1" noTextEdit="1"/>
+              </p:cNvSpPr>
+              <p:nvPr/>
+            </p:nvSpPr>
+            <p:spPr>
+              <a:xfrm>
+                <a:off x="2865943" y="4641328"/>
+                <a:ext cx="1188720" cy="316831"/>
+              </a:xfrm>
+              <a:prstGeom prst="rect">
+                <a:avLst/>
+              </a:prstGeom>
+              <a:blipFill>
+                <a:blip r:embed="rId8"/>
+                <a:stretch>
+                  <a:fillRect b="-7407"/>
+                </a:stretch>
+              </a:blipFill>
+            </p:spPr>
+            <p:txBody>
+              <a:bodyPr/>
+              <a:lstStyle/>
+              <a:p>
+                <a:r>
+                  <a:rPr lang="en-US">
+                    <a:noFill/>
+                  </a:rPr>
+                  <a:t> </a:t>
+                </a:r>
+              </a:p>
+            </p:txBody>
+          </p:sp>
+        </mc:Fallback>
+      </mc:AlternateContent>
+      <mc:AlternateContent xmlns:mc="http://schemas.openxmlformats.org/markup-compatibility/2006" xmlns:a14="http://schemas.microsoft.com/office/drawing/2010/main">
+        <mc:Choice Requires="a14">
+          <p:sp>
+            <p:nvSpPr>
+              <p:cNvPr id="3" name="Rectangle 2">
+                <a:extLst>
+                  <a:ext uri="{FF2B5EF4-FFF2-40B4-BE49-F238E27FC236}">
+                    <a16:creationId xmlns:a16="http://schemas.microsoft.com/office/drawing/2014/main" id="{59CE38E8-506A-B978-C685-69CF8B3309E0}"/>
+                  </a:ext>
+                </a:extLst>
+              </p:cNvPr>
+              <p:cNvSpPr>
+                <a:spLocks/>
+              </p:cNvSpPr>
+              <p:nvPr/>
+            </p:nvSpPr>
+            <p:spPr>
+              <a:xfrm>
+                <a:off x="4107343" y="4641327"/>
+                <a:ext cx="1188720" cy="316831"/>
+              </a:xfrm>
+              <a:prstGeom prst="rect">
+                <a:avLst/>
+              </a:prstGeom>
+              <a:solidFill>
+                <a:schemeClr val="accent2">
+                  <a:lumMod val="60000"/>
+                  <a:lumOff val="40000"/>
+                </a:schemeClr>
+              </a:solidFill>
+              <a:ln>
+                <a:noFill/>
+              </a:ln>
+            </p:spPr>
+            <p:style>
+              <a:lnRef idx="2">
+                <a:schemeClr val="accent1">
+                  <a:shade val="15000"/>
+                </a:schemeClr>
+              </a:lnRef>
+              <a:fillRef idx="1">
+                <a:schemeClr val="accent1"/>
+              </a:fillRef>
+              <a:effectRef idx="0">
+                <a:schemeClr val="accent1"/>
+              </a:effectRef>
+              <a:fontRef idx="minor">
+                <a:schemeClr val="lt1"/>
+              </a:fontRef>
+            </p:style>
+            <p:txBody>
+              <a:bodyPr rtlCol="0" anchor="ctr"/>
+              <a:lstStyle/>
+              <a:p>
+                <a:pPr algn="ctr"/>
+                <a14:m>
+                  <m:oMathPara xmlns:m="http://schemas.openxmlformats.org/officeDocument/2006/math">
+                    <m:oMathParaPr>
+                      <m:jc m:val="centerGroup"/>
+                    </m:oMathParaPr>
+                    <m:oMath xmlns:m="http://schemas.openxmlformats.org/officeDocument/2006/math">
+                      <m:r>
+                        <a:rPr lang="en-US" i="1">
+                          <a:latin typeface="Cambria Math" panose="02040503050406030204" pitchFamily="18" charset="0"/>
+                          <a:ea typeface="Cambria Math" panose="02040503050406030204" pitchFamily="18" charset="0"/>
+                        </a:rPr>
+                        <m:t>ℳ</m:t>
+                      </m:r>
+                      <m:r>
+                        <a:rPr lang="en-US" i="1" baseline="-25000">
+                          <a:latin typeface="Cambria Math" panose="02040503050406030204" pitchFamily="18" charset="0"/>
+                          <a:ea typeface="Cambria Math" panose="02040503050406030204" pitchFamily="18" charset="0"/>
+                        </a:rPr>
+                        <m:t>2</m:t>
+                      </m:r>
+                      <m:r>
+                        <a:rPr lang="en-US">
+                          <a:latin typeface="Cambria Math" panose="02040503050406030204" pitchFamily="18" charset="0"/>
+                          <a:ea typeface="Cambria Math" panose="02040503050406030204" pitchFamily="18" charset="0"/>
+                        </a:rPr>
+                        <m:t>−</m:t>
+                      </m:r>
+                      <m:r>
+                        <m:rPr>
+                          <m:sty m:val="p"/>
+                        </m:rPr>
+                        <a:rPr lang="en-US">
+                          <a:latin typeface="Cambria Math" panose="02040503050406030204" pitchFamily="18" charset="0"/>
+                          <a:ea typeface="Cambria Math" panose="02040503050406030204" pitchFamily="18" charset="0"/>
+                        </a:rPr>
+                        <m:t>X</m:t>
+                      </m:r>
+                      <m:r>
+                        <a:rPr lang="en-US" baseline="-25000">
+                          <a:latin typeface="Cambria Math" panose="02040503050406030204" pitchFamily="18" charset="0"/>
+                          <a:ea typeface="Cambria Math" panose="02040503050406030204" pitchFamily="18" charset="0"/>
+                        </a:rPr>
+                        <m:t>1</m:t>
+                      </m:r>
+                    </m:oMath>
+                  </m:oMathPara>
+                </a14:m>
+                <a:endParaRPr lang="en-US" baseline="-25000" dirty="0"/>
+              </a:p>
+            </p:txBody>
+          </p:sp>
+        </mc:Choice>
+        <mc:Fallback xmlns="">
+          <p:sp>
+            <p:nvSpPr>
+              <p:cNvPr id="3" name="Rectangle 2">
+                <a:extLst>
+                  <a:ext uri="{FF2B5EF4-FFF2-40B4-BE49-F238E27FC236}">
+                    <a16:creationId xmlns:a16="http://schemas.microsoft.com/office/drawing/2014/main" id="{59CE38E8-506A-B978-C685-69CF8B3309E0}"/>
+                  </a:ext>
+                </a:extLst>
+              </p:cNvPr>
+              <p:cNvSpPr>
+                <a:spLocks noRot="1" noChangeAspect="1" noMove="1" noResize="1" noEditPoints="1" noAdjustHandles="1" noChangeArrowheads="1" noChangeShapeType="1" noTextEdit="1"/>
+              </p:cNvSpPr>
+              <p:nvPr/>
+            </p:nvSpPr>
+            <p:spPr>
+              <a:xfrm>
+                <a:off x="4107343" y="4641327"/>
+                <a:ext cx="1188720" cy="316831"/>
+              </a:xfrm>
+              <a:prstGeom prst="rect">
+                <a:avLst/>
+              </a:prstGeom>
+              <a:blipFill>
+                <a:blip r:embed="rId9"/>
+                <a:stretch>
+                  <a:fillRect b="-3846"/>
+                </a:stretch>
+              </a:blipFill>
+              <a:ln>
+                <a:noFill/>
+              </a:ln>
+            </p:spPr>
+            <p:txBody>
+              <a:bodyPr/>
+              <a:lstStyle/>
+              <a:p>
+                <a:r>
+                  <a:rPr lang="en-US">
+                    <a:noFill/>
+                  </a:rPr>
+                  <a:t> </a:t>
+                </a:r>
+              </a:p>
+            </p:txBody>
+          </p:sp>
+        </mc:Fallback>
+      </mc:AlternateContent>
+      <p:sp>
+        <p:nvSpPr>
+          <p:cNvPr id="5" name="Rectangle 4">
+            <a:extLst>
+              <a:ext uri="{FF2B5EF4-FFF2-40B4-BE49-F238E27FC236}">
+                <a16:creationId xmlns:a16="http://schemas.microsoft.com/office/drawing/2014/main" id="{2F4F45E9-54B4-9A83-E8FC-36B7EC911A06}"/>
+              </a:ext>
+            </a:extLst>
+          </p:cNvPr>
+          <p:cNvSpPr>
+            <a:spLocks/>
+          </p:cNvSpPr>
+          <p:nvPr/>
+        </p:nvSpPr>
+        <p:spPr>
+          <a:xfrm rot="5400000">
+            <a:off x="4161726" y="3400976"/>
+            <a:ext cx="2801905" cy="300105"/>
+          </a:xfrm>
+          <a:prstGeom prst="rect">
+            <a:avLst/>
+          </a:prstGeom>
+          <a:solidFill>
+            <a:schemeClr val="bg1">
+              <a:lumMod val="85000"/>
+            </a:schemeClr>
+          </a:solidFill>
+          <a:ln>
+            <a:noFill/>
+          </a:ln>
+        </p:spPr>
+        <p:style>
+          <a:lnRef idx="2">
+            <a:schemeClr val="accent1">
+              <a:shade val="15000"/>
+            </a:schemeClr>
+          </a:lnRef>
+          <a:fillRef idx="1">
+            <a:schemeClr val="accent1"/>
+          </a:fillRef>
+          <a:effectRef idx="0">
+            <a:schemeClr val="accent1"/>
+          </a:effectRef>
+          <a:fontRef idx="minor">
+            <a:schemeClr val="lt1"/>
+          </a:fontRef>
+        </p:style>
+        <p:txBody>
+          <a:bodyPr rtlCol="0" anchor="ctr"/>
+          <a:lstStyle/>
+          <a:p>
+            <a:pPr algn="ctr"/>
+            <a:r>
+              <a:rPr lang="en-US" b="1" dirty="0">
+                <a:solidFill>
+                  <a:schemeClr val="tx1"/>
+                </a:solidFill>
+              </a:rPr>
+              <a:t>0</a:t>
+            </a:r>
+          </a:p>
+        </p:txBody>
+      </p:sp>
+    </p:spTree>
+    <p:extLst>
+      <p:ext uri="{BB962C8B-B14F-4D97-AF65-F5344CB8AC3E}">
+        <p14:creationId xmlns:p14="http://schemas.microsoft.com/office/powerpoint/2010/main" val="118654851"/>
+      </p:ext>
+    </p:extLst>
+  </p:cSld>
+  <p:clrMapOvr>
+    <a:masterClrMapping/>
+  </p:clrMapOvr>
+</p:sld>
+</file>
+
+<file path=ppt/slides/slide11.xml><?xml version="1.0" encoding="utf-8"?>
+<p:sld xmlns:a="http://schemas.openxmlformats.org/drawingml/2006/main" xmlns:r="http://schemas.openxmlformats.org/officeDocument/2006/relationships" xmlns:p="http://schemas.openxmlformats.org/presentationml/2006/main">
+  <p:cSld>
+    <p:spTree>
+      <p:nvGrpSpPr>
         <p:cNvPr id="1" name=""/>
         <p:cNvGrpSpPr/>
         <p:nvPr/>
@@ -6105,7 +7141,7 @@
 </p:sld>
 </file>
 
-<file path=ppt/slides/slide11.xml><?xml version="1.0" encoding="utf-8"?>
+<file path=ppt/slides/slide12.xml><?xml version="1.0" encoding="utf-8"?>
 <p:sld xmlns:a="http://schemas.openxmlformats.org/drawingml/2006/main" xmlns:r="http://schemas.openxmlformats.org/officeDocument/2006/relationships" xmlns:p="http://schemas.openxmlformats.org/presentationml/2006/main">
   <p:cSld>
     <p:spTree>
@@ -8243,7 +9279,7 @@
 </p:sld>
 </file>
 
-<file path=ppt/slides/slide12.xml><?xml version="1.0" encoding="utf-8"?>
+<file path=ppt/slides/slide13.xml><?xml version="1.0" encoding="utf-8"?>
 <p:sld xmlns:a="http://schemas.openxmlformats.org/drawingml/2006/main" xmlns:r="http://schemas.openxmlformats.org/officeDocument/2006/relationships" xmlns:p="http://schemas.openxmlformats.org/presentationml/2006/main">
   <p:cSld>
     <p:spTree>
@@ -8301,7 +9337,7 @@
 </p:sld>
 </file>
 
-<file path=ppt/slides/slide13.xml><?xml version="1.0" encoding="utf-8"?>
+<file path=ppt/slides/slide14.xml><?xml version="1.0" encoding="utf-8"?>
 <p:sld xmlns:a="http://schemas.openxmlformats.org/drawingml/2006/main" xmlns:r="http://schemas.openxmlformats.org/officeDocument/2006/relationships" xmlns:p="http://schemas.openxmlformats.org/presentationml/2006/main">
   <p:cSld>
     <p:spTree>
@@ -17859,6 +18895,2226 @@
   <p:cSld>
     <p:spTree>
       <p:nvGrpSpPr>
+        <p:cNvPr id="1" name="">
+          <a:extLst>
+            <a:ext uri="{FF2B5EF4-FFF2-40B4-BE49-F238E27FC236}">
+              <a16:creationId xmlns:a16="http://schemas.microsoft.com/office/drawing/2014/main" id="{6FEEAA66-5526-2C67-D376-B86D095D52DA}"/>
+            </a:ext>
+          </a:extLst>
+        </p:cNvPr>
+        <p:cNvGrpSpPr/>
+        <p:nvPr/>
+      </p:nvGrpSpPr>
+      <p:grpSpPr>
+        <a:xfrm>
+          <a:off x="0" y="0"/>
+          <a:ext cx="0" cy="0"/>
+          <a:chOff x="0" y="0"/>
+          <a:chExt cx="0" cy="0"/>
+        </a:xfrm>
+      </p:grpSpPr>
+      <p:pic>
+        <p:nvPicPr>
+          <p:cNvPr id="9" name="Picture 8">
+            <a:extLst>
+              <a:ext uri="{FF2B5EF4-FFF2-40B4-BE49-F238E27FC236}">
+                <a16:creationId xmlns:a16="http://schemas.microsoft.com/office/drawing/2014/main" id="{A0537A71-522E-8D11-0F62-EEB19375C494}"/>
+              </a:ext>
+            </a:extLst>
+          </p:cNvPr>
+          <p:cNvPicPr>
+            <a:picLocks noChangeAspect="1"/>
+          </p:cNvPicPr>
+          <p:nvPr/>
+        </p:nvPicPr>
+        <p:blipFill>
+          <a:blip r:embed="rId2"/>
+          <a:stretch>
+            <a:fillRect/>
+          </a:stretch>
+        </p:blipFill>
+        <p:spPr>
+          <a:xfrm>
+            <a:off x="1246096" y="1056939"/>
+            <a:ext cx="582882" cy="521304"/>
+          </a:xfrm>
+          <a:prstGeom prst="rect">
+            <a:avLst/>
+          </a:prstGeom>
+        </p:spPr>
+      </p:pic>
+      <p:pic>
+        <p:nvPicPr>
+          <p:cNvPr id="10" name="Picture 9">
+            <a:extLst>
+              <a:ext uri="{FF2B5EF4-FFF2-40B4-BE49-F238E27FC236}">
+                <a16:creationId xmlns:a16="http://schemas.microsoft.com/office/drawing/2014/main" id="{A2CEC523-43CD-9FAE-8E55-2E044AA0EAF1}"/>
+              </a:ext>
+            </a:extLst>
+          </p:cNvPr>
+          <p:cNvPicPr>
+            <a:picLocks noChangeAspect="1"/>
+          </p:cNvPicPr>
+          <p:nvPr/>
+        </p:nvPicPr>
+        <p:blipFill>
+          <a:blip r:embed="rId3"/>
+          <a:stretch>
+            <a:fillRect/>
+          </a:stretch>
+        </p:blipFill>
+        <p:spPr>
+          <a:xfrm>
+            <a:off x="3404650" y="1060916"/>
+            <a:ext cx="678355" cy="513350"/>
+          </a:xfrm>
+          <a:prstGeom prst="rect">
+            <a:avLst/>
+          </a:prstGeom>
+        </p:spPr>
+      </p:pic>
+      <p:pic>
+        <p:nvPicPr>
+          <p:cNvPr id="13" name="Picture 12">
+            <a:extLst>
+              <a:ext uri="{FF2B5EF4-FFF2-40B4-BE49-F238E27FC236}">
+                <a16:creationId xmlns:a16="http://schemas.microsoft.com/office/drawing/2014/main" id="{A9413D6C-F406-36FE-FA93-D29F9EB2B1CD}"/>
+              </a:ext>
+            </a:extLst>
+          </p:cNvPr>
+          <p:cNvPicPr>
+            <a:picLocks noChangeAspect="1"/>
+          </p:cNvPicPr>
+          <p:nvPr/>
+        </p:nvPicPr>
+        <p:blipFill>
+          <a:blip r:embed="rId4"/>
+          <a:stretch>
+            <a:fillRect/>
+          </a:stretch>
+        </p:blipFill>
+        <p:spPr>
+          <a:xfrm>
+            <a:off x="4793406" y="1056939"/>
+            <a:ext cx="688866" cy="521304"/>
+          </a:xfrm>
+          <a:prstGeom prst="rect">
+            <a:avLst/>
+          </a:prstGeom>
+        </p:spPr>
+      </p:pic>
+      <p:pic>
+        <p:nvPicPr>
+          <p:cNvPr id="16" name="Picture 15">
+            <a:extLst>
+              <a:ext uri="{FF2B5EF4-FFF2-40B4-BE49-F238E27FC236}">
+                <a16:creationId xmlns:a16="http://schemas.microsoft.com/office/drawing/2014/main" id="{34117D4B-C9B7-5B0D-1FCB-A3ED22DBB1A7}"/>
+              </a:ext>
+            </a:extLst>
+          </p:cNvPr>
+          <p:cNvPicPr>
+            <a:picLocks noChangeAspect="1"/>
+          </p:cNvPicPr>
+          <p:nvPr/>
+        </p:nvPicPr>
+        <p:blipFill>
+          <a:blip r:embed="rId5"/>
+          <a:stretch>
+            <a:fillRect/>
+          </a:stretch>
+        </p:blipFill>
+        <p:spPr>
+          <a:xfrm>
+            <a:off x="6247125" y="1056939"/>
+            <a:ext cx="688866" cy="521304"/>
+          </a:xfrm>
+          <a:prstGeom prst="rect">
+            <a:avLst/>
+          </a:prstGeom>
+        </p:spPr>
+      </p:pic>
+      <p:sp>
+        <p:nvSpPr>
+          <p:cNvPr id="21" name="TextBox 20">
+            <a:extLst>
+              <a:ext uri="{FF2B5EF4-FFF2-40B4-BE49-F238E27FC236}">
+                <a16:creationId xmlns:a16="http://schemas.microsoft.com/office/drawing/2014/main" id="{8B891D4C-773D-064C-4170-5C558A25E1EC}"/>
+              </a:ext>
+            </a:extLst>
+          </p:cNvPr>
+          <p:cNvSpPr txBox="1"/>
+          <p:nvPr/>
+        </p:nvSpPr>
+        <p:spPr>
+          <a:xfrm>
+            <a:off x="-23382" y="1163703"/>
+            <a:ext cx="1084079" cy="307777"/>
+          </a:xfrm>
+          <a:prstGeom prst="rect">
+            <a:avLst/>
+          </a:prstGeom>
+          <a:noFill/>
+        </p:spPr>
+        <p:txBody>
+          <a:bodyPr wrap="none" rtlCol="0">
+            <a:spAutoFit/>
+          </a:bodyPr>
+          <a:lstStyle/>
+          <a:p>
+            <a:r>
+              <a:rPr lang="en-US" sz="1400" b="1" dirty="0"/>
+              <a:t>Time course</a:t>
+            </a:r>
+          </a:p>
+        </p:txBody>
+      </p:sp>
+      <p:sp>
+        <p:nvSpPr>
+          <p:cNvPr id="23" name="TextBox 22">
+            <a:extLst>
+              <a:ext uri="{FF2B5EF4-FFF2-40B4-BE49-F238E27FC236}">
+                <a16:creationId xmlns:a16="http://schemas.microsoft.com/office/drawing/2014/main" id="{E1265B11-B276-4D31-3F71-6EA4C32716F5}"/>
+              </a:ext>
+            </a:extLst>
+          </p:cNvPr>
+          <p:cNvSpPr txBox="1"/>
+          <p:nvPr/>
+        </p:nvSpPr>
+        <p:spPr>
+          <a:xfrm>
+            <a:off x="-23382" y="1652159"/>
+            <a:ext cx="757067" cy="307777"/>
+          </a:xfrm>
+          <a:prstGeom prst="rect">
+            <a:avLst/>
+          </a:prstGeom>
+          <a:noFill/>
+        </p:spPr>
+        <p:txBody>
+          <a:bodyPr wrap="none" rtlCol="0">
+            <a:spAutoFit/>
+          </a:bodyPr>
+          <a:lstStyle/>
+          <a:p>
+            <a:r>
+              <a:rPr lang="en-US" sz="1400" b="1" dirty="0"/>
+              <a:t>G. disks</a:t>
+            </a:r>
+          </a:p>
+        </p:txBody>
+      </p:sp>
+      <p:sp>
+        <p:nvSpPr>
+          <p:cNvPr id="31" name="TextBox 30">
+            <a:extLst>
+              <a:ext uri="{FF2B5EF4-FFF2-40B4-BE49-F238E27FC236}">
+                <a16:creationId xmlns:a16="http://schemas.microsoft.com/office/drawing/2014/main" id="{8767C2D0-FF89-456B-1CA6-C93826223EDB}"/>
+              </a:ext>
+            </a:extLst>
+          </p:cNvPr>
+          <p:cNvSpPr txBox="1"/>
+          <p:nvPr/>
+        </p:nvSpPr>
+        <p:spPr>
+          <a:xfrm>
+            <a:off x="-23382" y="1994298"/>
+            <a:ext cx="492827" cy="307777"/>
+          </a:xfrm>
+          <a:prstGeom prst="rect">
+            <a:avLst/>
+          </a:prstGeom>
+          <a:noFill/>
+        </p:spPr>
+        <p:txBody>
+          <a:bodyPr wrap="none" rtlCol="0">
+            <a:spAutoFit/>
+          </a:bodyPr>
+          <a:lstStyle/>
+          <a:p>
+            <a:r>
+              <a:rPr lang="en-US" sz="1400" b="1" dirty="0"/>
+              <a:t>Sets</a:t>
+            </a:r>
+          </a:p>
+        </p:txBody>
+      </p:sp>
+      <mc:AlternateContent xmlns:mc="http://schemas.openxmlformats.org/markup-compatibility/2006">
+        <mc:Choice xmlns:a14="http://schemas.microsoft.com/office/drawing/2010/main" Requires="a14">
+          <p:sp>
+            <p:nvSpPr>
+              <p:cNvPr id="33" name="TextBox 32">
+                <a:extLst>
+                  <a:ext uri="{FF2B5EF4-FFF2-40B4-BE49-F238E27FC236}">
+                    <a16:creationId xmlns:a16="http://schemas.microsoft.com/office/drawing/2014/main" id="{6943BFDF-6A1C-E1C5-B96A-610FE418339B}"/>
+                  </a:ext>
+                </a:extLst>
+              </p:cNvPr>
+              <p:cNvSpPr txBox="1"/>
+              <p:nvPr/>
+            </p:nvSpPr>
+            <p:spPr>
+              <a:xfrm>
+                <a:off x="1246096" y="2040464"/>
+                <a:ext cx="767711" cy="215444"/>
+              </a:xfrm>
+              <a:prstGeom prst="rect">
+                <a:avLst/>
+              </a:prstGeom>
+              <a:noFill/>
+            </p:spPr>
+            <p:txBody>
+              <a:bodyPr wrap="none" lIns="0" tIns="0" rIns="0" bIns="0" rtlCol="0">
+                <a:spAutoFit/>
+              </a:bodyPr>
+              <a:lstStyle/>
+              <a:p>
+                <a14:m>
+                  <m:oMathPara xmlns:m="http://schemas.openxmlformats.org/officeDocument/2006/math">
+                    <m:oMathParaPr>
+                      <m:jc m:val="centerGroup"/>
+                    </m:oMathParaPr>
+                    <m:oMath xmlns:m="http://schemas.openxmlformats.org/officeDocument/2006/math">
+                      <m:r>
+                        <m:rPr>
+                          <m:sty m:val="p"/>
+                        </m:rPr>
+                        <a:rPr lang="en-US" sz="1400" b="0" i="1" smtClean="0">
+                          <a:latin typeface="Cambria Math" panose="02040503050406030204" pitchFamily="18" charset="0"/>
+                        </a:rPr>
+                        <m:t>S</m:t>
+                      </m:r>
+                      <m:r>
+                        <a:rPr lang="en-US" sz="1400" b="0" i="1" smtClean="0">
+                          <a:latin typeface="Cambria Math" panose="02040503050406030204" pitchFamily="18" charset="0"/>
+                        </a:rPr>
+                        <m:t>={1, 2}</m:t>
+                      </m:r>
+                    </m:oMath>
+                  </m:oMathPara>
+                </a14:m>
+                <a:endParaRPr lang="en-US" sz="1400" dirty="0"/>
+              </a:p>
+            </p:txBody>
+          </p:sp>
+        </mc:Choice>
+        <mc:Fallback>
+          <p:sp>
+            <p:nvSpPr>
+              <p:cNvPr id="33" name="TextBox 32">
+                <a:extLst>
+                  <a:ext uri="{FF2B5EF4-FFF2-40B4-BE49-F238E27FC236}">
+                    <a16:creationId xmlns:a16="http://schemas.microsoft.com/office/drawing/2014/main" id="{6943BFDF-6A1C-E1C5-B96A-610FE418339B}"/>
+                  </a:ext>
+                </a:extLst>
+              </p:cNvPr>
+              <p:cNvSpPr txBox="1">
+                <a:spLocks noRot="1" noChangeAspect="1" noMove="1" noResize="1" noEditPoints="1" noAdjustHandles="1" noChangeArrowheads="1" noChangeShapeType="1" noTextEdit="1"/>
+              </p:cNvSpPr>
+              <p:nvPr/>
+            </p:nvSpPr>
+            <p:spPr>
+              <a:xfrm>
+                <a:off x="1246096" y="2040464"/>
+                <a:ext cx="767711" cy="215444"/>
+              </a:xfrm>
+              <a:prstGeom prst="rect">
+                <a:avLst/>
+              </a:prstGeom>
+              <a:blipFill>
+                <a:blip r:embed="rId6"/>
+                <a:stretch>
+                  <a:fillRect l="-3226" r="-8065" b="-33333"/>
+                </a:stretch>
+              </a:blipFill>
+            </p:spPr>
+            <p:txBody>
+              <a:bodyPr/>
+              <a:lstStyle/>
+              <a:p>
+                <a:r>
+                  <a:rPr lang="en-US">
+                    <a:noFill/>
+                  </a:rPr>
+                  <a:t> </a:t>
+                </a:r>
+              </a:p>
+            </p:txBody>
+          </p:sp>
+        </mc:Fallback>
+      </mc:AlternateContent>
+      <p:sp>
+        <p:nvSpPr>
+          <p:cNvPr id="35" name="TextBox 34">
+            <a:extLst>
+              <a:ext uri="{FF2B5EF4-FFF2-40B4-BE49-F238E27FC236}">
+                <a16:creationId xmlns:a16="http://schemas.microsoft.com/office/drawing/2014/main" id="{5090C8B5-3D20-5F01-3EC1-DA317C4C4E66}"/>
+              </a:ext>
+            </a:extLst>
+          </p:cNvPr>
+          <p:cNvSpPr txBox="1"/>
+          <p:nvPr/>
+        </p:nvSpPr>
+        <p:spPr>
+          <a:xfrm>
+            <a:off x="-23382" y="2769695"/>
+            <a:ext cx="948914" cy="307777"/>
+          </a:xfrm>
+          <a:prstGeom prst="rect">
+            <a:avLst/>
+          </a:prstGeom>
+          <a:noFill/>
+        </p:spPr>
+        <p:txBody>
+          <a:bodyPr wrap="none" rtlCol="0">
+            <a:spAutoFit/>
+          </a:bodyPr>
+          <a:lstStyle/>
+          <a:p>
+            <a:r>
+              <a:rPr lang="en-US" sz="1400" b="1" dirty="0"/>
+              <a:t>Prediction</a:t>
+            </a:r>
+          </a:p>
+        </p:txBody>
+      </p:sp>
+      <p:sp>
+        <p:nvSpPr>
+          <p:cNvPr id="36" name="TextBox 35">
+            <a:extLst>
+              <a:ext uri="{FF2B5EF4-FFF2-40B4-BE49-F238E27FC236}">
+                <a16:creationId xmlns:a16="http://schemas.microsoft.com/office/drawing/2014/main" id="{58827862-2632-1F33-7139-D924E4C53EB1}"/>
+              </a:ext>
+            </a:extLst>
+          </p:cNvPr>
+          <p:cNvSpPr txBox="1"/>
+          <p:nvPr/>
+        </p:nvSpPr>
+        <p:spPr>
+          <a:xfrm>
+            <a:off x="1150401" y="2783675"/>
+            <a:ext cx="644728" cy="307777"/>
+          </a:xfrm>
+          <a:prstGeom prst="rect">
+            <a:avLst/>
+          </a:prstGeom>
+          <a:noFill/>
+        </p:spPr>
+        <p:txBody>
+          <a:bodyPr wrap="none" rtlCol="0">
+            <a:spAutoFit/>
+          </a:bodyPr>
+          <a:lstStyle/>
+          <a:p>
+            <a:r>
+              <a:rPr lang="en-US" sz="1400" b="1" dirty="0"/>
+              <a:t>S</a:t>
+            </a:r>
+            <a:r>
+              <a:rPr lang="en-US" sz="1400" dirty="0"/>
+              <a:t>table</a:t>
+            </a:r>
+          </a:p>
+        </p:txBody>
+      </p:sp>
+      <mc:AlternateContent xmlns:mc="http://schemas.openxmlformats.org/markup-compatibility/2006">
+        <mc:Choice xmlns:a14="http://schemas.microsoft.com/office/drawing/2010/main" Requires="a14">
+          <p:sp>
+            <p:nvSpPr>
+              <p:cNvPr id="37" name="TextBox 36">
+                <a:extLst>
+                  <a:ext uri="{FF2B5EF4-FFF2-40B4-BE49-F238E27FC236}">
+                    <a16:creationId xmlns:a16="http://schemas.microsoft.com/office/drawing/2014/main" id="{0A837C99-0984-AE6C-10F0-1FB15505FB63}"/>
+                  </a:ext>
+                </a:extLst>
+              </p:cNvPr>
+              <p:cNvSpPr txBox="1"/>
+              <p:nvPr/>
+            </p:nvSpPr>
+            <p:spPr>
+              <a:xfrm>
+                <a:off x="1246096" y="1698325"/>
+                <a:ext cx="1869166" cy="215444"/>
+              </a:xfrm>
+              <a:prstGeom prst="rect">
+                <a:avLst/>
+              </a:prstGeom>
+              <a:noFill/>
+            </p:spPr>
+            <p:txBody>
+              <a:bodyPr wrap="none" lIns="0" tIns="0" rIns="0" bIns="0" rtlCol="0">
+                <a:spAutoFit/>
+              </a:bodyPr>
+              <a:lstStyle/>
+              <a:p>
+                <a14:m>
+                  <m:oMathPara xmlns:m="http://schemas.openxmlformats.org/officeDocument/2006/math">
+                    <m:oMathParaPr>
+                      <m:jc m:val="centerGroup"/>
+                    </m:oMathParaPr>
+                    <m:oMath xmlns:m="http://schemas.openxmlformats.org/officeDocument/2006/math">
+                      <m:r>
+                        <a:rPr lang="en-US" sz="1400" b="0" i="1" smtClean="0">
+                          <a:latin typeface="Cambria Math" panose="02040503050406030204" pitchFamily="18" charset="0"/>
+                        </a:rPr>
+                        <m:t>[-1.5, -0.5], [-2.25, -0.25]</m:t>
+                      </m:r>
+                    </m:oMath>
+                  </m:oMathPara>
+                </a14:m>
+                <a:endParaRPr lang="en-US" sz="1400" dirty="0"/>
+              </a:p>
+            </p:txBody>
+          </p:sp>
+        </mc:Choice>
+        <mc:Fallback>
+          <p:sp>
+            <p:nvSpPr>
+              <p:cNvPr id="37" name="TextBox 36">
+                <a:extLst>
+                  <a:ext uri="{FF2B5EF4-FFF2-40B4-BE49-F238E27FC236}">
+                    <a16:creationId xmlns:a16="http://schemas.microsoft.com/office/drawing/2014/main" id="{0A837C99-0984-AE6C-10F0-1FB15505FB63}"/>
+                  </a:ext>
+                </a:extLst>
+              </p:cNvPr>
+              <p:cNvSpPr txBox="1">
+                <a:spLocks noRot="1" noChangeAspect="1" noMove="1" noResize="1" noEditPoints="1" noAdjustHandles="1" noChangeArrowheads="1" noChangeShapeType="1" noTextEdit="1"/>
+              </p:cNvSpPr>
+              <p:nvPr/>
+            </p:nvSpPr>
+            <p:spPr>
+              <a:xfrm>
+                <a:off x="1246096" y="1698325"/>
+                <a:ext cx="1869166" cy="215444"/>
+              </a:xfrm>
+              <a:prstGeom prst="rect">
+                <a:avLst/>
+              </a:prstGeom>
+              <a:blipFill>
+                <a:blip r:embed="rId7"/>
+                <a:stretch>
+                  <a:fillRect l="-2685" r="-2685" b="-33333"/>
+                </a:stretch>
+              </a:blipFill>
+            </p:spPr>
+            <p:txBody>
+              <a:bodyPr/>
+              <a:lstStyle/>
+              <a:p>
+                <a:r>
+                  <a:rPr lang="en-US">
+                    <a:noFill/>
+                  </a:rPr>
+                  <a:t> </a:t>
+                </a:r>
+              </a:p>
+            </p:txBody>
+          </p:sp>
+        </mc:Fallback>
+      </mc:AlternateContent>
+      <mc:AlternateContent xmlns:mc="http://schemas.openxmlformats.org/markup-compatibility/2006">
+        <mc:Choice xmlns:a14="http://schemas.microsoft.com/office/drawing/2010/main" Requires="a14">
+          <p:sp>
+            <p:nvSpPr>
+              <p:cNvPr id="44" name="TextBox 43">
+                <a:extLst>
+                  <a:ext uri="{FF2B5EF4-FFF2-40B4-BE49-F238E27FC236}">
+                    <a16:creationId xmlns:a16="http://schemas.microsoft.com/office/drawing/2014/main" id="{2D1D788B-D9D2-24AD-30BE-E86D75D1A4DC}"/>
+                  </a:ext>
+                </a:extLst>
+              </p:cNvPr>
+              <p:cNvSpPr txBox="1"/>
+              <p:nvPr/>
+            </p:nvSpPr>
+            <p:spPr>
+              <a:xfrm>
+                <a:off x="3404650" y="1698325"/>
+                <a:ext cx="858184" cy="215444"/>
+              </a:xfrm>
+              <a:prstGeom prst="rect">
+                <a:avLst/>
+              </a:prstGeom>
+              <a:noFill/>
+            </p:spPr>
+            <p:txBody>
+              <a:bodyPr wrap="none" lIns="0" tIns="0" rIns="0" bIns="0" rtlCol="0">
+                <a:spAutoFit/>
+              </a:bodyPr>
+              <a:lstStyle/>
+              <a:p>
+                <a14:m>
+                  <m:oMathPara xmlns:m="http://schemas.openxmlformats.org/officeDocument/2006/math">
+                    <m:oMathParaPr>
+                      <m:jc m:val="centerGroup"/>
+                    </m:oMathParaPr>
+                    <m:oMath xmlns:m="http://schemas.openxmlformats.org/officeDocument/2006/math">
+                      <m:r>
+                        <a:rPr lang="en-US" sz="1400" b="0" i="1" smtClean="0">
+                          <a:latin typeface="Cambria Math" panose="02040503050406030204" pitchFamily="18" charset="0"/>
+                        </a:rPr>
+                        <m:t>[2,4], [1, 3]</m:t>
+                      </m:r>
+                    </m:oMath>
+                  </m:oMathPara>
+                </a14:m>
+                <a:endParaRPr lang="en-US" sz="1400" dirty="0"/>
+              </a:p>
+            </p:txBody>
+          </p:sp>
+        </mc:Choice>
+        <mc:Fallback>
+          <p:sp>
+            <p:nvSpPr>
+              <p:cNvPr id="44" name="TextBox 43">
+                <a:extLst>
+                  <a:ext uri="{FF2B5EF4-FFF2-40B4-BE49-F238E27FC236}">
+                    <a16:creationId xmlns:a16="http://schemas.microsoft.com/office/drawing/2014/main" id="{2D1D788B-D9D2-24AD-30BE-E86D75D1A4DC}"/>
+                  </a:ext>
+                </a:extLst>
+              </p:cNvPr>
+              <p:cNvSpPr txBox="1">
+                <a:spLocks noRot="1" noChangeAspect="1" noMove="1" noResize="1" noEditPoints="1" noAdjustHandles="1" noChangeArrowheads="1" noChangeShapeType="1" noTextEdit="1"/>
+              </p:cNvSpPr>
+              <p:nvPr/>
+            </p:nvSpPr>
+            <p:spPr>
+              <a:xfrm>
+                <a:off x="3404650" y="1698325"/>
+                <a:ext cx="858184" cy="215444"/>
+              </a:xfrm>
+              <a:prstGeom prst="rect">
+                <a:avLst/>
+              </a:prstGeom>
+              <a:blipFill>
+                <a:blip r:embed="rId8"/>
+                <a:stretch>
+                  <a:fillRect l="-7353" r="-7353" b="-33333"/>
+                </a:stretch>
+              </a:blipFill>
+            </p:spPr>
+            <p:txBody>
+              <a:bodyPr/>
+              <a:lstStyle/>
+              <a:p>
+                <a:r>
+                  <a:rPr lang="en-US">
+                    <a:noFill/>
+                  </a:rPr>
+                  <a:t> </a:t>
+                </a:r>
+              </a:p>
+            </p:txBody>
+          </p:sp>
+        </mc:Fallback>
+      </mc:AlternateContent>
+      <mc:AlternateContent xmlns:mc="http://schemas.openxmlformats.org/markup-compatibility/2006">
+        <mc:Choice xmlns:a14="http://schemas.microsoft.com/office/drawing/2010/main" Requires="a14">
+          <p:sp>
+            <p:nvSpPr>
+              <p:cNvPr id="49" name="TextBox 48">
+                <a:extLst>
+                  <a:ext uri="{FF2B5EF4-FFF2-40B4-BE49-F238E27FC236}">
+                    <a16:creationId xmlns:a16="http://schemas.microsoft.com/office/drawing/2014/main" id="{14B27A4F-05FD-6264-B9C3-32A6DB2D584F}"/>
+                  </a:ext>
+                </a:extLst>
+              </p:cNvPr>
+              <p:cNvSpPr txBox="1"/>
+              <p:nvPr/>
+            </p:nvSpPr>
+            <p:spPr>
+              <a:xfrm>
+                <a:off x="4793406" y="1698325"/>
+                <a:ext cx="917495" cy="215444"/>
+              </a:xfrm>
+              <a:prstGeom prst="rect">
+                <a:avLst/>
+              </a:prstGeom>
+              <a:noFill/>
+            </p:spPr>
+            <p:txBody>
+              <a:bodyPr wrap="none" lIns="0" tIns="0" rIns="0" bIns="0" rtlCol="0">
+                <a:spAutoFit/>
+              </a:bodyPr>
+              <a:lstStyle/>
+              <a:p>
+                <a14:m>
+                  <m:oMathPara xmlns:m="http://schemas.openxmlformats.org/officeDocument/2006/math">
+                    <m:oMathParaPr>
+                      <m:jc m:val="centerGroup"/>
+                    </m:oMathParaPr>
+                    <m:oMath xmlns:m="http://schemas.openxmlformats.org/officeDocument/2006/math">
+                      <m:r>
+                        <a:rPr lang="en-US" sz="1400" b="0" i="1" smtClean="0">
+                          <a:latin typeface="Cambria Math" panose="02040503050406030204" pitchFamily="18" charset="0"/>
+                        </a:rPr>
+                        <m:t>[2,4], [-1, 1]</m:t>
+                      </m:r>
+                    </m:oMath>
+                  </m:oMathPara>
+                </a14:m>
+                <a:endParaRPr lang="en-US" sz="1400" dirty="0"/>
+              </a:p>
+            </p:txBody>
+          </p:sp>
+        </mc:Choice>
+        <mc:Fallback>
+          <p:sp>
+            <p:nvSpPr>
+              <p:cNvPr id="49" name="TextBox 48">
+                <a:extLst>
+                  <a:ext uri="{FF2B5EF4-FFF2-40B4-BE49-F238E27FC236}">
+                    <a16:creationId xmlns:a16="http://schemas.microsoft.com/office/drawing/2014/main" id="{14B27A4F-05FD-6264-B9C3-32A6DB2D584F}"/>
+                  </a:ext>
+                </a:extLst>
+              </p:cNvPr>
+              <p:cNvSpPr txBox="1">
+                <a:spLocks noRot="1" noChangeAspect="1" noMove="1" noResize="1" noEditPoints="1" noAdjustHandles="1" noChangeArrowheads="1" noChangeShapeType="1" noTextEdit="1"/>
+              </p:cNvSpPr>
+              <p:nvPr/>
+            </p:nvSpPr>
+            <p:spPr>
+              <a:xfrm>
+                <a:off x="4793406" y="1698325"/>
+                <a:ext cx="917495" cy="215444"/>
+              </a:xfrm>
+              <a:prstGeom prst="rect">
+                <a:avLst/>
+              </a:prstGeom>
+              <a:blipFill>
+                <a:blip r:embed="rId9"/>
+                <a:stretch>
+                  <a:fillRect l="-6849" r="-6849" b="-33333"/>
+                </a:stretch>
+              </a:blipFill>
+            </p:spPr>
+            <p:txBody>
+              <a:bodyPr/>
+              <a:lstStyle/>
+              <a:p>
+                <a:r>
+                  <a:rPr lang="en-US">
+                    <a:noFill/>
+                  </a:rPr>
+                  <a:t> </a:t>
+                </a:r>
+              </a:p>
+            </p:txBody>
+          </p:sp>
+        </mc:Fallback>
+      </mc:AlternateContent>
+      <mc:AlternateContent xmlns:mc="http://schemas.openxmlformats.org/markup-compatibility/2006">
+        <mc:Choice xmlns:a14="http://schemas.microsoft.com/office/drawing/2010/main" Requires="a14">
+          <p:sp>
+            <p:nvSpPr>
+              <p:cNvPr id="50" name="TextBox 49">
+                <a:extLst>
+                  <a:ext uri="{FF2B5EF4-FFF2-40B4-BE49-F238E27FC236}">
+                    <a16:creationId xmlns:a16="http://schemas.microsoft.com/office/drawing/2014/main" id="{A87E03D8-A38E-4E75-199A-8F6DD9C8DE1C}"/>
+                  </a:ext>
+                </a:extLst>
+              </p:cNvPr>
+              <p:cNvSpPr txBox="1"/>
+              <p:nvPr/>
+            </p:nvSpPr>
+            <p:spPr>
+              <a:xfrm>
+                <a:off x="6247125" y="1698325"/>
+                <a:ext cx="1624419" cy="215444"/>
+              </a:xfrm>
+              <a:prstGeom prst="rect">
+                <a:avLst/>
+              </a:prstGeom>
+              <a:noFill/>
+            </p:spPr>
+            <p:txBody>
+              <a:bodyPr wrap="none" lIns="0" tIns="0" rIns="0" bIns="0" rtlCol="0">
+                <a:spAutoFit/>
+              </a:bodyPr>
+              <a:lstStyle/>
+              <a:p>
+                <a14:m>
+                  <m:oMathPara xmlns:m="http://schemas.openxmlformats.org/officeDocument/2006/math">
+                    <m:oMathParaPr>
+                      <m:jc m:val="centerGroup"/>
+                    </m:oMathParaPr>
+                    <m:oMath xmlns:m="http://schemas.openxmlformats.org/officeDocument/2006/math">
+                      <m:r>
+                        <a:rPr lang="en-US" sz="1400" b="0" i="1" smtClean="0">
+                          <a:latin typeface="Cambria Math" panose="02040503050406030204" pitchFamily="18" charset="0"/>
+                        </a:rPr>
+                        <m:t>[-4.4,-1.6], [-0.4, 0.4]</m:t>
+                      </m:r>
+                    </m:oMath>
+                  </m:oMathPara>
+                </a14:m>
+                <a:endParaRPr lang="en-US" sz="1400" dirty="0"/>
+              </a:p>
+            </p:txBody>
+          </p:sp>
+        </mc:Choice>
+        <mc:Fallback>
+          <p:sp>
+            <p:nvSpPr>
+              <p:cNvPr id="50" name="TextBox 49">
+                <a:extLst>
+                  <a:ext uri="{FF2B5EF4-FFF2-40B4-BE49-F238E27FC236}">
+                    <a16:creationId xmlns:a16="http://schemas.microsoft.com/office/drawing/2014/main" id="{A87E03D8-A38E-4E75-199A-8F6DD9C8DE1C}"/>
+                  </a:ext>
+                </a:extLst>
+              </p:cNvPr>
+              <p:cNvSpPr txBox="1">
+                <a:spLocks noRot="1" noChangeAspect="1" noMove="1" noResize="1" noEditPoints="1" noAdjustHandles="1" noChangeArrowheads="1" noChangeShapeType="1" noTextEdit="1"/>
+              </p:cNvSpPr>
+              <p:nvPr/>
+            </p:nvSpPr>
+            <p:spPr>
+              <a:xfrm>
+                <a:off x="6247125" y="1698325"/>
+                <a:ext cx="1624419" cy="215444"/>
+              </a:xfrm>
+              <a:prstGeom prst="rect">
+                <a:avLst/>
+              </a:prstGeom>
+              <a:blipFill>
+                <a:blip r:embed="rId10"/>
+                <a:stretch>
+                  <a:fillRect l="-3906" r="-3125" b="-33333"/>
+                </a:stretch>
+              </a:blipFill>
+            </p:spPr>
+            <p:txBody>
+              <a:bodyPr/>
+              <a:lstStyle/>
+              <a:p>
+                <a:r>
+                  <a:rPr lang="en-US">
+                    <a:noFill/>
+                  </a:rPr>
+                  <a:t> </a:t>
+                </a:r>
+              </a:p>
+            </p:txBody>
+          </p:sp>
+        </mc:Fallback>
+      </mc:AlternateContent>
+      <p:sp>
+        <p:nvSpPr>
+          <p:cNvPr id="54" name="TextBox 53">
+            <a:extLst>
+              <a:ext uri="{FF2B5EF4-FFF2-40B4-BE49-F238E27FC236}">
+                <a16:creationId xmlns:a16="http://schemas.microsoft.com/office/drawing/2014/main" id="{F2DA1811-823E-1FBD-8A67-44F7BB948145}"/>
+              </a:ext>
+            </a:extLst>
+          </p:cNvPr>
+          <p:cNvSpPr txBox="1"/>
+          <p:nvPr/>
+        </p:nvSpPr>
+        <p:spPr>
+          <a:xfrm>
+            <a:off x="3319587" y="2783675"/>
+            <a:ext cx="834524" cy="307777"/>
+          </a:xfrm>
+          <a:prstGeom prst="rect">
+            <a:avLst/>
+          </a:prstGeom>
+          <a:noFill/>
+        </p:spPr>
+        <p:txBody>
+          <a:bodyPr wrap="none" rtlCol="0">
+            <a:spAutoFit/>
+          </a:bodyPr>
+          <a:lstStyle/>
+          <a:p>
+            <a:r>
+              <a:rPr lang="en-US" sz="1400" b="1" dirty="0"/>
+              <a:t>U</a:t>
+            </a:r>
+            <a:r>
+              <a:rPr lang="en-US" sz="1400" dirty="0"/>
+              <a:t>nstable</a:t>
+            </a:r>
+          </a:p>
+        </p:txBody>
+      </p:sp>
+      <p:sp>
+        <p:nvSpPr>
+          <p:cNvPr id="55" name="TextBox 54">
+            <a:extLst>
+              <a:ext uri="{FF2B5EF4-FFF2-40B4-BE49-F238E27FC236}">
+                <a16:creationId xmlns:a16="http://schemas.microsoft.com/office/drawing/2014/main" id="{DA36AB60-D711-1C16-E9C1-D2322B0645A1}"/>
+              </a:ext>
+            </a:extLst>
+          </p:cNvPr>
+          <p:cNvSpPr txBox="1"/>
+          <p:nvPr/>
+        </p:nvSpPr>
+        <p:spPr>
+          <a:xfrm>
+            <a:off x="4718976" y="2783675"/>
+            <a:ext cx="1228157" cy="307777"/>
+          </a:xfrm>
+          <a:prstGeom prst="rect">
+            <a:avLst/>
+          </a:prstGeom>
+          <a:noFill/>
+        </p:spPr>
+        <p:txBody>
+          <a:bodyPr wrap="none" rtlCol="0">
+            <a:spAutoFit/>
+          </a:bodyPr>
+          <a:lstStyle/>
+          <a:p>
+            <a:r>
+              <a:rPr lang="en-US" sz="1400" b="1" dirty="0"/>
+              <a:t>I</a:t>
+            </a:r>
+            <a:r>
+              <a:rPr lang="en-US" sz="1400" dirty="0"/>
+              <a:t>ndeterminate</a:t>
+            </a:r>
+          </a:p>
+        </p:txBody>
+      </p:sp>
+      <p:sp>
+        <p:nvSpPr>
+          <p:cNvPr id="56" name="TextBox 55">
+            <a:extLst>
+              <a:ext uri="{FF2B5EF4-FFF2-40B4-BE49-F238E27FC236}">
+                <a16:creationId xmlns:a16="http://schemas.microsoft.com/office/drawing/2014/main" id="{4EDD36F7-A293-21CE-7D4A-0E2A2886935C}"/>
+              </a:ext>
+            </a:extLst>
+          </p:cNvPr>
+          <p:cNvSpPr txBox="1"/>
+          <p:nvPr/>
+        </p:nvSpPr>
+        <p:spPr>
+          <a:xfrm>
+            <a:off x="6172695" y="2783675"/>
+            <a:ext cx="1228157" cy="307777"/>
+          </a:xfrm>
+          <a:prstGeom prst="rect">
+            <a:avLst/>
+          </a:prstGeom>
+          <a:noFill/>
+        </p:spPr>
+        <p:txBody>
+          <a:bodyPr wrap="none" rtlCol="0">
+            <a:spAutoFit/>
+          </a:bodyPr>
+          <a:lstStyle/>
+          <a:p>
+            <a:r>
+              <a:rPr lang="en-US" sz="1400" b="1" dirty="0"/>
+              <a:t>I</a:t>
+            </a:r>
+            <a:r>
+              <a:rPr lang="en-US" sz="1400" dirty="0"/>
+              <a:t>ndeterminate</a:t>
+            </a:r>
+          </a:p>
+        </p:txBody>
+      </p:sp>
+      <p:sp>
+        <p:nvSpPr>
+          <p:cNvPr id="62" name="TextBox 61">
+            <a:extLst>
+              <a:ext uri="{FF2B5EF4-FFF2-40B4-BE49-F238E27FC236}">
+                <a16:creationId xmlns:a16="http://schemas.microsoft.com/office/drawing/2014/main" id="{BBF23F95-119B-21B9-3783-13877C350868}"/>
+              </a:ext>
+            </a:extLst>
+          </p:cNvPr>
+          <p:cNvSpPr txBox="1"/>
+          <p:nvPr/>
+        </p:nvSpPr>
+        <p:spPr>
+          <a:xfrm>
+            <a:off x="1246096" y="619952"/>
+            <a:ext cx="436338" cy="369332"/>
+          </a:xfrm>
+          <a:prstGeom prst="rect">
+            <a:avLst/>
+          </a:prstGeom>
+          <a:noFill/>
+        </p:spPr>
+        <p:txBody>
+          <a:bodyPr wrap="none" rtlCol="0">
+            <a:spAutoFit/>
+          </a:bodyPr>
+          <a:lstStyle/>
+          <a:p>
+            <a:r>
+              <a:rPr lang="en-US" dirty="0"/>
+              <a:t>(a)</a:t>
+            </a:r>
+          </a:p>
+        </p:txBody>
+      </p:sp>
+      <p:sp>
+        <p:nvSpPr>
+          <p:cNvPr id="63" name="TextBox 62">
+            <a:extLst>
+              <a:ext uri="{FF2B5EF4-FFF2-40B4-BE49-F238E27FC236}">
+                <a16:creationId xmlns:a16="http://schemas.microsoft.com/office/drawing/2014/main" id="{B39FEA7E-3F4E-249F-D6EE-FCA3F7E6DD30}"/>
+              </a:ext>
+            </a:extLst>
+          </p:cNvPr>
+          <p:cNvSpPr txBox="1"/>
+          <p:nvPr/>
+        </p:nvSpPr>
+        <p:spPr>
+          <a:xfrm>
+            <a:off x="3404650" y="619952"/>
+            <a:ext cx="447558" cy="369332"/>
+          </a:xfrm>
+          <a:prstGeom prst="rect">
+            <a:avLst/>
+          </a:prstGeom>
+          <a:noFill/>
+        </p:spPr>
+        <p:txBody>
+          <a:bodyPr wrap="none" rtlCol="0">
+            <a:spAutoFit/>
+          </a:bodyPr>
+          <a:lstStyle/>
+          <a:p>
+            <a:r>
+              <a:rPr lang="en-US" dirty="0"/>
+              <a:t>(b)</a:t>
+            </a:r>
+          </a:p>
+        </p:txBody>
+      </p:sp>
+      <p:sp>
+        <p:nvSpPr>
+          <p:cNvPr id="64" name="TextBox 63">
+            <a:extLst>
+              <a:ext uri="{FF2B5EF4-FFF2-40B4-BE49-F238E27FC236}">
+                <a16:creationId xmlns:a16="http://schemas.microsoft.com/office/drawing/2014/main" id="{0C183437-451E-8A6F-E41B-3B8CD6170DDD}"/>
+              </a:ext>
+            </a:extLst>
+          </p:cNvPr>
+          <p:cNvSpPr txBox="1"/>
+          <p:nvPr/>
+        </p:nvSpPr>
+        <p:spPr>
+          <a:xfrm>
+            <a:off x="4793406" y="619952"/>
+            <a:ext cx="423514" cy="369332"/>
+          </a:xfrm>
+          <a:prstGeom prst="rect">
+            <a:avLst/>
+          </a:prstGeom>
+          <a:noFill/>
+        </p:spPr>
+        <p:txBody>
+          <a:bodyPr wrap="none" rtlCol="0">
+            <a:spAutoFit/>
+          </a:bodyPr>
+          <a:lstStyle/>
+          <a:p>
+            <a:r>
+              <a:rPr lang="en-US" dirty="0"/>
+              <a:t>(c)</a:t>
+            </a:r>
+          </a:p>
+        </p:txBody>
+      </p:sp>
+      <p:sp>
+        <p:nvSpPr>
+          <p:cNvPr id="65" name="TextBox 64">
+            <a:extLst>
+              <a:ext uri="{FF2B5EF4-FFF2-40B4-BE49-F238E27FC236}">
+                <a16:creationId xmlns:a16="http://schemas.microsoft.com/office/drawing/2014/main" id="{C4324800-4942-FFDD-6D42-3AACCFB81B6E}"/>
+              </a:ext>
+            </a:extLst>
+          </p:cNvPr>
+          <p:cNvSpPr txBox="1"/>
+          <p:nvPr/>
+        </p:nvSpPr>
+        <p:spPr>
+          <a:xfrm>
+            <a:off x="6247125" y="619952"/>
+            <a:ext cx="447558" cy="369332"/>
+          </a:xfrm>
+          <a:prstGeom prst="rect">
+            <a:avLst/>
+          </a:prstGeom>
+          <a:noFill/>
+        </p:spPr>
+        <p:txBody>
+          <a:bodyPr wrap="none" rtlCol="0">
+            <a:spAutoFit/>
+          </a:bodyPr>
+          <a:lstStyle/>
+          <a:p>
+            <a:r>
+              <a:rPr lang="en-US" dirty="0"/>
+              <a:t>(d)</a:t>
+            </a:r>
+          </a:p>
+        </p:txBody>
+      </p:sp>
+      <mc:AlternateContent xmlns:mc="http://schemas.openxmlformats.org/markup-compatibility/2006">
+        <mc:Choice xmlns:a14="http://schemas.microsoft.com/office/drawing/2010/main" Requires="a14">
+          <p:sp>
+            <p:nvSpPr>
+              <p:cNvPr id="2" name="TextBox 1">
+                <a:extLst>
+                  <a:ext uri="{FF2B5EF4-FFF2-40B4-BE49-F238E27FC236}">
+                    <a16:creationId xmlns:a16="http://schemas.microsoft.com/office/drawing/2014/main" id="{FE1394C2-74A1-8FB9-30BA-67B772FC5A1D}"/>
+                  </a:ext>
+                </a:extLst>
+              </p:cNvPr>
+              <p:cNvSpPr txBox="1"/>
+              <p:nvPr/>
+            </p:nvSpPr>
+            <p:spPr>
+              <a:xfrm>
+                <a:off x="1246096" y="2261277"/>
+                <a:ext cx="543802" cy="215444"/>
+              </a:xfrm>
+              <a:prstGeom prst="rect">
+                <a:avLst/>
+              </a:prstGeom>
+              <a:noFill/>
+            </p:spPr>
+            <p:txBody>
+              <a:bodyPr wrap="none" lIns="0" tIns="0" rIns="0" bIns="0" rtlCol="0">
+                <a:spAutoFit/>
+              </a:bodyPr>
+              <a:lstStyle/>
+              <a:p>
+                <a14:m>
+                  <m:oMathPara xmlns:m="http://schemas.openxmlformats.org/officeDocument/2006/math">
+                    <m:oMathParaPr>
+                      <m:jc m:val="centerGroup"/>
+                    </m:oMathParaPr>
+                    <m:oMath xmlns:m="http://schemas.openxmlformats.org/officeDocument/2006/math">
+                      <m:r>
+                        <m:rPr>
+                          <m:sty m:val="p"/>
+                        </m:rPr>
+                        <a:rPr lang="en-US" sz="1400" i="1">
+                          <a:latin typeface="Cambria Math" panose="02040503050406030204" pitchFamily="18" charset="0"/>
+                        </a:rPr>
+                        <m:t>U</m:t>
+                      </m:r>
+                      <m:r>
+                        <a:rPr lang="en-US" sz="1400" b="0" i="1" smtClean="0">
+                          <a:latin typeface="Cambria Math" panose="02040503050406030204" pitchFamily="18" charset="0"/>
+                        </a:rPr>
+                        <m:t>= ∅</m:t>
+                      </m:r>
+                    </m:oMath>
+                  </m:oMathPara>
+                </a14:m>
+                <a:endParaRPr lang="en-US" sz="1400" dirty="0"/>
+              </a:p>
+            </p:txBody>
+          </p:sp>
+        </mc:Choice>
+        <mc:Fallback>
+          <p:sp>
+            <p:nvSpPr>
+              <p:cNvPr id="2" name="TextBox 1">
+                <a:extLst>
+                  <a:ext uri="{FF2B5EF4-FFF2-40B4-BE49-F238E27FC236}">
+                    <a16:creationId xmlns:a16="http://schemas.microsoft.com/office/drawing/2014/main" id="{FE1394C2-74A1-8FB9-30BA-67B772FC5A1D}"/>
+                  </a:ext>
+                </a:extLst>
+              </p:cNvPr>
+              <p:cNvSpPr txBox="1">
+                <a:spLocks noRot="1" noChangeAspect="1" noMove="1" noResize="1" noEditPoints="1" noAdjustHandles="1" noChangeArrowheads="1" noChangeShapeType="1" noTextEdit="1"/>
+              </p:cNvSpPr>
+              <p:nvPr/>
+            </p:nvSpPr>
+            <p:spPr>
+              <a:xfrm>
+                <a:off x="1246096" y="2261277"/>
+                <a:ext cx="543802" cy="215444"/>
+              </a:xfrm>
+              <a:prstGeom prst="rect">
+                <a:avLst/>
+              </a:prstGeom>
+              <a:blipFill>
+                <a:blip r:embed="rId11"/>
+                <a:stretch>
+                  <a:fillRect l="-4444" t="-11765" r="-6667" b="-41176"/>
+                </a:stretch>
+              </a:blipFill>
+            </p:spPr>
+            <p:txBody>
+              <a:bodyPr/>
+              <a:lstStyle/>
+              <a:p>
+                <a:r>
+                  <a:rPr lang="en-US">
+                    <a:noFill/>
+                  </a:rPr>
+                  <a:t> </a:t>
+                </a:r>
+              </a:p>
+            </p:txBody>
+          </p:sp>
+        </mc:Fallback>
+      </mc:AlternateContent>
+      <mc:AlternateContent xmlns:mc="http://schemas.openxmlformats.org/markup-compatibility/2006">
+        <mc:Choice xmlns:a14="http://schemas.microsoft.com/office/drawing/2010/main" Requires="a14">
+          <p:sp>
+            <p:nvSpPr>
+              <p:cNvPr id="3" name="TextBox 2">
+                <a:extLst>
+                  <a:ext uri="{FF2B5EF4-FFF2-40B4-BE49-F238E27FC236}">
+                    <a16:creationId xmlns:a16="http://schemas.microsoft.com/office/drawing/2014/main" id="{C97EC979-BA38-4E86-62B9-909EF90E559F}"/>
+                  </a:ext>
+                </a:extLst>
+              </p:cNvPr>
+              <p:cNvSpPr txBox="1"/>
+              <p:nvPr/>
+            </p:nvSpPr>
+            <p:spPr>
+              <a:xfrm>
+                <a:off x="3404650" y="2040464"/>
+                <a:ext cx="516552" cy="215444"/>
+              </a:xfrm>
+              <a:prstGeom prst="rect">
+                <a:avLst/>
+              </a:prstGeom>
+              <a:noFill/>
+            </p:spPr>
+            <p:txBody>
+              <a:bodyPr wrap="none" lIns="0" tIns="0" rIns="0" bIns="0" rtlCol="0">
+                <a:spAutoFit/>
+              </a:bodyPr>
+              <a:lstStyle/>
+              <a:p>
+                <a14:m>
+                  <m:oMathPara xmlns:m="http://schemas.openxmlformats.org/officeDocument/2006/math">
+                    <m:oMathParaPr>
+                      <m:jc m:val="centerGroup"/>
+                    </m:oMathParaPr>
+                    <m:oMath xmlns:m="http://schemas.openxmlformats.org/officeDocument/2006/math">
+                      <m:r>
+                        <m:rPr>
+                          <m:sty m:val="p"/>
+                        </m:rPr>
+                        <a:rPr lang="en-US" sz="1400" i="1" smtClean="0">
+                          <a:latin typeface="Cambria Math" panose="02040503050406030204" pitchFamily="18" charset="0"/>
+                        </a:rPr>
+                        <m:t>S</m:t>
+                      </m:r>
+                      <m:r>
+                        <a:rPr lang="en-US" sz="1400" b="0" i="1" smtClean="0">
+                          <a:latin typeface="Cambria Math" panose="02040503050406030204" pitchFamily="18" charset="0"/>
+                        </a:rPr>
+                        <m:t>= ∅</m:t>
+                      </m:r>
+                    </m:oMath>
+                  </m:oMathPara>
+                </a14:m>
+                <a:endParaRPr lang="en-US" sz="1400" dirty="0"/>
+              </a:p>
+            </p:txBody>
+          </p:sp>
+        </mc:Choice>
+        <mc:Fallback>
+          <p:sp>
+            <p:nvSpPr>
+              <p:cNvPr id="3" name="TextBox 2">
+                <a:extLst>
+                  <a:ext uri="{FF2B5EF4-FFF2-40B4-BE49-F238E27FC236}">
+                    <a16:creationId xmlns:a16="http://schemas.microsoft.com/office/drawing/2014/main" id="{C97EC979-BA38-4E86-62B9-909EF90E559F}"/>
+                  </a:ext>
+                </a:extLst>
+              </p:cNvPr>
+              <p:cNvSpPr txBox="1">
+                <a:spLocks noRot="1" noChangeAspect="1" noMove="1" noResize="1" noEditPoints="1" noAdjustHandles="1" noChangeArrowheads="1" noChangeShapeType="1" noTextEdit="1"/>
+              </p:cNvSpPr>
+              <p:nvPr/>
+            </p:nvSpPr>
+            <p:spPr>
+              <a:xfrm>
+                <a:off x="3404650" y="2040464"/>
+                <a:ext cx="516552" cy="215444"/>
+              </a:xfrm>
+              <a:prstGeom prst="rect">
+                <a:avLst/>
+              </a:prstGeom>
+              <a:blipFill>
+                <a:blip r:embed="rId12"/>
+                <a:stretch>
+                  <a:fillRect l="-9756" t="-11111" r="-9756" b="-33333"/>
+                </a:stretch>
+              </a:blipFill>
+            </p:spPr>
+            <p:txBody>
+              <a:bodyPr/>
+              <a:lstStyle/>
+              <a:p>
+                <a:r>
+                  <a:rPr lang="en-US">
+                    <a:noFill/>
+                  </a:rPr>
+                  <a:t> </a:t>
+                </a:r>
+              </a:p>
+            </p:txBody>
+          </p:sp>
+        </mc:Fallback>
+      </mc:AlternateContent>
+      <mc:AlternateContent xmlns:mc="http://schemas.openxmlformats.org/markup-compatibility/2006">
+        <mc:Choice xmlns:a14="http://schemas.microsoft.com/office/drawing/2010/main" Requires="a14">
+          <p:sp>
+            <p:nvSpPr>
+              <p:cNvPr id="6" name="TextBox 5">
+                <a:extLst>
+                  <a:ext uri="{FF2B5EF4-FFF2-40B4-BE49-F238E27FC236}">
+                    <a16:creationId xmlns:a16="http://schemas.microsoft.com/office/drawing/2014/main" id="{526AB151-FA20-5A96-22F9-CF62AAF78F75}"/>
+                  </a:ext>
+                </a:extLst>
+              </p:cNvPr>
+              <p:cNvSpPr txBox="1"/>
+              <p:nvPr/>
+            </p:nvSpPr>
+            <p:spPr>
+              <a:xfrm>
+                <a:off x="3404650" y="2261277"/>
+                <a:ext cx="794961" cy="215444"/>
+              </a:xfrm>
+              <a:prstGeom prst="rect">
+                <a:avLst/>
+              </a:prstGeom>
+              <a:noFill/>
+            </p:spPr>
+            <p:txBody>
+              <a:bodyPr wrap="none" lIns="0" tIns="0" rIns="0" bIns="0" rtlCol="0">
+                <a:spAutoFit/>
+              </a:bodyPr>
+              <a:lstStyle/>
+              <a:p>
+                <a14:m>
+                  <m:oMathPara xmlns:m="http://schemas.openxmlformats.org/officeDocument/2006/math">
+                    <m:oMathParaPr>
+                      <m:jc m:val="centerGroup"/>
+                    </m:oMathParaPr>
+                    <m:oMath xmlns:m="http://schemas.openxmlformats.org/officeDocument/2006/math">
+                      <m:r>
+                        <m:rPr>
+                          <m:sty m:val="p"/>
+                        </m:rPr>
+                        <a:rPr lang="en-US" sz="1400" i="1">
+                          <a:latin typeface="Cambria Math" panose="02040503050406030204" pitchFamily="18" charset="0"/>
+                        </a:rPr>
+                        <m:t>U</m:t>
+                      </m:r>
+                      <m:r>
+                        <a:rPr lang="en-US" sz="1400" b="0" i="1" smtClean="0">
+                          <a:latin typeface="Cambria Math" panose="02040503050406030204" pitchFamily="18" charset="0"/>
+                        </a:rPr>
+                        <m:t>={1, 2}</m:t>
+                      </m:r>
+                    </m:oMath>
+                  </m:oMathPara>
+                </a14:m>
+                <a:endParaRPr lang="en-US" sz="1400" dirty="0"/>
+              </a:p>
+            </p:txBody>
+          </p:sp>
+        </mc:Choice>
+        <mc:Fallback>
+          <p:sp>
+            <p:nvSpPr>
+              <p:cNvPr id="6" name="TextBox 5">
+                <a:extLst>
+                  <a:ext uri="{FF2B5EF4-FFF2-40B4-BE49-F238E27FC236}">
+                    <a16:creationId xmlns:a16="http://schemas.microsoft.com/office/drawing/2014/main" id="{526AB151-FA20-5A96-22F9-CF62AAF78F75}"/>
+                  </a:ext>
+                </a:extLst>
+              </p:cNvPr>
+              <p:cNvSpPr txBox="1">
+                <a:spLocks noRot="1" noChangeAspect="1" noMove="1" noResize="1" noEditPoints="1" noAdjustHandles="1" noChangeArrowheads="1" noChangeShapeType="1" noTextEdit="1"/>
+              </p:cNvSpPr>
+              <p:nvPr/>
+            </p:nvSpPr>
+            <p:spPr>
+              <a:xfrm>
+                <a:off x="3404650" y="2261277"/>
+                <a:ext cx="794961" cy="215444"/>
+              </a:xfrm>
+              <a:prstGeom prst="rect">
+                <a:avLst/>
+              </a:prstGeom>
+              <a:blipFill>
+                <a:blip r:embed="rId13"/>
+                <a:stretch>
+                  <a:fillRect l="-6349" t="-5882" r="-7937" b="-35294"/>
+                </a:stretch>
+              </a:blipFill>
+            </p:spPr>
+            <p:txBody>
+              <a:bodyPr/>
+              <a:lstStyle/>
+              <a:p>
+                <a:r>
+                  <a:rPr lang="en-US">
+                    <a:noFill/>
+                  </a:rPr>
+                  <a:t> </a:t>
+                </a:r>
+              </a:p>
+            </p:txBody>
+          </p:sp>
+        </mc:Fallback>
+      </mc:AlternateContent>
+      <mc:AlternateContent xmlns:mc="http://schemas.openxmlformats.org/markup-compatibility/2006">
+        <mc:Choice xmlns:a14="http://schemas.microsoft.com/office/drawing/2010/main" Requires="a14">
+          <p:sp>
+            <p:nvSpPr>
+              <p:cNvPr id="7" name="TextBox 6">
+                <a:extLst>
+                  <a:ext uri="{FF2B5EF4-FFF2-40B4-BE49-F238E27FC236}">
+                    <a16:creationId xmlns:a16="http://schemas.microsoft.com/office/drawing/2014/main" id="{E77E8F3C-D4CA-9A4D-639F-7CD6AE6BCE30}"/>
+                  </a:ext>
+                </a:extLst>
+              </p:cNvPr>
+              <p:cNvSpPr txBox="1"/>
+              <p:nvPr/>
+            </p:nvSpPr>
+            <p:spPr>
+              <a:xfrm>
+                <a:off x="1246096" y="2482216"/>
+                <a:ext cx="484492" cy="215444"/>
+              </a:xfrm>
+              <a:prstGeom prst="rect">
+                <a:avLst/>
+              </a:prstGeom>
+              <a:noFill/>
+            </p:spPr>
+            <p:txBody>
+              <a:bodyPr wrap="none" lIns="0" tIns="0" rIns="0" bIns="0" rtlCol="0">
+                <a:spAutoFit/>
+              </a:bodyPr>
+              <a:lstStyle/>
+              <a:p>
+                <a14:m>
+                  <m:oMathPara xmlns:m="http://schemas.openxmlformats.org/officeDocument/2006/math">
+                    <m:oMathParaPr>
+                      <m:jc m:val="centerGroup"/>
+                    </m:oMathParaPr>
+                    <m:oMath xmlns:m="http://schemas.openxmlformats.org/officeDocument/2006/math">
+                      <m:r>
+                        <m:rPr>
+                          <m:sty m:val="p"/>
+                        </m:rPr>
+                        <a:rPr lang="en-US" sz="1400" i="1" smtClean="0">
+                          <a:latin typeface="Cambria Math" panose="02040503050406030204" pitchFamily="18" charset="0"/>
+                        </a:rPr>
+                        <m:t>I</m:t>
+                      </m:r>
+                      <m:r>
+                        <a:rPr lang="en-US" sz="1400" b="0" i="1" smtClean="0">
+                          <a:latin typeface="Cambria Math" panose="02040503050406030204" pitchFamily="18" charset="0"/>
+                        </a:rPr>
+                        <m:t>= ∅</m:t>
+                      </m:r>
+                    </m:oMath>
+                  </m:oMathPara>
+                </a14:m>
+                <a:endParaRPr lang="en-US" sz="1400" dirty="0"/>
+              </a:p>
+            </p:txBody>
+          </p:sp>
+        </mc:Choice>
+        <mc:Fallback>
+          <p:sp>
+            <p:nvSpPr>
+              <p:cNvPr id="7" name="TextBox 6">
+                <a:extLst>
+                  <a:ext uri="{FF2B5EF4-FFF2-40B4-BE49-F238E27FC236}">
+                    <a16:creationId xmlns:a16="http://schemas.microsoft.com/office/drawing/2014/main" id="{E77E8F3C-D4CA-9A4D-639F-7CD6AE6BCE30}"/>
+                  </a:ext>
+                </a:extLst>
+              </p:cNvPr>
+              <p:cNvSpPr txBox="1">
+                <a:spLocks noRot="1" noChangeAspect="1" noMove="1" noResize="1" noEditPoints="1" noAdjustHandles="1" noChangeArrowheads="1" noChangeShapeType="1" noTextEdit="1"/>
+              </p:cNvSpPr>
+              <p:nvPr/>
+            </p:nvSpPr>
+            <p:spPr>
+              <a:xfrm>
+                <a:off x="1246096" y="2482216"/>
+                <a:ext cx="484492" cy="215444"/>
+              </a:xfrm>
+              <a:prstGeom prst="rect">
+                <a:avLst/>
+              </a:prstGeom>
+              <a:blipFill>
+                <a:blip r:embed="rId14"/>
+                <a:stretch>
+                  <a:fillRect l="-5000" t="-11111" r="-10000" b="-33333"/>
+                </a:stretch>
+              </a:blipFill>
+            </p:spPr>
+            <p:txBody>
+              <a:bodyPr/>
+              <a:lstStyle/>
+              <a:p>
+                <a:r>
+                  <a:rPr lang="en-US">
+                    <a:noFill/>
+                  </a:rPr>
+                  <a:t> </a:t>
+                </a:r>
+              </a:p>
+            </p:txBody>
+          </p:sp>
+        </mc:Fallback>
+      </mc:AlternateContent>
+      <mc:AlternateContent xmlns:mc="http://schemas.openxmlformats.org/markup-compatibility/2006">
+        <mc:Choice xmlns:a14="http://schemas.microsoft.com/office/drawing/2010/main" Requires="a14">
+          <p:sp>
+            <p:nvSpPr>
+              <p:cNvPr id="8" name="TextBox 7">
+                <a:extLst>
+                  <a:ext uri="{FF2B5EF4-FFF2-40B4-BE49-F238E27FC236}">
+                    <a16:creationId xmlns:a16="http://schemas.microsoft.com/office/drawing/2014/main" id="{246937C8-67E1-C26A-C211-2E64617C3C75}"/>
+                  </a:ext>
+                </a:extLst>
+              </p:cNvPr>
+              <p:cNvSpPr txBox="1"/>
+              <p:nvPr/>
+            </p:nvSpPr>
+            <p:spPr>
+              <a:xfrm>
+                <a:off x="3404650" y="2482216"/>
+                <a:ext cx="484492" cy="215444"/>
+              </a:xfrm>
+              <a:prstGeom prst="rect">
+                <a:avLst/>
+              </a:prstGeom>
+              <a:noFill/>
+            </p:spPr>
+            <p:txBody>
+              <a:bodyPr wrap="none" lIns="0" tIns="0" rIns="0" bIns="0" rtlCol="0">
+                <a:spAutoFit/>
+              </a:bodyPr>
+              <a:lstStyle/>
+              <a:p>
+                <a14:m>
+                  <m:oMathPara xmlns:m="http://schemas.openxmlformats.org/officeDocument/2006/math">
+                    <m:oMathParaPr>
+                      <m:jc m:val="centerGroup"/>
+                    </m:oMathParaPr>
+                    <m:oMath xmlns:m="http://schemas.openxmlformats.org/officeDocument/2006/math">
+                      <m:r>
+                        <m:rPr>
+                          <m:sty m:val="p"/>
+                        </m:rPr>
+                        <a:rPr lang="en-US" sz="1400" i="1" smtClean="0">
+                          <a:latin typeface="Cambria Math" panose="02040503050406030204" pitchFamily="18" charset="0"/>
+                        </a:rPr>
+                        <m:t>I</m:t>
+                      </m:r>
+                      <m:r>
+                        <a:rPr lang="en-US" sz="1400" b="0" i="1" smtClean="0">
+                          <a:latin typeface="Cambria Math" panose="02040503050406030204" pitchFamily="18" charset="0"/>
+                        </a:rPr>
+                        <m:t>= ∅</m:t>
+                      </m:r>
+                    </m:oMath>
+                  </m:oMathPara>
+                </a14:m>
+                <a:endParaRPr lang="en-US" sz="1400" dirty="0"/>
+              </a:p>
+            </p:txBody>
+          </p:sp>
+        </mc:Choice>
+        <mc:Fallback>
+          <p:sp>
+            <p:nvSpPr>
+              <p:cNvPr id="8" name="TextBox 7">
+                <a:extLst>
+                  <a:ext uri="{FF2B5EF4-FFF2-40B4-BE49-F238E27FC236}">
+                    <a16:creationId xmlns:a16="http://schemas.microsoft.com/office/drawing/2014/main" id="{246937C8-67E1-C26A-C211-2E64617C3C75}"/>
+                  </a:ext>
+                </a:extLst>
+              </p:cNvPr>
+              <p:cNvSpPr txBox="1">
+                <a:spLocks noRot="1" noChangeAspect="1" noMove="1" noResize="1" noEditPoints="1" noAdjustHandles="1" noChangeArrowheads="1" noChangeShapeType="1" noTextEdit="1"/>
+              </p:cNvSpPr>
+              <p:nvPr/>
+            </p:nvSpPr>
+            <p:spPr>
+              <a:xfrm>
+                <a:off x="3404650" y="2482216"/>
+                <a:ext cx="484492" cy="215444"/>
+              </a:xfrm>
+              <a:prstGeom prst="rect">
+                <a:avLst/>
+              </a:prstGeom>
+              <a:blipFill>
+                <a:blip r:embed="rId15"/>
+                <a:stretch>
+                  <a:fillRect l="-10256" t="-11111" r="-10256" b="-33333"/>
+                </a:stretch>
+              </a:blipFill>
+            </p:spPr>
+            <p:txBody>
+              <a:bodyPr/>
+              <a:lstStyle/>
+              <a:p>
+                <a:r>
+                  <a:rPr lang="en-US">
+                    <a:noFill/>
+                  </a:rPr>
+                  <a:t> </a:t>
+                </a:r>
+              </a:p>
+            </p:txBody>
+          </p:sp>
+        </mc:Fallback>
+      </mc:AlternateContent>
+      <mc:AlternateContent xmlns:mc="http://schemas.openxmlformats.org/markup-compatibility/2006">
+        <mc:Choice xmlns:a14="http://schemas.microsoft.com/office/drawing/2010/main" Requires="a14">
+          <p:sp>
+            <p:nvSpPr>
+              <p:cNvPr id="11" name="TextBox 10">
+                <a:extLst>
+                  <a:ext uri="{FF2B5EF4-FFF2-40B4-BE49-F238E27FC236}">
+                    <a16:creationId xmlns:a16="http://schemas.microsoft.com/office/drawing/2014/main" id="{25EC89E3-7217-4F1E-2A23-7B7A06DCA416}"/>
+                  </a:ext>
+                </a:extLst>
+              </p:cNvPr>
+              <p:cNvSpPr txBox="1"/>
+              <p:nvPr/>
+            </p:nvSpPr>
+            <p:spPr>
+              <a:xfrm>
+                <a:off x="4793406" y="2040464"/>
+                <a:ext cx="516552" cy="215444"/>
+              </a:xfrm>
+              <a:prstGeom prst="rect">
+                <a:avLst/>
+              </a:prstGeom>
+              <a:noFill/>
+            </p:spPr>
+            <p:txBody>
+              <a:bodyPr wrap="none" lIns="0" tIns="0" rIns="0" bIns="0" rtlCol="0">
+                <a:spAutoFit/>
+              </a:bodyPr>
+              <a:lstStyle/>
+              <a:p>
+                <a14:m>
+                  <m:oMathPara xmlns:m="http://schemas.openxmlformats.org/officeDocument/2006/math">
+                    <m:oMathParaPr>
+                      <m:jc m:val="centerGroup"/>
+                    </m:oMathParaPr>
+                    <m:oMath xmlns:m="http://schemas.openxmlformats.org/officeDocument/2006/math">
+                      <m:r>
+                        <m:rPr>
+                          <m:sty m:val="p"/>
+                        </m:rPr>
+                        <a:rPr lang="en-US" sz="1400" i="1" smtClean="0">
+                          <a:latin typeface="Cambria Math" panose="02040503050406030204" pitchFamily="18" charset="0"/>
+                        </a:rPr>
+                        <m:t>S</m:t>
+                      </m:r>
+                      <m:r>
+                        <a:rPr lang="en-US" sz="1400" b="0" i="1" smtClean="0">
+                          <a:latin typeface="Cambria Math" panose="02040503050406030204" pitchFamily="18" charset="0"/>
+                        </a:rPr>
+                        <m:t>= ∅</m:t>
+                      </m:r>
+                    </m:oMath>
+                  </m:oMathPara>
+                </a14:m>
+                <a:endParaRPr lang="en-US" sz="1400" dirty="0"/>
+              </a:p>
+            </p:txBody>
+          </p:sp>
+        </mc:Choice>
+        <mc:Fallback>
+          <p:sp>
+            <p:nvSpPr>
+              <p:cNvPr id="11" name="TextBox 10">
+                <a:extLst>
+                  <a:ext uri="{FF2B5EF4-FFF2-40B4-BE49-F238E27FC236}">
+                    <a16:creationId xmlns:a16="http://schemas.microsoft.com/office/drawing/2014/main" id="{25EC89E3-7217-4F1E-2A23-7B7A06DCA416}"/>
+                  </a:ext>
+                </a:extLst>
+              </p:cNvPr>
+              <p:cNvSpPr txBox="1">
+                <a:spLocks noRot="1" noChangeAspect="1" noMove="1" noResize="1" noEditPoints="1" noAdjustHandles="1" noChangeArrowheads="1" noChangeShapeType="1" noTextEdit="1"/>
+              </p:cNvSpPr>
+              <p:nvPr/>
+            </p:nvSpPr>
+            <p:spPr>
+              <a:xfrm>
+                <a:off x="4793406" y="2040464"/>
+                <a:ext cx="516552" cy="215444"/>
+              </a:xfrm>
+              <a:prstGeom prst="rect">
+                <a:avLst/>
+              </a:prstGeom>
+              <a:blipFill>
+                <a:blip r:embed="rId16"/>
+                <a:stretch>
+                  <a:fillRect l="-7143" t="-11111" r="-7143" b="-33333"/>
+                </a:stretch>
+              </a:blipFill>
+            </p:spPr>
+            <p:txBody>
+              <a:bodyPr/>
+              <a:lstStyle/>
+              <a:p>
+                <a:r>
+                  <a:rPr lang="en-US">
+                    <a:noFill/>
+                  </a:rPr>
+                  <a:t> </a:t>
+                </a:r>
+              </a:p>
+            </p:txBody>
+          </p:sp>
+        </mc:Fallback>
+      </mc:AlternateContent>
+      <mc:AlternateContent xmlns:mc="http://schemas.openxmlformats.org/markup-compatibility/2006">
+        <mc:Choice xmlns:a14="http://schemas.microsoft.com/office/drawing/2010/main" Requires="a14">
+          <p:sp>
+            <p:nvSpPr>
+              <p:cNvPr id="12" name="TextBox 11">
+                <a:extLst>
+                  <a:ext uri="{FF2B5EF4-FFF2-40B4-BE49-F238E27FC236}">
+                    <a16:creationId xmlns:a16="http://schemas.microsoft.com/office/drawing/2014/main" id="{F8562025-9BE7-0A5F-BB59-17B11707E706}"/>
+                  </a:ext>
+                </a:extLst>
+              </p:cNvPr>
+              <p:cNvSpPr txBox="1"/>
+              <p:nvPr/>
+            </p:nvSpPr>
+            <p:spPr>
+              <a:xfrm>
+                <a:off x="4793406" y="2261277"/>
+                <a:ext cx="628762" cy="215444"/>
+              </a:xfrm>
+              <a:prstGeom prst="rect">
+                <a:avLst/>
+              </a:prstGeom>
+              <a:noFill/>
+            </p:spPr>
+            <p:txBody>
+              <a:bodyPr wrap="none" lIns="0" tIns="0" rIns="0" bIns="0" rtlCol="0">
+                <a:spAutoFit/>
+              </a:bodyPr>
+              <a:lstStyle/>
+              <a:p>
+                <a14:m>
+                  <m:oMathPara xmlns:m="http://schemas.openxmlformats.org/officeDocument/2006/math">
+                    <m:oMathParaPr>
+                      <m:jc m:val="centerGroup"/>
+                    </m:oMathParaPr>
+                    <m:oMath xmlns:m="http://schemas.openxmlformats.org/officeDocument/2006/math">
+                      <m:r>
+                        <m:rPr>
+                          <m:sty m:val="p"/>
+                        </m:rPr>
+                        <a:rPr lang="en-US" sz="1400" i="1">
+                          <a:latin typeface="Cambria Math" panose="02040503050406030204" pitchFamily="18" charset="0"/>
+                        </a:rPr>
+                        <m:t>U</m:t>
+                      </m:r>
+                      <m:r>
+                        <a:rPr lang="en-US" sz="1400" b="0" i="1" smtClean="0">
+                          <a:latin typeface="Cambria Math" panose="02040503050406030204" pitchFamily="18" charset="0"/>
+                        </a:rPr>
+                        <m:t>={1}</m:t>
+                      </m:r>
+                    </m:oMath>
+                  </m:oMathPara>
+                </a14:m>
+                <a:endParaRPr lang="en-US" sz="1400" dirty="0"/>
+              </a:p>
+            </p:txBody>
+          </p:sp>
+        </mc:Choice>
+        <mc:Fallback>
+          <p:sp>
+            <p:nvSpPr>
+              <p:cNvPr id="12" name="TextBox 11">
+                <a:extLst>
+                  <a:ext uri="{FF2B5EF4-FFF2-40B4-BE49-F238E27FC236}">
+                    <a16:creationId xmlns:a16="http://schemas.microsoft.com/office/drawing/2014/main" id="{F8562025-9BE7-0A5F-BB59-17B11707E706}"/>
+                  </a:ext>
+                </a:extLst>
+              </p:cNvPr>
+              <p:cNvSpPr txBox="1">
+                <a:spLocks noRot="1" noChangeAspect="1" noMove="1" noResize="1" noEditPoints="1" noAdjustHandles="1" noChangeArrowheads="1" noChangeShapeType="1" noTextEdit="1"/>
+              </p:cNvSpPr>
+              <p:nvPr/>
+            </p:nvSpPr>
+            <p:spPr>
+              <a:xfrm>
+                <a:off x="4793406" y="2261277"/>
+                <a:ext cx="628762" cy="215444"/>
+              </a:xfrm>
+              <a:prstGeom prst="rect">
+                <a:avLst/>
+              </a:prstGeom>
+              <a:blipFill>
+                <a:blip r:embed="rId17"/>
+                <a:stretch>
+                  <a:fillRect l="-6000" t="-5882" r="-12000" b="-35294"/>
+                </a:stretch>
+              </a:blipFill>
+            </p:spPr>
+            <p:txBody>
+              <a:bodyPr/>
+              <a:lstStyle/>
+              <a:p>
+                <a:r>
+                  <a:rPr lang="en-US">
+                    <a:noFill/>
+                  </a:rPr>
+                  <a:t> </a:t>
+                </a:r>
+              </a:p>
+            </p:txBody>
+          </p:sp>
+        </mc:Fallback>
+      </mc:AlternateContent>
+      <mc:AlternateContent xmlns:mc="http://schemas.openxmlformats.org/markup-compatibility/2006">
+        <mc:Choice xmlns:a14="http://schemas.microsoft.com/office/drawing/2010/main" Requires="a14">
+          <p:sp>
+            <p:nvSpPr>
+              <p:cNvPr id="14" name="TextBox 13">
+                <a:extLst>
+                  <a:ext uri="{FF2B5EF4-FFF2-40B4-BE49-F238E27FC236}">
+                    <a16:creationId xmlns:a16="http://schemas.microsoft.com/office/drawing/2014/main" id="{6D921EA9-D155-B8C4-0B1D-72049A22B89D}"/>
+                  </a:ext>
+                </a:extLst>
+              </p:cNvPr>
+              <p:cNvSpPr txBox="1"/>
+              <p:nvPr/>
+            </p:nvSpPr>
+            <p:spPr>
+              <a:xfrm>
+                <a:off x="4793406" y="2482216"/>
+                <a:ext cx="609526" cy="215444"/>
+              </a:xfrm>
+              <a:prstGeom prst="rect">
+                <a:avLst/>
+              </a:prstGeom>
+              <a:noFill/>
+            </p:spPr>
+            <p:txBody>
+              <a:bodyPr wrap="none" lIns="0" tIns="0" rIns="0" bIns="0" rtlCol="0">
+                <a:spAutoFit/>
+              </a:bodyPr>
+              <a:lstStyle/>
+              <a:p>
+                <a14:m>
+                  <m:oMathPara xmlns:m="http://schemas.openxmlformats.org/officeDocument/2006/math">
+                    <m:oMathParaPr>
+                      <m:jc m:val="centerGroup"/>
+                    </m:oMathParaPr>
+                    <m:oMath xmlns:m="http://schemas.openxmlformats.org/officeDocument/2006/math">
+                      <m:r>
+                        <m:rPr>
+                          <m:sty m:val="p"/>
+                        </m:rPr>
+                        <a:rPr lang="en-US" sz="1400" i="1" smtClean="0">
+                          <a:latin typeface="Cambria Math" panose="02040503050406030204" pitchFamily="18" charset="0"/>
+                        </a:rPr>
+                        <m:t>I</m:t>
+                      </m:r>
+                      <m:r>
+                        <a:rPr lang="en-US" sz="1400" b="0" i="1" smtClean="0">
+                          <a:latin typeface="Cambria Math" panose="02040503050406030204" pitchFamily="18" charset="0"/>
+                        </a:rPr>
+                        <m:t>= {2}</m:t>
+                      </m:r>
+                    </m:oMath>
+                  </m:oMathPara>
+                </a14:m>
+                <a:endParaRPr lang="en-US" sz="1400" dirty="0"/>
+              </a:p>
+            </p:txBody>
+          </p:sp>
+        </mc:Choice>
+        <mc:Fallback>
+          <p:sp>
+            <p:nvSpPr>
+              <p:cNvPr id="14" name="TextBox 13">
+                <a:extLst>
+                  <a:ext uri="{FF2B5EF4-FFF2-40B4-BE49-F238E27FC236}">
+                    <a16:creationId xmlns:a16="http://schemas.microsoft.com/office/drawing/2014/main" id="{6D921EA9-D155-B8C4-0B1D-72049A22B89D}"/>
+                  </a:ext>
+                </a:extLst>
+              </p:cNvPr>
+              <p:cNvSpPr txBox="1">
+                <a:spLocks noRot="1" noChangeAspect="1" noMove="1" noResize="1" noEditPoints="1" noAdjustHandles="1" noChangeArrowheads="1" noChangeShapeType="1" noTextEdit="1"/>
+              </p:cNvSpPr>
+              <p:nvPr/>
+            </p:nvSpPr>
+            <p:spPr>
+              <a:xfrm>
+                <a:off x="4793406" y="2482216"/>
+                <a:ext cx="609526" cy="215444"/>
+              </a:xfrm>
+              <a:prstGeom prst="rect">
+                <a:avLst/>
+              </a:prstGeom>
+              <a:blipFill>
+                <a:blip r:embed="rId18"/>
+                <a:stretch>
+                  <a:fillRect l="-6122" t="-11111" r="-10204" b="-33333"/>
+                </a:stretch>
+              </a:blipFill>
+            </p:spPr>
+            <p:txBody>
+              <a:bodyPr/>
+              <a:lstStyle/>
+              <a:p>
+                <a:r>
+                  <a:rPr lang="en-US">
+                    <a:noFill/>
+                  </a:rPr>
+                  <a:t> </a:t>
+                </a:r>
+              </a:p>
+            </p:txBody>
+          </p:sp>
+        </mc:Fallback>
+      </mc:AlternateContent>
+      <mc:AlternateContent xmlns:mc="http://schemas.openxmlformats.org/markup-compatibility/2006">
+        <mc:Choice xmlns:a14="http://schemas.microsoft.com/office/drawing/2010/main" Requires="a14">
+          <p:sp>
+            <p:nvSpPr>
+              <p:cNvPr id="15" name="TextBox 14">
+                <a:extLst>
+                  <a:ext uri="{FF2B5EF4-FFF2-40B4-BE49-F238E27FC236}">
+                    <a16:creationId xmlns:a16="http://schemas.microsoft.com/office/drawing/2014/main" id="{95F99CFD-05E5-705D-16C9-70ABE49CDE1D}"/>
+                  </a:ext>
+                </a:extLst>
+              </p:cNvPr>
+              <p:cNvSpPr txBox="1"/>
+              <p:nvPr/>
+            </p:nvSpPr>
+            <p:spPr>
+              <a:xfrm>
+                <a:off x="6247125" y="2040464"/>
+                <a:ext cx="641586" cy="215444"/>
+              </a:xfrm>
+              <a:prstGeom prst="rect">
+                <a:avLst/>
+              </a:prstGeom>
+              <a:noFill/>
+            </p:spPr>
+            <p:txBody>
+              <a:bodyPr wrap="none" lIns="0" tIns="0" rIns="0" bIns="0" rtlCol="0">
+                <a:spAutoFit/>
+              </a:bodyPr>
+              <a:lstStyle/>
+              <a:p>
+                <a14:m>
+                  <m:oMathPara xmlns:m="http://schemas.openxmlformats.org/officeDocument/2006/math">
+                    <m:oMathParaPr>
+                      <m:jc m:val="centerGroup"/>
+                    </m:oMathParaPr>
+                    <m:oMath xmlns:m="http://schemas.openxmlformats.org/officeDocument/2006/math">
+                      <m:r>
+                        <m:rPr>
+                          <m:sty m:val="p"/>
+                        </m:rPr>
+                        <a:rPr lang="en-US" sz="1400" i="1" smtClean="0">
+                          <a:latin typeface="Cambria Math" panose="02040503050406030204" pitchFamily="18" charset="0"/>
+                        </a:rPr>
+                        <m:t>S</m:t>
+                      </m:r>
+                      <m:r>
+                        <a:rPr lang="en-US" sz="1400" b="0" i="1" smtClean="0">
+                          <a:latin typeface="Cambria Math" panose="02040503050406030204" pitchFamily="18" charset="0"/>
+                        </a:rPr>
+                        <m:t>= {1}</m:t>
+                      </m:r>
+                    </m:oMath>
+                  </m:oMathPara>
+                </a14:m>
+                <a:endParaRPr lang="en-US" sz="1400" dirty="0"/>
+              </a:p>
+            </p:txBody>
+          </p:sp>
+        </mc:Choice>
+        <mc:Fallback>
+          <p:sp>
+            <p:nvSpPr>
+              <p:cNvPr id="15" name="TextBox 14">
+                <a:extLst>
+                  <a:ext uri="{FF2B5EF4-FFF2-40B4-BE49-F238E27FC236}">
+                    <a16:creationId xmlns:a16="http://schemas.microsoft.com/office/drawing/2014/main" id="{95F99CFD-05E5-705D-16C9-70ABE49CDE1D}"/>
+                  </a:ext>
+                </a:extLst>
+              </p:cNvPr>
+              <p:cNvSpPr txBox="1">
+                <a:spLocks noRot="1" noChangeAspect="1" noMove="1" noResize="1" noEditPoints="1" noAdjustHandles="1" noChangeArrowheads="1" noChangeShapeType="1" noTextEdit="1"/>
+              </p:cNvSpPr>
+              <p:nvPr/>
+            </p:nvSpPr>
+            <p:spPr>
+              <a:xfrm>
+                <a:off x="6247125" y="2040464"/>
+                <a:ext cx="641586" cy="215444"/>
+              </a:xfrm>
+              <a:prstGeom prst="rect">
+                <a:avLst/>
+              </a:prstGeom>
+              <a:blipFill>
+                <a:blip r:embed="rId19"/>
+                <a:stretch>
+                  <a:fillRect l="-5882" t="-11111" r="-9804" b="-33333"/>
+                </a:stretch>
+              </a:blipFill>
+            </p:spPr>
+            <p:txBody>
+              <a:bodyPr/>
+              <a:lstStyle/>
+              <a:p>
+                <a:r>
+                  <a:rPr lang="en-US">
+                    <a:noFill/>
+                  </a:rPr>
+                  <a:t> </a:t>
+                </a:r>
+              </a:p>
+            </p:txBody>
+          </p:sp>
+        </mc:Fallback>
+      </mc:AlternateContent>
+      <mc:AlternateContent xmlns:mc="http://schemas.openxmlformats.org/markup-compatibility/2006">
+        <mc:Choice xmlns:a14="http://schemas.microsoft.com/office/drawing/2010/main" Requires="a14">
+          <p:sp>
+            <p:nvSpPr>
+              <p:cNvPr id="17" name="TextBox 16">
+                <a:extLst>
+                  <a:ext uri="{FF2B5EF4-FFF2-40B4-BE49-F238E27FC236}">
+                    <a16:creationId xmlns:a16="http://schemas.microsoft.com/office/drawing/2014/main" id="{273F583D-9AB7-31C4-95D1-9CC731B8F4B4}"/>
+                  </a:ext>
+                </a:extLst>
+              </p:cNvPr>
+              <p:cNvSpPr txBox="1"/>
+              <p:nvPr/>
+            </p:nvSpPr>
+            <p:spPr>
+              <a:xfrm>
+                <a:off x="6247125" y="2261277"/>
+                <a:ext cx="503728" cy="215444"/>
+              </a:xfrm>
+              <a:prstGeom prst="rect">
+                <a:avLst/>
+              </a:prstGeom>
+              <a:noFill/>
+            </p:spPr>
+            <p:txBody>
+              <a:bodyPr wrap="none" lIns="0" tIns="0" rIns="0" bIns="0" rtlCol="0">
+                <a:spAutoFit/>
+              </a:bodyPr>
+              <a:lstStyle/>
+              <a:p>
+                <a14:m>
+                  <m:oMathPara xmlns:m="http://schemas.openxmlformats.org/officeDocument/2006/math">
+                    <m:oMathParaPr>
+                      <m:jc m:val="centerGroup"/>
+                    </m:oMathParaPr>
+                    <m:oMath xmlns:m="http://schemas.openxmlformats.org/officeDocument/2006/math">
+                      <m:r>
+                        <m:rPr>
+                          <m:sty m:val="p"/>
+                        </m:rPr>
+                        <a:rPr lang="en-US" sz="1400" i="1">
+                          <a:latin typeface="Cambria Math" panose="02040503050406030204" pitchFamily="18" charset="0"/>
+                        </a:rPr>
+                        <m:t>U</m:t>
+                      </m:r>
+                      <m:r>
+                        <a:rPr lang="en-US" sz="1400" b="0" i="1" smtClean="0">
+                          <a:latin typeface="Cambria Math" panose="02040503050406030204" pitchFamily="18" charset="0"/>
+                        </a:rPr>
+                        <m:t>=∅</m:t>
+                      </m:r>
+                    </m:oMath>
+                  </m:oMathPara>
+                </a14:m>
+                <a:endParaRPr lang="en-US" sz="1400" dirty="0"/>
+              </a:p>
+            </p:txBody>
+          </p:sp>
+        </mc:Choice>
+        <mc:Fallback>
+          <p:sp>
+            <p:nvSpPr>
+              <p:cNvPr id="17" name="TextBox 16">
+                <a:extLst>
+                  <a:ext uri="{FF2B5EF4-FFF2-40B4-BE49-F238E27FC236}">
+                    <a16:creationId xmlns:a16="http://schemas.microsoft.com/office/drawing/2014/main" id="{273F583D-9AB7-31C4-95D1-9CC731B8F4B4}"/>
+                  </a:ext>
+                </a:extLst>
+              </p:cNvPr>
+              <p:cNvSpPr txBox="1">
+                <a:spLocks noRot="1" noChangeAspect="1" noMove="1" noResize="1" noEditPoints="1" noAdjustHandles="1" noChangeArrowheads="1" noChangeShapeType="1" noTextEdit="1"/>
+              </p:cNvSpPr>
+              <p:nvPr/>
+            </p:nvSpPr>
+            <p:spPr>
+              <a:xfrm>
+                <a:off x="6247125" y="2261277"/>
+                <a:ext cx="503728" cy="215444"/>
+              </a:xfrm>
+              <a:prstGeom prst="rect">
+                <a:avLst/>
+              </a:prstGeom>
+              <a:blipFill>
+                <a:blip r:embed="rId20"/>
+                <a:stretch>
+                  <a:fillRect l="-7500" r="-10000" b="-17647"/>
+                </a:stretch>
+              </a:blipFill>
+            </p:spPr>
+            <p:txBody>
+              <a:bodyPr/>
+              <a:lstStyle/>
+              <a:p>
+                <a:r>
+                  <a:rPr lang="en-US">
+                    <a:noFill/>
+                  </a:rPr>
+                  <a:t> </a:t>
+                </a:r>
+              </a:p>
+            </p:txBody>
+          </p:sp>
+        </mc:Fallback>
+      </mc:AlternateContent>
+      <mc:AlternateContent xmlns:mc="http://schemas.openxmlformats.org/markup-compatibility/2006">
+        <mc:Choice xmlns:a14="http://schemas.microsoft.com/office/drawing/2010/main" Requires="a14">
+          <p:sp>
+            <p:nvSpPr>
+              <p:cNvPr id="18" name="TextBox 17">
+                <a:extLst>
+                  <a:ext uri="{FF2B5EF4-FFF2-40B4-BE49-F238E27FC236}">
+                    <a16:creationId xmlns:a16="http://schemas.microsoft.com/office/drawing/2014/main" id="{19A99F29-9AAC-AE18-4989-5B2DA0B4D57C}"/>
+                  </a:ext>
+                </a:extLst>
+              </p:cNvPr>
+              <p:cNvSpPr txBox="1"/>
+              <p:nvPr/>
+            </p:nvSpPr>
+            <p:spPr>
+              <a:xfrm>
+                <a:off x="6247125" y="2482216"/>
+                <a:ext cx="609526" cy="215444"/>
+              </a:xfrm>
+              <a:prstGeom prst="rect">
+                <a:avLst/>
+              </a:prstGeom>
+              <a:noFill/>
+            </p:spPr>
+            <p:txBody>
+              <a:bodyPr wrap="none" lIns="0" tIns="0" rIns="0" bIns="0" rtlCol="0">
+                <a:spAutoFit/>
+              </a:bodyPr>
+              <a:lstStyle/>
+              <a:p>
+                <a14:m>
+                  <m:oMathPara xmlns:m="http://schemas.openxmlformats.org/officeDocument/2006/math">
+                    <m:oMathParaPr>
+                      <m:jc m:val="centerGroup"/>
+                    </m:oMathParaPr>
+                    <m:oMath xmlns:m="http://schemas.openxmlformats.org/officeDocument/2006/math">
+                      <m:r>
+                        <m:rPr>
+                          <m:sty m:val="p"/>
+                        </m:rPr>
+                        <a:rPr lang="en-US" sz="1400" i="1" smtClean="0">
+                          <a:latin typeface="Cambria Math" panose="02040503050406030204" pitchFamily="18" charset="0"/>
+                        </a:rPr>
+                        <m:t>I</m:t>
+                      </m:r>
+                      <m:r>
+                        <a:rPr lang="en-US" sz="1400" b="0" i="1" smtClean="0">
+                          <a:latin typeface="Cambria Math" panose="02040503050406030204" pitchFamily="18" charset="0"/>
+                        </a:rPr>
+                        <m:t>= {2}</m:t>
+                      </m:r>
+                    </m:oMath>
+                  </m:oMathPara>
+                </a14:m>
+                <a:endParaRPr lang="en-US" sz="1400" dirty="0"/>
+              </a:p>
+            </p:txBody>
+          </p:sp>
+        </mc:Choice>
+        <mc:Fallback>
+          <p:sp>
+            <p:nvSpPr>
+              <p:cNvPr id="18" name="TextBox 17">
+                <a:extLst>
+                  <a:ext uri="{FF2B5EF4-FFF2-40B4-BE49-F238E27FC236}">
+                    <a16:creationId xmlns:a16="http://schemas.microsoft.com/office/drawing/2014/main" id="{19A99F29-9AAC-AE18-4989-5B2DA0B4D57C}"/>
+                  </a:ext>
+                </a:extLst>
+              </p:cNvPr>
+              <p:cNvSpPr txBox="1">
+                <a:spLocks noRot="1" noChangeAspect="1" noMove="1" noResize="1" noEditPoints="1" noAdjustHandles="1" noChangeArrowheads="1" noChangeShapeType="1" noTextEdit="1"/>
+              </p:cNvSpPr>
+              <p:nvPr/>
+            </p:nvSpPr>
+            <p:spPr>
+              <a:xfrm>
+                <a:off x="6247125" y="2482216"/>
+                <a:ext cx="609526" cy="215444"/>
+              </a:xfrm>
+              <a:prstGeom prst="rect">
+                <a:avLst/>
+              </a:prstGeom>
+              <a:blipFill>
+                <a:blip r:embed="rId21"/>
+                <a:stretch>
+                  <a:fillRect l="-6250" t="-11111" r="-10417" b="-33333"/>
+                </a:stretch>
+              </a:blipFill>
+            </p:spPr>
+            <p:txBody>
+              <a:bodyPr/>
+              <a:lstStyle/>
+              <a:p>
+                <a:r>
+                  <a:rPr lang="en-US">
+                    <a:noFill/>
+                  </a:rPr>
+                  <a:t> </a:t>
+                </a:r>
+              </a:p>
+            </p:txBody>
+          </p:sp>
+        </mc:Fallback>
+      </mc:AlternateContent>
+    </p:spTree>
+    <p:extLst>
+      <p:ext uri="{BB962C8B-B14F-4D97-AF65-F5344CB8AC3E}">
+        <p14:creationId xmlns:p14="http://schemas.microsoft.com/office/powerpoint/2010/main" val="3525987290"/>
+      </p:ext>
+    </p:extLst>
+  </p:cSld>
+  <p:clrMapOvr>
+    <a:masterClrMapping/>
+  </p:clrMapOvr>
+</p:sld>
+</file>
+
+<file path=ppt/slides/slide6.xml><?xml version="1.0" encoding="utf-8"?>
+<p:sld xmlns:a="http://schemas.openxmlformats.org/drawingml/2006/main" xmlns:r="http://schemas.openxmlformats.org/officeDocument/2006/relationships" xmlns:p="http://schemas.openxmlformats.org/presentationml/2006/main">
+  <p:cSld>
+    <p:spTree>
+      <p:nvGrpSpPr>
         <p:cNvPr id="1" name=""/>
         <p:cNvGrpSpPr/>
         <p:nvPr/>
@@ -17884,7 +21140,7 @@
 </p:sld>
 </file>
 
-<file path=ppt/slides/slide6.xml><?xml version="1.0" encoding="utf-8"?>
+<file path=ppt/slides/slide7.xml><?xml version="1.0" encoding="utf-8"?>
 <p:sld xmlns:a="http://schemas.openxmlformats.org/drawingml/2006/main" xmlns:r="http://schemas.openxmlformats.org/officeDocument/2006/relationships" xmlns:p="http://schemas.openxmlformats.org/presentationml/2006/main">
   <p:cSld>
     <p:spTree>
@@ -20182,7 +23438,7 @@
 </p:sld>
 </file>
 
-<file path=ppt/slides/slide7.xml><?xml version="1.0" encoding="utf-8"?>
+<file path=ppt/slides/slide8.xml><?xml version="1.0" encoding="utf-8"?>
 <p:sld xmlns:a="http://schemas.openxmlformats.org/drawingml/2006/main" xmlns:r="http://schemas.openxmlformats.org/officeDocument/2006/relationships" xmlns:p="http://schemas.openxmlformats.org/presentationml/2006/main">
   <p:cSld>
     <p:spTree>
@@ -21519,7 +24775,7 @@
 </p:sld>
 </file>
 
-<file path=ppt/slides/slide8.xml><?xml version="1.0" encoding="utf-8"?>
+<file path=ppt/slides/slide9.xml><?xml version="1.0" encoding="utf-8"?>
 <p:sld xmlns:a="http://schemas.openxmlformats.org/drawingml/2006/main" xmlns:r="http://schemas.openxmlformats.org/officeDocument/2006/relationships" xmlns:p="http://schemas.openxmlformats.org/presentationml/2006/main">
   <p:cSld>
     <p:spTree>
@@ -22335,1041 +25591,6 @@
 </p:sld>
 </file>
 
-<file path=ppt/slides/slide9.xml><?xml version="1.0" encoding="utf-8"?>
-<p:sld xmlns:a="http://schemas.openxmlformats.org/drawingml/2006/main" xmlns:r="http://schemas.openxmlformats.org/officeDocument/2006/relationships" xmlns:p="http://schemas.openxmlformats.org/presentationml/2006/main">
-  <p:cSld>
-    <p:spTree>
-      <p:nvGrpSpPr>
-        <p:cNvPr id="1" name="">
-          <a:extLst>
-            <a:ext uri="{FF2B5EF4-FFF2-40B4-BE49-F238E27FC236}">
-              <a16:creationId xmlns:a16="http://schemas.microsoft.com/office/drawing/2014/main" id="{476B5D77-D685-C424-9CA2-EC4A3293D9DD}"/>
-            </a:ext>
-          </a:extLst>
-        </p:cNvPr>
-        <p:cNvGrpSpPr/>
-        <p:nvPr/>
-      </p:nvGrpSpPr>
-      <p:grpSpPr>
-        <a:xfrm>
-          <a:off x="0" y="0"/>
-          <a:ext cx="0" cy="0"/>
-          <a:chOff x="0" y="0"/>
-          <a:chExt cx="0" cy="0"/>
-        </a:xfrm>
-      </p:grpSpPr>
-      <p:pic>
-        <p:nvPicPr>
-          <p:cNvPr id="15" name="Picture 14">
-            <a:extLst>
-              <a:ext uri="{FF2B5EF4-FFF2-40B4-BE49-F238E27FC236}">
-                <a16:creationId xmlns:a16="http://schemas.microsoft.com/office/drawing/2014/main" id="{2BB9B683-2259-2487-0FB1-94E9B4503A8C}"/>
-              </a:ext>
-            </a:extLst>
-          </p:cNvPr>
-          <p:cNvPicPr>
-            <a:picLocks noChangeAspect="1"/>
-          </p:cNvPicPr>
-          <p:nvPr/>
-        </p:nvPicPr>
-        <p:blipFill>
-          <a:blip r:embed="rId2"/>
-          <a:stretch>
-            <a:fillRect/>
-          </a:stretch>
-        </p:blipFill>
-        <p:spPr>
-          <a:xfrm>
-            <a:off x="1761981" y="1600200"/>
-            <a:ext cx="1392389" cy="3657600"/>
-          </a:xfrm>
-          <a:prstGeom prst="rect">
-            <a:avLst/>
-          </a:prstGeom>
-        </p:spPr>
-      </p:pic>
-      <p:pic>
-        <p:nvPicPr>
-          <p:cNvPr id="17" name="Picture 16">
-            <a:extLst>
-              <a:ext uri="{FF2B5EF4-FFF2-40B4-BE49-F238E27FC236}">
-                <a16:creationId xmlns:a16="http://schemas.microsoft.com/office/drawing/2014/main" id="{30B4CCDB-C456-3238-4EA9-BABE44498B7F}"/>
-              </a:ext>
-            </a:extLst>
-          </p:cNvPr>
-          <p:cNvPicPr>
-            <a:picLocks noChangeAspect="1"/>
-          </p:cNvPicPr>
-          <p:nvPr/>
-        </p:nvPicPr>
-        <p:blipFill>
-          <a:blip r:embed="rId3"/>
-          <a:stretch>
-            <a:fillRect/>
-          </a:stretch>
-        </p:blipFill>
-        <p:spPr>
-          <a:xfrm>
-            <a:off x="5493760" y="1691640"/>
-            <a:ext cx="1130337" cy="3474720"/>
-          </a:xfrm>
-          <a:prstGeom prst="rect">
-            <a:avLst/>
-          </a:prstGeom>
-        </p:spPr>
-      </p:pic>
-      <mc:AlternateContent xmlns:mc="http://schemas.openxmlformats.org/markup-compatibility/2006" xmlns:a14="http://schemas.microsoft.com/office/drawing/2010/main">
-        <mc:Choice Requires="a14">
-          <p:sp>
-            <p:nvSpPr>
-              <p:cNvPr id="22" name="TextBox 21">
-                <a:extLst>
-                  <a:ext uri="{FF2B5EF4-FFF2-40B4-BE49-F238E27FC236}">
-                    <a16:creationId xmlns:a16="http://schemas.microsoft.com/office/drawing/2014/main" id="{E443F7E9-CF42-0AF7-B386-2598FE890044}"/>
-                  </a:ext>
-                </a:extLst>
-              </p:cNvPr>
-              <p:cNvSpPr txBox="1"/>
-              <p:nvPr/>
-            </p:nvSpPr>
-            <p:spPr>
-              <a:xfrm>
-                <a:off x="5412627" y="1513700"/>
-                <a:ext cx="293863" cy="276999"/>
-              </a:xfrm>
-              <a:prstGeom prst="rect">
-                <a:avLst/>
-              </a:prstGeom>
-              <a:noFill/>
-            </p:spPr>
-            <p:txBody>
-              <a:bodyPr wrap="none" lIns="0" tIns="0" rIns="0" bIns="0" rtlCol="0">
-                <a:spAutoFit/>
-              </a:bodyPr>
-              <a:lstStyle/>
-              <a:p>
-                <a:pPr/>
-                <a14:m>
-                  <m:oMathPara xmlns:m="http://schemas.openxmlformats.org/officeDocument/2006/math">
-                    <m:oMathParaPr>
-                      <m:jc m:val="centerGroup"/>
-                    </m:oMathParaPr>
-                    <m:oMath xmlns:m="http://schemas.openxmlformats.org/officeDocument/2006/math">
-                      <m:sSub>
-                        <m:sSubPr>
-                          <m:ctrlPr>
-                            <a:rPr lang="en-US" b="0" i="1" smtClean="0">
-                              <a:latin typeface="Cambria Math" panose="02040503050406030204" pitchFamily="18" charset="0"/>
-                            </a:rPr>
-                          </m:ctrlPr>
-                        </m:sSubPr>
-                        <m:e>
-                          <m:r>
-                            <a:rPr lang="en-US" b="0" i="1" smtClean="0">
-                              <a:latin typeface="Cambria Math" panose="02040503050406030204" pitchFamily="18" charset="0"/>
-                            </a:rPr>
-                            <m:t>𝑋</m:t>
-                          </m:r>
-                        </m:e>
-                        <m:sub>
-                          <m:r>
-                            <a:rPr lang="en-US" b="0" i="1" smtClean="0">
-                              <a:latin typeface="Cambria Math" panose="02040503050406030204" pitchFamily="18" charset="0"/>
-                            </a:rPr>
-                            <m:t>1</m:t>
-                          </m:r>
-                        </m:sub>
-                      </m:sSub>
-                    </m:oMath>
-                  </m:oMathPara>
-                </a14:m>
-                <a:endParaRPr lang="en-US" dirty="0"/>
-              </a:p>
-            </p:txBody>
-          </p:sp>
-        </mc:Choice>
-        <mc:Fallback xmlns="">
-          <p:sp>
-            <p:nvSpPr>
-              <p:cNvPr id="22" name="TextBox 21">
-                <a:extLst>
-                  <a:ext uri="{FF2B5EF4-FFF2-40B4-BE49-F238E27FC236}">
-                    <a16:creationId xmlns:a16="http://schemas.microsoft.com/office/drawing/2014/main" id="{E443F7E9-CF42-0AF7-B386-2598FE890044}"/>
-                  </a:ext>
-                </a:extLst>
-              </p:cNvPr>
-              <p:cNvSpPr txBox="1">
-                <a:spLocks noRot="1" noChangeAspect="1" noMove="1" noResize="1" noEditPoints="1" noAdjustHandles="1" noChangeArrowheads="1" noChangeShapeType="1" noTextEdit="1"/>
-              </p:cNvSpPr>
-              <p:nvPr/>
-            </p:nvSpPr>
-            <p:spPr>
-              <a:xfrm>
-                <a:off x="5412627" y="1513700"/>
-                <a:ext cx="293863" cy="276999"/>
-              </a:xfrm>
-              <a:prstGeom prst="rect">
-                <a:avLst/>
-              </a:prstGeom>
-              <a:blipFill>
-                <a:blip r:embed="rId4"/>
-                <a:stretch>
-                  <a:fillRect l="-20833" r="-4167" b="-8696"/>
-                </a:stretch>
-              </a:blipFill>
-            </p:spPr>
-            <p:txBody>
-              <a:bodyPr/>
-              <a:lstStyle/>
-              <a:p>
-                <a:r>
-                  <a:rPr lang="en-US">
-                    <a:noFill/>
-                  </a:rPr>
-                  <a:t> </a:t>
-                </a:r>
-              </a:p>
-            </p:txBody>
-          </p:sp>
-        </mc:Fallback>
-      </mc:AlternateContent>
-      <mc:AlternateContent xmlns:mc="http://schemas.openxmlformats.org/markup-compatibility/2006" xmlns:a14="http://schemas.microsoft.com/office/drawing/2010/main">
-        <mc:Choice Requires="a14">
-          <p:sp>
-            <p:nvSpPr>
-              <p:cNvPr id="24" name="TextBox 23">
-                <a:extLst>
-                  <a:ext uri="{FF2B5EF4-FFF2-40B4-BE49-F238E27FC236}">
-                    <a16:creationId xmlns:a16="http://schemas.microsoft.com/office/drawing/2014/main" id="{F8777DE3-5E3D-C514-4D85-A6CE1CBE3F04}"/>
-                  </a:ext>
-                </a:extLst>
-              </p:cNvPr>
-              <p:cNvSpPr txBox="1"/>
-              <p:nvPr/>
-            </p:nvSpPr>
-            <p:spPr>
-              <a:xfrm>
-                <a:off x="1863795" y="4681160"/>
-                <a:ext cx="293863" cy="276999"/>
-              </a:xfrm>
-              <a:prstGeom prst="rect">
-                <a:avLst/>
-              </a:prstGeom>
-              <a:noFill/>
-            </p:spPr>
-            <p:txBody>
-              <a:bodyPr wrap="none" lIns="0" tIns="0" rIns="0" bIns="0" rtlCol="0">
-                <a:spAutoFit/>
-              </a:bodyPr>
-              <a:lstStyle/>
-              <a:p>
-                <a:pPr/>
-                <a14:m>
-                  <m:oMathPara xmlns:m="http://schemas.openxmlformats.org/officeDocument/2006/math">
-                    <m:oMathParaPr>
-                      <m:jc m:val="centerGroup"/>
-                    </m:oMathParaPr>
-                    <m:oMath xmlns:m="http://schemas.openxmlformats.org/officeDocument/2006/math">
-                      <m:sSub>
-                        <m:sSubPr>
-                          <m:ctrlPr>
-                            <a:rPr lang="en-US" b="0" i="1" smtClean="0">
-                              <a:latin typeface="Cambria Math" panose="02040503050406030204" pitchFamily="18" charset="0"/>
-                            </a:rPr>
-                          </m:ctrlPr>
-                        </m:sSubPr>
-                        <m:e>
-                          <m:r>
-                            <a:rPr lang="en-US" b="0" i="1" smtClean="0">
-                              <a:latin typeface="Cambria Math" panose="02040503050406030204" pitchFamily="18" charset="0"/>
-                            </a:rPr>
-                            <m:t>𝑋</m:t>
-                          </m:r>
-                        </m:e>
-                        <m:sub>
-                          <m:r>
-                            <a:rPr lang="en-US" b="0" i="1" smtClean="0">
-                              <a:latin typeface="Cambria Math" panose="02040503050406030204" pitchFamily="18" charset="0"/>
-                            </a:rPr>
-                            <m:t>1</m:t>
-                          </m:r>
-                        </m:sub>
-                      </m:sSub>
-                    </m:oMath>
-                  </m:oMathPara>
-                </a14:m>
-                <a:endParaRPr lang="en-US" dirty="0"/>
-              </a:p>
-            </p:txBody>
-          </p:sp>
-        </mc:Choice>
-        <mc:Fallback xmlns="">
-          <p:sp>
-            <p:nvSpPr>
-              <p:cNvPr id="24" name="TextBox 23">
-                <a:extLst>
-                  <a:ext uri="{FF2B5EF4-FFF2-40B4-BE49-F238E27FC236}">
-                    <a16:creationId xmlns:a16="http://schemas.microsoft.com/office/drawing/2014/main" id="{F8777DE3-5E3D-C514-4D85-A6CE1CBE3F04}"/>
-                  </a:ext>
-                </a:extLst>
-              </p:cNvPr>
-              <p:cNvSpPr txBox="1">
-                <a:spLocks noRot="1" noChangeAspect="1" noMove="1" noResize="1" noEditPoints="1" noAdjustHandles="1" noChangeArrowheads="1" noChangeShapeType="1" noTextEdit="1"/>
-              </p:cNvSpPr>
-              <p:nvPr/>
-            </p:nvSpPr>
-            <p:spPr>
-              <a:xfrm>
-                <a:off x="1863795" y="4681160"/>
-                <a:ext cx="293863" cy="276999"/>
-              </a:xfrm>
-              <a:prstGeom prst="rect">
-                <a:avLst/>
-              </a:prstGeom>
-              <a:blipFill>
-                <a:blip r:embed="rId5"/>
-                <a:stretch>
-                  <a:fillRect l="-16667" r="-8333" b="-13043"/>
-                </a:stretch>
-              </a:blipFill>
-            </p:spPr>
-            <p:txBody>
-              <a:bodyPr/>
-              <a:lstStyle/>
-              <a:p>
-                <a:r>
-                  <a:rPr lang="en-US">
-                    <a:noFill/>
-                  </a:rPr>
-                  <a:t> </a:t>
-                </a:r>
-              </a:p>
-            </p:txBody>
-          </p:sp>
-        </mc:Fallback>
-      </mc:AlternateContent>
-      <mc:AlternateContent xmlns:mc="http://schemas.openxmlformats.org/markup-compatibility/2006" xmlns:a14="http://schemas.microsoft.com/office/drawing/2010/main">
-        <mc:Choice Requires="a14">
-          <p:sp>
-            <p:nvSpPr>
-              <p:cNvPr id="25" name="Rectangle 24">
-                <a:extLst>
-                  <a:ext uri="{FF2B5EF4-FFF2-40B4-BE49-F238E27FC236}">
-                    <a16:creationId xmlns:a16="http://schemas.microsoft.com/office/drawing/2014/main" id="{C7AEA308-BE30-3F96-8043-BF55377A5161}"/>
-                  </a:ext>
-                </a:extLst>
-              </p:cNvPr>
-              <p:cNvSpPr>
-                <a:spLocks/>
-              </p:cNvSpPr>
-              <p:nvPr/>
-            </p:nvSpPr>
-            <p:spPr>
-              <a:xfrm>
-                <a:off x="2922362" y="2150074"/>
-                <a:ext cx="1188720" cy="1188720"/>
-              </a:xfrm>
-              <a:prstGeom prst="rect">
-                <a:avLst/>
-              </a:prstGeom>
-            </p:spPr>
-            <p:style>
-              <a:lnRef idx="2">
-                <a:schemeClr val="accent1">
-                  <a:shade val="15000"/>
-                </a:schemeClr>
-              </a:lnRef>
-              <a:fillRef idx="1">
-                <a:schemeClr val="accent1"/>
-              </a:fillRef>
-              <a:effectRef idx="0">
-                <a:schemeClr val="accent1"/>
-              </a:effectRef>
-              <a:fontRef idx="minor">
-                <a:schemeClr val="lt1"/>
-              </a:fontRef>
-            </p:style>
-            <p:txBody>
-              <a:bodyPr rtlCol="0" anchor="ctr"/>
-              <a:lstStyle/>
-              <a:p>
-                <a:pPr algn="ctr"/>
-                <a14:m>
-                  <m:oMathPara xmlns:m="http://schemas.openxmlformats.org/officeDocument/2006/math">
-                    <m:oMathParaPr>
-                      <m:jc m:val="centerGroup"/>
-                    </m:oMathParaPr>
-                    <m:oMath xmlns:m="http://schemas.openxmlformats.org/officeDocument/2006/math">
-                      <m:r>
-                        <a:rPr lang="en-US" i="1" smtClean="0">
-                          <a:latin typeface="Cambria Math" panose="02040503050406030204" pitchFamily="18" charset="0"/>
-                          <a:ea typeface="Cambria Math" panose="02040503050406030204" pitchFamily="18" charset="0"/>
-                        </a:rPr>
-                        <m:t>ℳ</m:t>
-                      </m:r>
-                      <m:r>
-                        <a:rPr lang="en-US" b="0" i="1" baseline="-25000" smtClean="0">
-                          <a:latin typeface="Cambria Math" panose="02040503050406030204" pitchFamily="18" charset="0"/>
-                          <a:ea typeface="Cambria Math" panose="02040503050406030204" pitchFamily="18" charset="0"/>
-                        </a:rPr>
-                        <m:t>1</m:t>
-                      </m:r>
-                      <m:r>
-                        <a:rPr lang="en-US" b="0" i="1" smtClean="0">
-                          <a:latin typeface="Cambria Math" panose="02040503050406030204" pitchFamily="18" charset="0"/>
-                          <a:ea typeface="Cambria Math" panose="02040503050406030204" pitchFamily="18" charset="0"/>
-                        </a:rPr>
-                        <m:t>−</m:t>
-                      </m:r>
-                      <m:sSub>
-                        <m:sSubPr>
-                          <m:ctrlPr>
-                            <a:rPr lang="en-US" b="0" i="1" smtClean="0">
-                              <a:latin typeface="Cambria Math" panose="02040503050406030204" pitchFamily="18" charset="0"/>
-                              <a:ea typeface="Cambria Math" panose="02040503050406030204" pitchFamily="18" charset="0"/>
-                            </a:rPr>
-                          </m:ctrlPr>
-                        </m:sSubPr>
-                        <m:e>
-                          <m:r>
-                            <a:rPr lang="en-US" b="0" i="1" smtClean="0">
-                              <a:latin typeface="Cambria Math" panose="02040503050406030204" pitchFamily="18" charset="0"/>
-                              <a:ea typeface="Cambria Math" panose="02040503050406030204" pitchFamily="18" charset="0"/>
-                            </a:rPr>
-                            <m:t>𝑋</m:t>
-                          </m:r>
-                        </m:e>
-                        <m:sub>
-                          <m:r>
-                            <a:rPr lang="en-US" b="0" i="1" smtClean="0">
-                              <a:latin typeface="Cambria Math" panose="02040503050406030204" pitchFamily="18" charset="0"/>
-                              <a:ea typeface="Cambria Math" panose="02040503050406030204" pitchFamily="18" charset="0"/>
-                            </a:rPr>
-                            <m:t>1</m:t>
-                          </m:r>
-                        </m:sub>
-                      </m:sSub>
-                    </m:oMath>
-                  </m:oMathPara>
-                </a14:m>
-                <a:endParaRPr lang="en-US" dirty="0"/>
-              </a:p>
-            </p:txBody>
-          </p:sp>
-        </mc:Choice>
-        <mc:Fallback xmlns="">
-          <p:sp>
-            <p:nvSpPr>
-              <p:cNvPr id="25" name="Rectangle 24">
-                <a:extLst>
-                  <a:ext uri="{FF2B5EF4-FFF2-40B4-BE49-F238E27FC236}">
-                    <a16:creationId xmlns:a16="http://schemas.microsoft.com/office/drawing/2014/main" id="{C7AEA308-BE30-3F96-8043-BF55377A5161}"/>
-                  </a:ext>
-                </a:extLst>
-              </p:cNvPr>
-              <p:cNvSpPr>
-                <a:spLocks noRot="1" noChangeAspect="1" noMove="1" noResize="1" noEditPoints="1" noAdjustHandles="1" noChangeArrowheads="1" noChangeShapeType="1" noTextEdit="1"/>
-              </p:cNvSpPr>
-              <p:nvPr/>
-            </p:nvSpPr>
-            <p:spPr>
-              <a:xfrm>
-                <a:off x="2922362" y="2150074"/>
-                <a:ext cx="1188720" cy="1188720"/>
-              </a:xfrm>
-              <a:prstGeom prst="rect">
-                <a:avLst/>
-              </a:prstGeom>
-              <a:blipFill>
-                <a:blip r:embed="rId6"/>
-                <a:stretch>
-                  <a:fillRect/>
-                </a:stretch>
-              </a:blipFill>
-            </p:spPr>
-            <p:txBody>
-              <a:bodyPr/>
-              <a:lstStyle/>
-              <a:p>
-                <a:r>
-                  <a:rPr lang="en-US">
-                    <a:noFill/>
-                  </a:rPr>
-                  <a:t> </a:t>
-                </a:r>
-              </a:p>
-            </p:txBody>
-          </p:sp>
-        </mc:Fallback>
-      </mc:AlternateContent>
-      <mc:AlternateContent xmlns:mc="http://schemas.openxmlformats.org/markup-compatibility/2006" xmlns:a14="http://schemas.microsoft.com/office/drawing/2010/main">
-        <mc:Choice Requires="a14">
-          <p:sp>
-            <p:nvSpPr>
-              <p:cNvPr id="28" name="Rectangle 27">
-                <a:extLst>
-                  <a:ext uri="{FF2B5EF4-FFF2-40B4-BE49-F238E27FC236}">
-                    <a16:creationId xmlns:a16="http://schemas.microsoft.com/office/drawing/2014/main" id="{4AB347E8-7AF4-A6F5-665E-45B559168B5D}"/>
-                  </a:ext>
-                </a:extLst>
-              </p:cNvPr>
-              <p:cNvSpPr>
-                <a:spLocks/>
-              </p:cNvSpPr>
-              <p:nvPr/>
-            </p:nvSpPr>
-            <p:spPr>
-              <a:xfrm>
-                <a:off x="4125981" y="3365156"/>
-                <a:ext cx="1188720" cy="1188720"/>
-              </a:xfrm>
-              <a:prstGeom prst="rect">
-                <a:avLst/>
-              </a:prstGeom>
-              <a:solidFill>
-                <a:schemeClr val="accent2">
-                  <a:lumMod val="60000"/>
-                  <a:lumOff val="40000"/>
-                </a:schemeClr>
-              </a:solidFill>
-              <a:ln>
-                <a:noFill/>
-              </a:ln>
-            </p:spPr>
-            <p:style>
-              <a:lnRef idx="2">
-                <a:schemeClr val="accent1">
-                  <a:shade val="15000"/>
-                </a:schemeClr>
-              </a:lnRef>
-              <a:fillRef idx="1">
-                <a:schemeClr val="accent1"/>
-              </a:fillRef>
-              <a:effectRef idx="0">
-                <a:schemeClr val="accent1"/>
-              </a:effectRef>
-              <a:fontRef idx="minor">
-                <a:schemeClr val="lt1"/>
-              </a:fontRef>
-            </p:style>
-            <p:txBody>
-              <a:bodyPr rtlCol="0" anchor="ctr"/>
-              <a:lstStyle/>
-              <a:p>
-                <a:pPr algn="ctr"/>
-                <a14:m>
-                  <m:oMathPara xmlns:m="http://schemas.openxmlformats.org/officeDocument/2006/math">
-                    <m:oMathParaPr>
-                      <m:jc m:val="centerGroup"/>
-                    </m:oMathParaPr>
-                    <m:oMath xmlns:m="http://schemas.openxmlformats.org/officeDocument/2006/math">
-                      <m:r>
-                        <a:rPr lang="en-US" i="1" smtClean="0">
-                          <a:latin typeface="Cambria Math" panose="02040503050406030204" pitchFamily="18" charset="0"/>
-                          <a:ea typeface="Cambria Math" panose="02040503050406030204" pitchFamily="18" charset="0"/>
-                        </a:rPr>
-                        <m:t>ℳ</m:t>
-                      </m:r>
-                      <m:r>
-                        <a:rPr lang="en-US" b="0" i="1" baseline="-25000" smtClean="0">
-                          <a:latin typeface="Cambria Math" panose="02040503050406030204" pitchFamily="18" charset="0"/>
-                          <a:ea typeface="Cambria Math" panose="02040503050406030204" pitchFamily="18" charset="0"/>
-                        </a:rPr>
-                        <m:t>2</m:t>
-                      </m:r>
-                      <m:r>
-                        <a:rPr lang="en-US" b="0" i="0" smtClean="0">
-                          <a:latin typeface="Cambria Math" panose="02040503050406030204" pitchFamily="18" charset="0"/>
-                          <a:ea typeface="Cambria Math" panose="02040503050406030204" pitchFamily="18" charset="0"/>
-                        </a:rPr>
-                        <m:t>−</m:t>
-                      </m:r>
-                      <m:r>
-                        <m:rPr>
-                          <m:sty m:val="p"/>
-                        </m:rPr>
-                        <a:rPr lang="en-US" b="0" i="0" smtClean="0">
-                          <a:latin typeface="Cambria Math" panose="02040503050406030204" pitchFamily="18" charset="0"/>
-                          <a:ea typeface="Cambria Math" panose="02040503050406030204" pitchFamily="18" charset="0"/>
-                        </a:rPr>
-                        <m:t>X</m:t>
-                      </m:r>
-                      <m:r>
-                        <a:rPr lang="en-US" b="0" i="0" baseline="-25000" smtClean="0">
-                          <a:latin typeface="Cambria Math" panose="02040503050406030204" pitchFamily="18" charset="0"/>
-                          <a:ea typeface="Cambria Math" panose="02040503050406030204" pitchFamily="18" charset="0"/>
-                        </a:rPr>
-                        <m:t>1</m:t>
-                      </m:r>
-                    </m:oMath>
-                  </m:oMathPara>
-                </a14:m>
-                <a:endParaRPr lang="en-US" baseline="-25000" dirty="0"/>
-              </a:p>
-            </p:txBody>
-          </p:sp>
-        </mc:Choice>
-        <mc:Fallback xmlns="">
-          <p:sp>
-            <p:nvSpPr>
-              <p:cNvPr id="28" name="Rectangle 27">
-                <a:extLst>
-                  <a:ext uri="{FF2B5EF4-FFF2-40B4-BE49-F238E27FC236}">
-                    <a16:creationId xmlns:a16="http://schemas.microsoft.com/office/drawing/2014/main" id="{4AB347E8-7AF4-A6F5-665E-45B559168B5D}"/>
-                  </a:ext>
-                </a:extLst>
-              </p:cNvPr>
-              <p:cNvSpPr>
-                <a:spLocks noRot="1" noChangeAspect="1" noMove="1" noResize="1" noEditPoints="1" noAdjustHandles="1" noChangeArrowheads="1" noChangeShapeType="1" noTextEdit="1"/>
-              </p:cNvSpPr>
-              <p:nvPr/>
-            </p:nvSpPr>
-            <p:spPr>
-              <a:xfrm>
-                <a:off x="4125981" y="3365156"/>
-                <a:ext cx="1188720" cy="1188720"/>
-              </a:xfrm>
-              <a:prstGeom prst="rect">
-                <a:avLst/>
-              </a:prstGeom>
-              <a:blipFill>
-                <a:blip r:embed="rId7"/>
-                <a:stretch>
-                  <a:fillRect/>
-                </a:stretch>
-              </a:blipFill>
-              <a:ln>
-                <a:noFill/>
-              </a:ln>
-            </p:spPr>
-            <p:txBody>
-              <a:bodyPr/>
-              <a:lstStyle/>
-              <a:p>
-                <a:r>
-                  <a:rPr lang="en-US">
-                    <a:noFill/>
-                  </a:rPr>
-                  <a:t> </a:t>
-                </a:r>
-              </a:p>
-            </p:txBody>
-          </p:sp>
-        </mc:Fallback>
-      </mc:AlternateContent>
-      <p:sp>
-        <p:nvSpPr>
-          <p:cNvPr id="30" name="Title 29">
-            <a:extLst>
-              <a:ext uri="{FF2B5EF4-FFF2-40B4-BE49-F238E27FC236}">
-                <a16:creationId xmlns:a16="http://schemas.microsoft.com/office/drawing/2014/main" id="{84556FDF-D043-AC39-20A2-F718F0A89ADD}"/>
-              </a:ext>
-            </a:extLst>
-          </p:cNvPr>
-          <p:cNvSpPr>
-            <a:spLocks noGrp="1"/>
-          </p:cNvSpPr>
-          <p:nvPr>
-            <p:ph type="title"/>
-          </p:nvPr>
-        </p:nvSpPr>
-        <p:spPr/>
-        <p:txBody>
-          <a:bodyPr/>
-          <a:lstStyle/>
-          <a:p>
-            <a:r>
-              <a:rPr lang="en-US" dirty="0"/>
-              <a:t>Join Jacobian</a:t>
-            </a:r>
-          </a:p>
-        </p:txBody>
-      </p:sp>
-      <mc:AlternateContent xmlns:mc="http://schemas.openxmlformats.org/markup-compatibility/2006" xmlns:a14="http://schemas.microsoft.com/office/drawing/2010/main">
-        <mc:Choice Requires="a14">
-          <p:sp>
-            <p:nvSpPr>
-              <p:cNvPr id="2" name="Rectangle 1">
-                <a:extLst>
-                  <a:ext uri="{FF2B5EF4-FFF2-40B4-BE49-F238E27FC236}">
-                    <a16:creationId xmlns:a16="http://schemas.microsoft.com/office/drawing/2014/main" id="{C209E7F9-39BB-33E4-F812-00C4DAD25EEC}"/>
-                  </a:ext>
-                </a:extLst>
-              </p:cNvPr>
-              <p:cNvSpPr>
-                <a:spLocks/>
-              </p:cNvSpPr>
-              <p:nvPr/>
-            </p:nvSpPr>
-            <p:spPr>
-              <a:xfrm>
-                <a:off x="2865943" y="4641328"/>
-                <a:ext cx="1188720" cy="316831"/>
-              </a:xfrm>
-              <a:prstGeom prst="rect">
-                <a:avLst/>
-              </a:prstGeom>
-            </p:spPr>
-            <p:style>
-              <a:lnRef idx="2">
-                <a:schemeClr val="accent1">
-                  <a:shade val="15000"/>
-                </a:schemeClr>
-              </a:lnRef>
-              <a:fillRef idx="1">
-                <a:schemeClr val="accent1"/>
-              </a:fillRef>
-              <a:effectRef idx="0">
-                <a:schemeClr val="accent1"/>
-              </a:effectRef>
-              <a:fontRef idx="minor">
-                <a:schemeClr val="lt1"/>
-              </a:fontRef>
-            </p:style>
-            <p:txBody>
-              <a:bodyPr rtlCol="0" anchor="ctr"/>
-              <a:lstStyle/>
-              <a:p>
-                <a:pPr algn="ctr"/>
-                <a14:m>
-                  <m:oMathPara xmlns:m="http://schemas.openxmlformats.org/officeDocument/2006/math">
-                    <m:oMathParaPr>
-                      <m:jc m:val="centerGroup"/>
-                    </m:oMathParaPr>
-                    <m:oMath xmlns:m="http://schemas.openxmlformats.org/officeDocument/2006/math">
-                      <m:r>
-                        <a:rPr lang="en-US" i="1">
-                          <a:latin typeface="Cambria Math" panose="02040503050406030204" pitchFamily="18" charset="0"/>
-                          <a:ea typeface="Cambria Math" panose="02040503050406030204" pitchFamily="18" charset="0"/>
-                        </a:rPr>
-                        <m:t>ℳ</m:t>
-                      </m:r>
-                      <m:r>
-                        <a:rPr lang="en-US" i="1" baseline="-25000">
-                          <a:latin typeface="Cambria Math" panose="02040503050406030204" pitchFamily="18" charset="0"/>
-                          <a:ea typeface="Cambria Math" panose="02040503050406030204" pitchFamily="18" charset="0"/>
-                        </a:rPr>
-                        <m:t>1</m:t>
-                      </m:r>
-                      <m:r>
-                        <a:rPr lang="en-US" i="1">
-                          <a:latin typeface="Cambria Math" panose="02040503050406030204" pitchFamily="18" charset="0"/>
-                          <a:ea typeface="Cambria Math" panose="02040503050406030204" pitchFamily="18" charset="0"/>
-                        </a:rPr>
-                        <m:t>−</m:t>
-                      </m:r>
-                      <m:sSub>
-                        <m:sSubPr>
-                          <m:ctrlPr>
-                            <a:rPr lang="en-US" i="1">
-                              <a:latin typeface="Cambria Math" panose="02040503050406030204" pitchFamily="18" charset="0"/>
-                              <a:ea typeface="Cambria Math" panose="02040503050406030204" pitchFamily="18" charset="0"/>
-                            </a:rPr>
-                          </m:ctrlPr>
-                        </m:sSubPr>
-                        <m:e>
-                          <m:r>
-                            <a:rPr lang="en-US" i="1">
-                              <a:latin typeface="Cambria Math" panose="02040503050406030204" pitchFamily="18" charset="0"/>
-                              <a:ea typeface="Cambria Math" panose="02040503050406030204" pitchFamily="18" charset="0"/>
-                            </a:rPr>
-                            <m:t>𝑋</m:t>
-                          </m:r>
-                        </m:e>
-                        <m:sub>
-                          <m:r>
-                            <a:rPr lang="en-US" i="1">
-                              <a:latin typeface="Cambria Math" panose="02040503050406030204" pitchFamily="18" charset="0"/>
-                              <a:ea typeface="Cambria Math" panose="02040503050406030204" pitchFamily="18" charset="0"/>
-                            </a:rPr>
-                            <m:t>1</m:t>
-                          </m:r>
-                        </m:sub>
-                      </m:sSub>
-                    </m:oMath>
-                  </m:oMathPara>
-                </a14:m>
-                <a:endParaRPr lang="en-US" dirty="0"/>
-              </a:p>
-            </p:txBody>
-          </p:sp>
-        </mc:Choice>
-        <mc:Fallback xmlns="">
-          <p:sp>
-            <p:nvSpPr>
-              <p:cNvPr id="2" name="Rectangle 1">
-                <a:extLst>
-                  <a:ext uri="{FF2B5EF4-FFF2-40B4-BE49-F238E27FC236}">
-                    <a16:creationId xmlns:a16="http://schemas.microsoft.com/office/drawing/2014/main" id="{C209E7F9-39BB-33E4-F812-00C4DAD25EEC}"/>
-                  </a:ext>
-                </a:extLst>
-              </p:cNvPr>
-              <p:cNvSpPr>
-                <a:spLocks noRot="1" noChangeAspect="1" noMove="1" noResize="1" noEditPoints="1" noAdjustHandles="1" noChangeArrowheads="1" noChangeShapeType="1" noTextEdit="1"/>
-              </p:cNvSpPr>
-              <p:nvPr/>
-            </p:nvSpPr>
-            <p:spPr>
-              <a:xfrm>
-                <a:off x="2865943" y="4641328"/>
-                <a:ext cx="1188720" cy="316831"/>
-              </a:xfrm>
-              <a:prstGeom prst="rect">
-                <a:avLst/>
-              </a:prstGeom>
-              <a:blipFill>
-                <a:blip r:embed="rId8"/>
-                <a:stretch>
-                  <a:fillRect b="-7407"/>
-                </a:stretch>
-              </a:blipFill>
-            </p:spPr>
-            <p:txBody>
-              <a:bodyPr/>
-              <a:lstStyle/>
-              <a:p>
-                <a:r>
-                  <a:rPr lang="en-US">
-                    <a:noFill/>
-                  </a:rPr>
-                  <a:t> </a:t>
-                </a:r>
-              </a:p>
-            </p:txBody>
-          </p:sp>
-        </mc:Fallback>
-      </mc:AlternateContent>
-      <mc:AlternateContent xmlns:mc="http://schemas.openxmlformats.org/markup-compatibility/2006" xmlns:a14="http://schemas.microsoft.com/office/drawing/2010/main">
-        <mc:Choice Requires="a14">
-          <p:sp>
-            <p:nvSpPr>
-              <p:cNvPr id="3" name="Rectangle 2">
-                <a:extLst>
-                  <a:ext uri="{FF2B5EF4-FFF2-40B4-BE49-F238E27FC236}">
-                    <a16:creationId xmlns:a16="http://schemas.microsoft.com/office/drawing/2014/main" id="{59CE38E8-506A-B978-C685-69CF8B3309E0}"/>
-                  </a:ext>
-                </a:extLst>
-              </p:cNvPr>
-              <p:cNvSpPr>
-                <a:spLocks/>
-              </p:cNvSpPr>
-              <p:nvPr/>
-            </p:nvSpPr>
-            <p:spPr>
-              <a:xfrm>
-                <a:off x="4107343" y="4641327"/>
-                <a:ext cx="1188720" cy="316831"/>
-              </a:xfrm>
-              <a:prstGeom prst="rect">
-                <a:avLst/>
-              </a:prstGeom>
-              <a:solidFill>
-                <a:schemeClr val="accent2">
-                  <a:lumMod val="60000"/>
-                  <a:lumOff val="40000"/>
-                </a:schemeClr>
-              </a:solidFill>
-              <a:ln>
-                <a:noFill/>
-              </a:ln>
-            </p:spPr>
-            <p:style>
-              <a:lnRef idx="2">
-                <a:schemeClr val="accent1">
-                  <a:shade val="15000"/>
-                </a:schemeClr>
-              </a:lnRef>
-              <a:fillRef idx="1">
-                <a:schemeClr val="accent1"/>
-              </a:fillRef>
-              <a:effectRef idx="0">
-                <a:schemeClr val="accent1"/>
-              </a:effectRef>
-              <a:fontRef idx="minor">
-                <a:schemeClr val="lt1"/>
-              </a:fontRef>
-            </p:style>
-            <p:txBody>
-              <a:bodyPr rtlCol="0" anchor="ctr"/>
-              <a:lstStyle/>
-              <a:p>
-                <a:pPr algn="ctr"/>
-                <a14:m>
-                  <m:oMathPara xmlns:m="http://schemas.openxmlformats.org/officeDocument/2006/math">
-                    <m:oMathParaPr>
-                      <m:jc m:val="centerGroup"/>
-                    </m:oMathParaPr>
-                    <m:oMath xmlns:m="http://schemas.openxmlformats.org/officeDocument/2006/math">
-                      <m:r>
-                        <a:rPr lang="en-US" i="1">
-                          <a:latin typeface="Cambria Math" panose="02040503050406030204" pitchFamily="18" charset="0"/>
-                          <a:ea typeface="Cambria Math" panose="02040503050406030204" pitchFamily="18" charset="0"/>
-                        </a:rPr>
-                        <m:t>ℳ</m:t>
-                      </m:r>
-                      <m:r>
-                        <a:rPr lang="en-US" i="1" baseline="-25000">
-                          <a:latin typeface="Cambria Math" panose="02040503050406030204" pitchFamily="18" charset="0"/>
-                          <a:ea typeface="Cambria Math" panose="02040503050406030204" pitchFamily="18" charset="0"/>
-                        </a:rPr>
-                        <m:t>2</m:t>
-                      </m:r>
-                      <m:r>
-                        <a:rPr lang="en-US">
-                          <a:latin typeface="Cambria Math" panose="02040503050406030204" pitchFamily="18" charset="0"/>
-                          <a:ea typeface="Cambria Math" panose="02040503050406030204" pitchFamily="18" charset="0"/>
-                        </a:rPr>
-                        <m:t>−</m:t>
-                      </m:r>
-                      <m:r>
-                        <m:rPr>
-                          <m:sty m:val="p"/>
-                        </m:rPr>
-                        <a:rPr lang="en-US">
-                          <a:latin typeface="Cambria Math" panose="02040503050406030204" pitchFamily="18" charset="0"/>
-                          <a:ea typeface="Cambria Math" panose="02040503050406030204" pitchFamily="18" charset="0"/>
-                        </a:rPr>
-                        <m:t>X</m:t>
-                      </m:r>
-                      <m:r>
-                        <a:rPr lang="en-US" baseline="-25000">
-                          <a:latin typeface="Cambria Math" panose="02040503050406030204" pitchFamily="18" charset="0"/>
-                          <a:ea typeface="Cambria Math" panose="02040503050406030204" pitchFamily="18" charset="0"/>
-                        </a:rPr>
-                        <m:t>1</m:t>
-                      </m:r>
-                    </m:oMath>
-                  </m:oMathPara>
-                </a14:m>
-                <a:endParaRPr lang="en-US" baseline="-25000" dirty="0"/>
-              </a:p>
-            </p:txBody>
-          </p:sp>
-        </mc:Choice>
-        <mc:Fallback xmlns="">
-          <p:sp>
-            <p:nvSpPr>
-              <p:cNvPr id="3" name="Rectangle 2">
-                <a:extLst>
-                  <a:ext uri="{FF2B5EF4-FFF2-40B4-BE49-F238E27FC236}">
-                    <a16:creationId xmlns:a16="http://schemas.microsoft.com/office/drawing/2014/main" id="{59CE38E8-506A-B978-C685-69CF8B3309E0}"/>
-                  </a:ext>
-                </a:extLst>
-              </p:cNvPr>
-              <p:cNvSpPr>
-                <a:spLocks noRot="1" noChangeAspect="1" noMove="1" noResize="1" noEditPoints="1" noAdjustHandles="1" noChangeArrowheads="1" noChangeShapeType="1" noTextEdit="1"/>
-              </p:cNvSpPr>
-              <p:nvPr/>
-            </p:nvSpPr>
-            <p:spPr>
-              <a:xfrm>
-                <a:off x="4107343" y="4641327"/>
-                <a:ext cx="1188720" cy="316831"/>
-              </a:xfrm>
-              <a:prstGeom prst="rect">
-                <a:avLst/>
-              </a:prstGeom>
-              <a:blipFill>
-                <a:blip r:embed="rId9"/>
-                <a:stretch>
-                  <a:fillRect b="-3846"/>
-                </a:stretch>
-              </a:blipFill>
-              <a:ln>
-                <a:noFill/>
-              </a:ln>
-            </p:spPr>
-            <p:txBody>
-              <a:bodyPr/>
-              <a:lstStyle/>
-              <a:p>
-                <a:r>
-                  <a:rPr lang="en-US">
-                    <a:noFill/>
-                  </a:rPr>
-                  <a:t> </a:t>
-                </a:r>
-              </a:p>
-            </p:txBody>
-          </p:sp>
-        </mc:Fallback>
-      </mc:AlternateContent>
-      <p:sp>
-        <p:nvSpPr>
-          <p:cNvPr id="5" name="Rectangle 4">
-            <a:extLst>
-              <a:ext uri="{FF2B5EF4-FFF2-40B4-BE49-F238E27FC236}">
-                <a16:creationId xmlns:a16="http://schemas.microsoft.com/office/drawing/2014/main" id="{2F4F45E9-54B4-9A83-E8FC-36B7EC911A06}"/>
-              </a:ext>
-            </a:extLst>
-          </p:cNvPr>
-          <p:cNvSpPr>
-            <a:spLocks/>
-          </p:cNvSpPr>
-          <p:nvPr/>
-        </p:nvSpPr>
-        <p:spPr>
-          <a:xfrm rot="5400000">
-            <a:off x="4161726" y="3400976"/>
-            <a:ext cx="2801905" cy="300105"/>
-          </a:xfrm>
-          <a:prstGeom prst="rect">
-            <a:avLst/>
-          </a:prstGeom>
-          <a:solidFill>
-            <a:schemeClr val="bg1">
-              <a:lumMod val="85000"/>
-            </a:schemeClr>
-          </a:solidFill>
-          <a:ln>
-            <a:noFill/>
-          </a:ln>
-        </p:spPr>
-        <p:style>
-          <a:lnRef idx="2">
-            <a:schemeClr val="accent1">
-              <a:shade val="15000"/>
-            </a:schemeClr>
-          </a:lnRef>
-          <a:fillRef idx="1">
-            <a:schemeClr val="accent1"/>
-          </a:fillRef>
-          <a:effectRef idx="0">
-            <a:schemeClr val="accent1"/>
-          </a:effectRef>
-          <a:fontRef idx="minor">
-            <a:schemeClr val="lt1"/>
-          </a:fontRef>
-        </p:style>
-        <p:txBody>
-          <a:bodyPr rtlCol="0" anchor="ctr"/>
-          <a:lstStyle/>
-          <a:p>
-            <a:pPr algn="ctr"/>
-            <a:r>
-              <a:rPr lang="en-US" b="1" dirty="0">
-                <a:solidFill>
-                  <a:schemeClr val="tx1"/>
-                </a:solidFill>
-              </a:rPr>
-              <a:t>0</a:t>
-            </a:r>
-          </a:p>
-        </p:txBody>
-      </p:sp>
-    </p:spTree>
-    <p:extLst>
-      <p:ext uri="{BB962C8B-B14F-4D97-AF65-F5344CB8AC3E}">
-        <p14:creationId xmlns:p14="http://schemas.microsoft.com/office/powerpoint/2010/main" val="118654851"/>
-      </p:ext>
-    </p:extLst>
-  </p:cSld>
-  <p:clrMapOvr>
-    <a:masterClrMapping/>
-  </p:clrMapOvr>
-</p:sld>
-</file>
-
 <file path=ppt/theme/theme1.xml><?xml version="1.0" encoding="utf-8"?>
 <a:theme xmlns:a="http://schemas.openxmlformats.org/drawingml/2006/main" name="Office Theme">
   <a:themeElements>

</xml_diff>